<commit_message>
meeting deck: add data tables (actual numbers) to result slides 7-11
D1 hit-rate table, D2 throughput/p95 table, F1 global table, F2 per-backend table
(tr/def x 4090/5090), F3 capacity-vs-split table. dtable() helper; tables placed
left of graphs, no overlap, no overflow. Notes preserved on all 14 slides.

Co-Authored-By: Claude Opus 4.8 (1M context) <noreply@anthropic.com>
</commit_message>
<xml_diff>
--- a/meeting_hetero_yunuikang.pptx
+++ b/meeting_hetero_yunuikang.pptx
@@ -4652,8 +4652,8 @@
         </p:nvSpPr>
         <p:spPr>
           <a:xfrm>
-            <a:off x="502920" y="1280160"/>
-            <a:ext cx="4572000" cy="4572000"/>
+            <a:off x="502920" y="1234440"/>
+            <a:ext cx="5120640" cy="1188720"/>
           </a:xfrm>
           <a:prstGeom prst="rect">
             <a:avLst/>
@@ -4672,42 +4672,12 @@
               </a:spcAft>
             </a:pPr>
             <a:r>
-              <a:rPr sz="1500" b="1">
-                <a:solidFill>
-                  <a:srgbClr val="1B2A4A"/>
-                </a:solidFill>
-              </a:rPr>
-              <a:t>default가 작은 4090을 혹사한다:</a:t>
-            </a:r>
-          </a:p>
-          <a:p>
-            <a:pPr lvl="1">
-              <a:spcAft>
-                <a:spcPts val="700"/>
-              </a:spcAft>
-            </a:pPr>
-            <a:r>
-              <a:rPr sz="1300" b="0">
+              <a:rPr sz="1400" b="1">
                 <a:solidFill>
                   <a:srgbClr val="B12A2A"/>
                 </a:solidFill>
               </a:rPr>
-              <a:t>c=8: 4090 hit 0.08 (스래싱) vs 5090 0.67</a:t>
-            </a:r>
-          </a:p>
-          <a:p>
-            <a:pPr lvl="1">
-              <a:spcAft>
-                <a:spcPts val="700"/>
-              </a:spcAft>
-            </a:pPr>
-            <a:r>
-              <a:rPr sz="1300" b="0">
-                <a:solidFill>
-                  <a:srgbClr val="B12A2A"/>
-                </a:solidFill>
-              </a:rPr>
-              <a:t>재프리필 4090 9.2M vs 5090 2.2M (~4×)</a:t>
+              <a:t>default가 작은 4090을 혹사 (c8 hit 0.08, 재프리필 ~4×)</a:t>
             </a:r>
           </a:p>
           <a:p>
@@ -4717,34 +4687,530 @@
               </a:spcAft>
             </a:pPr>
             <a:r>
-              <a:rPr sz="1500" b="1">
+              <a:rPr sz="1400" b="1">
+                <a:solidFill>
+                  <a:srgbClr val="1E7A3C"/>
+                </a:solidFill>
+              </a:rPr>
+              <a:t>tr은 4090·5090 둘 다 ~0.67 균형, 큰 5090에 더 라우팅(1:1.6)</a:t>
+            </a:r>
+          </a:p>
+        </p:txBody>
+      </p:sp>
+      <p:graphicFrame>
+        <p:nvGraphicFramePr>
+          <p:cNvPr id="5" name="Table 4"/>
+          <p:cNvGraphicFramePr>
+            <a:graphicFrameLocks noGrp="1"/>
+          </p:cNvGraphicFramePr>
+          <p:nvPr/>
+        </p:nvGraphicFramePr>
+        <p:xfrm>
+          <a:off x="457200" y="2606040"/>
+          <a:ext cx="5212080" cy="1170432"/>
+        </p:xfrm>
+        <a:graphic>
+          <a:graphicData uri="http://schemas.openxmlformats.org/drawingml/2006/table">
+            <a:tbl>
+              <a:tblPr>
+                <a:tableStyleId>{5C22544A-7EE6-4342-B048-85BDC9FD1C3A}</a:tableStyleId>
+              </a:tblPr>
+              <a:tblGrid>
+                <a:gridCol w="1554480"/>
+                <a:gridCol w="914400"/>
+                <a:gridCol w="914400"/>
+                <a:gridCol w="914400"/>
+                <a:gridCol w="914400"/>
+              </a:tblGrid>
+              <a:tr h="292608">
+                <a:tc>
+                  <a:txBody>
+                    <a:bodyPr/>
+                    <a:lstStyle/>
+                    <a:p>
+                      <a:pPr algn="ctr"/>
+                      <a:r>
+                        <a:rPr sz="1200" b="1">
+                          <a:solidFill>
+                            <a:srgbClr val="FFFFFF"/>
+                          </a:solidFill>
+                        </a:rPr>
+                        <a:t>지표</a:t>
+                      </a:r>
+                    </a:p>
+                  </a:txBody>
+                  <a:tcPr marT="12700" marB="12700">
+                    <a:solidFill>
+                      <a:srgbClr val="1B2A4A"/>
+                    </a:solidFill>
+                  </a:tcPr>
+                </a:tc>
+                <a:tc>
+                  <a:txBody>
+                    <a:bodyPr/>
+                    <a:lstStyle/>
+                    <a:p>
+                      <a:pPr algn="ctr"/>
+                      <a:r>
+                        <a:rPr sz="1200" b="1">
+                          <a:solidFill>
+                            <a:srgbClr val="FFFFFF"/>
+                          </a:solidFill>
+                        </a:rPr>
+                        <a:t>tr 4090</a:t>
+                      </a:r>
+                    </a:p>
+                  </a:txBody>
+                  <a:tcPr marT="12700" marB="12700">
+                    <a:solidFill>
+                      <a:srgbClr val="1B2A4A"/>
+                    </a:solidFill>
+                  </a:tcPr>
+                </a:tc>
+                <a:tc>
+                  <a:txBody>
+                    <a:bodyPr/>
+                    <a:lstStyle/>
+                    <a:p>
+                      <a:pPr algn="ctr"/>
+                      <a:r>
+                        <a:rPr sz="1200" b="1">
+                          <a:solidFill>
+                            <a:srgbClr val="FFFFFF"/>
+                          </a:solidFill>
+                        </a:rPr>
+                        <a:t>tr 5090</a:t>
+                      </a:r>
+                    </a:p>
+                  </a:txBody>
+                  <a:tcPr marT="12700" marB="12700">
+                    <a:solidFill>
+                      <a:srgbClr val="1B2A4A"/>
+                    </a:solidFill>
+                  </a:tcPr>
+                </a:tc>
+                <a:tc>
+                  <a:txBody>
+                    <a:bodyPr/>
+                    <a:lstStyle/>
+                    <a:p>
+                      <a:pPr algn="ctr"/>
+                      <a:r>
+                        <a:rPr sz="1200" b="1">
+                          <a:solidFill>
+                            <a:srgbClr val="FFFFFF"/>
+                          </a:solidFill>
+                        </a:rPr>
+                        <a:t>def 4090</a:t>
+                      </a:r>
+                    </a:p>
+                  </a:txBody>
+                  <a:tcPr marT="12700" marB="12700">
+                    <a:solidFill>
+                      <a:srgbClr val="1B2A4A"/>
+                    </a:solidFill>
+                  </a:tcPr>
+                </a:tc>
+                <a:tc>
+                  <a:txBody>
+                    <a:bodyPr/>
+                    <a:lstStyle/>
+                    <a:p>
+                      <a:pPr algn="ctr"/>
+                      <a:r>
+                        <a:rPr sz="1200" b="1">
+                          <a:solidFill>
+                            <a:srgbClr val="FFFFFF"/>
+                          </a:solidFill>
+                        </a:rPr>
+                        <a:t>def 5090</a:t>
+                      </a:r>
+                    </a:p>
+                  </a:txBody>
+                  <a:tcPr marT="12700" marB="12700">
+                    <a:solidFill>
+                      <a:srgbClr val="1B2A4A"/>
+                    </a:solidFill>
+                  </a:tcPr>
+                </a:tc>
+              </a:tr>
+              <a:tr h="292608">
+                <a:tc>
+                  <a:txBody>
+                    <a:bodyPr/>
+                    <a:lstStyle/>
+                    <a:p>
+                      <a:pPr algn="ctr"/>
+                      <a:r>
+                        <a:rPr sz="1200" b="0">
+                          <a:solidFill>
+                            <a:srgbClr val="1B2A4A"/>
+                          </a:solidFill>
+                        </a:rPr>
+                        <a:t>hit (c=8)</a:t>
+                      </a:r>
+                    </a:p>
+                  </a:txBody>
+                  <a:tcPr marT="12700" marB="12700">
+                    <a:solidFill>
+                      <a:srgbClr val="FFFFFF"/>
+                    </a:solidFill>
+                  </a:tcPr>
+                </a:tc>
+                <a:tc>
+                  <a:txBody>
+                    <a:bodyPr/>
+                    <a:lstStyle/>
+                    <a:p>
+                      <a:pPr algn="ctr"/>
+                      <a:r>
+                        <a:rPr sz="1200" b="0">
+                          <a:solidFill>
+                            <a:srgbClr val="1B2A4A"/>
+                          </a:solidFill>
+                        </a:rPr>
+                        <a:t>0.48</a:t>
+                      </a:r>
+                    </a:p>
+                  </a:txBody>
+                  <a:tcPr marT="12700" marB="12700">
+                    <a:solidFill>
+                      <a:srgbClr val="FFFFFF"/>
+                    </a:solidFill>
+                  </a:tcPr>
+                </a:tc>
+                <a:tc>
+                  <a:txBody>
+                    <a:bodyPr/>
+                    <a:lstStyle/>
+                    <a:p>
+                      <a:pPr algn="ctr"/>
+                      <a:r>
+                        <a:rPr sz="1200" b="0">
+                          <a:solidFill>
+                            <a:srgbClr val="1B2A4A"/>
+                          </a:solidFill>
+                        </a:rPr>
+                        <a:t>0.64</a:t>
+                      </a:r>
+                    </a:p>
+                  </a:txBody>
+                  <a:tcPr marT="12700" marB="12700">
+                    <a:solidFill>
+                      <a:srgbClr val="FFFFFF"/>
+                    </a:solidFill>
+                  </a:tcPr>
+                </a:tc>
+                <a:tc>
+                  <a:txBody>
+                    <a:bodyPr/>
+                    <a:lstStyle/>
+                    <a:p>
+                      <a:pPr algn="ctr"/>
+                      <a:r>
+                        <a:rPr sz="1200" b="1">
+                          <a:solidFill>
+                            <a:srgbClr val="B12A2A"/>
+                          </a:solidFill>
+                        </a:rPr>
+                        <a:t>0.08</a:t>
+                      </a:r>
+                    </a:p>
+                  </a:txBody>
+                  <a:tcPr marT="12700" marB="12700">
+                    <a:solidFill>
+                      <a:srgbClr val="FFFFFF"/>
+                    </a:solidFill>
+                  </a:tcPr>
+                </a:tc>
+                <a:tc>
+                  <a:txBody>
+                    <a:bodyPr/>
+                    <a:lstStyle/>
+                    <a:p>
+                      <a:pPr algn="ctr"/>
+                      <a:r>
+                        <a:rPr sz="1200" b="0">
+                          <a:solidFill>
+                            <a:srgbClr val="1B2A4A"/>
+                          </a:solidFill>
+                        </a:rPr>
+                        <a:t>0.67</a:t>
+                      </a:r>
+                    </a:p>
+                  </a:txBody>
+                  <a:tcPr marT="12700" marB="12700">
+                    <a:solidFill>
+                      <a:srgbClr val="FFFFFF"/>
+                    </a:solidFill>
+                  </a:tcPr>
+                </a:tc>
+              </a:tr>
+              <a:tr h="292608">
+                <a:tc>
+                  <a:txBody>
+                    <a:bodyPr/>
+                    <a:lstStyle/>
+                    <a:p>
+                      <a:pPr algn="ctr"/>
+                      <a:r>
+                        <a:rPr sz="1200" b="0">
+                          <a:solidFill>
+                            <a:srgbClr val="1B2A4A"/>
+                          </a:solidFill>
+                        </a:rPr>
+                        <a:t>hit (c≥16)</a:t>
+                      </a:r>
+                    </a:p>
+                  </a:txBody>
+                  <a:tcPr marT="12700" marB="12700">
+                    <a:solidFill>
+                      <a:srgbClr val="FFFFFF"/>
+                    </a:solidFill>
+                  </a:tcPr>
+                </a:tc>
+                <a:tc>
+                  <a:txBody>
+                    <a:bodyPr/>
+                    <a:lstStyle/>
+                    <a:p>
+                      <a:pPr algn="ctr"/>
+                      <a:r>
+                        <a:rPr sz="1200" b="0">
+                          <a:solidFill>
+                            <a:srgbClr val="1B2A4A"/>
+                          </a:solidFill>
+                        </a:rPr>
+                        <a:t>0.67</a:t>
+                      </a:r>
+                    </a:p>
+                  </a:txBody>
+                  <a:tcPr marT="12700" marB="12700">
+                    <a:solidFill>
+                      <a:srgbClr val="FFFFFF"/>
+                    </a:solidFill>
+                  </a:tcPr>
+                </a:tc>
+                <a:tc>
+                  <a:txBody>
+                    <a:bodyPr/>
+                    <a:lstStyle/>
+                    <a:p>
+                      <a:pPr algn="ctr"/>
+                      <a:r>
+                        <a:rPr sz="1200" b="0">
+                          <a:solidFill>
+                            <a:srgbClr val="1B2A4A"/>
+                          </a:solidFill>
+                        </a:rPr>
+                        <a:t>0.67</a:t>
+                      </a:r>
+                    </a:p>
+                  </a:txBody>
+                  <a:tcPr marT="12700" marB="12700">
+                    <a:solidFill>
+                      <a:srgbClr val="FFFFFF"/>
+                    </a:solidFill>
+                  </a:tcPr>
+                </a:tc>
+                <a:tc>
+                  <a:txBody>
+                    <a:bodyPr/>
+                    <a:lstStyle/>
+                    <a:p>
+                      <a:pPr algn="ctr"/>
+                      <a:r>
+                        <a:rPr sz="1200" b="1">
+                          <a:solidFill>
+                            <a:srgbClr val="B12A2A"/>
+                          </a:solidFill>
+                        </a:rPr>
+                        <a:t>0.02</a:t>
+                      </a:r>
+                    </a:p>
+                  </a:txBody>
+                  <a:tcPr marT="12700" marB="12700">
+                    <a:solidFill>
+                      <a:srgbClr val="FFFFFF"/>
+                    </a:solidFill>
+                  </a:tcPr>
+                </a:tc>
+                <a:tc>
+                  <a:txBody>
+                    <a:bodyPr/>
+                    <a:lstStyle/>
+                    <a:p>
+                      <a:pPr algn="ctr"/>
+                      <a:r>
+                        <a:rPr sz="1200" b="0">
+                          <a:solidFill>
+                            <a:srgbClr val="1B2A4A"/>
+                          </a:solidFill>
+                        </a:rPr>
+                        <a:t>0.02</a:t>
+                      </a:r>
+                    </a:p>
+                  </a:txBody>
+                  <a:tcPr marT="12700" marB="12700">
+                    <a:solidFill>
+                      <a:srgbClr val="FFFFFF"/>
+                    </a:solidFill>
+                  </a:tcPr>
+                </a:tc>
+              </a:tr>
+              <a:tr h="292608">
+                <a:tc>
+                  <a:txBody>
+                    <a:bodyPr/>
+                    <a:lstStyle/>
+                    <a:p>
+                      <a:pPr algn="ctr"/>
+                      <a:r>
+                        <a:rPr sz="1200" b="0">
+                          <a:solidFill>
+                            <a:srgbClr val="1B2A4A"/>
+                          </a:solidFill>
+                        </a:rPr>
+                        <a:t>재프리필 M (c≥16)</a:t>
+                      </a:r>
+                    </a:p>
+                  </a:txBody>
+                  <a:tcPr marT="12700" marB="12700">
+                    <a:solidFill>
+                      <a:srgbClr val="FFFFFF"/>
+                    </a:solidFill>
+                  </a:tcPr>
+                </a:tc>
+                <a:tc>
+                  <a:txBody>
+                    <a:bodyPr/>
+                    <a:lstStyle/>
+                    <a:p>
+                      <a:pPr algn="ctr"/>
+                      <a:r>
+                        <a:rPr sz="1200" b="0">
+                          <a:solidFill>
+                            <a:srgbClr val="1B2A4A"/>
+                          </a:solidFill>
+                        </a:rPr>
+                        <a:t>0.80</a:t>
+                      </a:r>
+                    </a:p>
+                  </a:txBody>
+                  <a:tcPr marT="12700" marB="12700">
+                    <a:solidFill>
+                      <a:srgbClr val="FFFFFF"/>
+                    </a:solidFill>
+                  </a:tcPr>
+                </a:tc>
+                <a:tc>
+                  <a:txBody>
+                    <a:bodyPr/>
+                    <a:lstStyle/>
+                    <a:p>
+                      <a:pPr algn="ctr"/>
+                      <a:r>
+                        <a:rPr sz="1200" b="0">
+                          <a:solidFill>
+                            <a:srgbClr val="1B2A4A"/>
+                          </a:solidFill>
+                        </a:rPr>
+                        <a:t>1.29</a:t>
+                      </a:r>
+                    </a:p>
+                  </a:txBody>
+                  <a:tcPr marT="12700" marB="12700">
+                    <a:solidFill>
+                      <a:srgbClr val="FFFFFF"/>
+                    </a:solidFill>
+                  </a:tcPr>
+                </a:tc>
+                <a:tc>
+                  <a:txBody>
+                    <a:bodyPr/>
+                    <a:lstStyle/>
+                    <a:p>
+                      <a:pPr algn="ctr"/>
+                      <a:r>
+                        <a:rPr sz="1200" b="1">
+                          <a:solidFill>
+                            <a:srgbClr val="B12A2A"/>
+                          </a:solidFill>
+                        </a:rPr>
+                        <a:t>9.2</a:t>
+                      </a:r>
+                    </a:p>
+                  </a:txBody>
+                  <a:tcPr marT="12700" marB="12700">
+                    <a:solidFill>
+                      <a:srgbClr val="FFFFFF"/>
+                    </a:solidFill>
+                  </a:tcPr>
+                </a:tc>
+                <a:tc>
+                  <a:txBody>
+                    <a:bodyPr/>
+                    <a:lstStyle/>
+                    <a:p>
+                      <a:pPr algn="ctr"/>
+                      <a:r>
+                        <a:rPr sz="1200" b="0">
+                          <a:solidFill>
+                            <a:srgbClr val="1B2A4A"/>
+                          </a:solidFill>
+                        </a:rPr>
+                        <a:t>2.2</a:t>
+                      </a:r>
+                    </a:p>
+                  </a:txBody>
+                  <a:tcPr marT="12700" marB="12700">
+                    <a:solidFill>
+                      <a:srgbClr val="FFFFFF"/>
+                    </a:solidFill>
+                  </a:tcPr>
+                </a:tc>
+              </a:tr>
+            </a:tbl>
+          </a:graphicData>
+        </a:graphic>
+      </p:graphicFrame>
+      <p:sp>
+        <p:nvSpPr>
+          <p:cNvPr id="6" name="TextBox 5"/>
+          <p:cNvSpPr txBox="1"/>
+          <p:nvPr/>
+        </p:nvSpPr>
+        <p:spPr>
+          <a:xfrm>
+            <a:off x="457200" y="4160520"/>
+            <a:ext cx="5212080" cy="320040"/>
+          </a:xfrm>
+          <a:prstGeom prst="rect">
+            <a:avLst/>
+          </a:prstGeom>
+          <a:noFill/>
+        </p:spPr>
+        <p:txBody>
+          <a:bodyPr wrap="none">
+            <a:spAutoFit/>
+          </a:bodyPr>
+          <a:lstStyle/>
+          <a:p>
+            <a:pPr algn="ctr"/>
+            <a:r>
+              <a:rPr sz="1100" b="1">
                 <a:solidFill>
                   <a:srgbClr val="1B2A4A"/>
                 </a:solidFill>
               </a:rPr>
-              <a:t>tr은 두 GPU를 균형 유지:</a:t>
-            </a:r>
-          </a:p>
-          <a:p>
-            <a:pPr lvl="1">
-              <a:spcAft>
-                <a:spcPts val="700"/>
-              </a:spcAft>
-            </a:pPr>
-            <a:r>
-              <a:rPr sz="1300" b="0">
-                <a:solidFill>
-                  <a:srgbClr val="1E7A3C"/>
-                </a:solidFill>
-              </a:rPr>
-              <a:t>4090·5090 hit 둘 다 ~0.67, 큰 5090에 더 라우팅 (q 1:1.6)</a:t>
+              <a:t>백엔드별 수치 (빨강=default 4090, 혹사)</a:t>
             </a:r>
           </a:p>
         </p:txBody>
       </p:sp>
       <p:pic>
         <p:nvPicPr>
-          <p:cNvPr id="5" name="Picture 4" descr="homo_hetero_perbackend_hitrate.png"/>
+          <p:cNvPr id="7" name="Picture 6" descr="homo_hetero_perbackend_hitrate.png"/>
           <p:cNvPicPr>
             <a:picLocks noChangeAspect="1"/>
           </p:cNvPicPr>
@@ -4758,8 +5224,8 @@
         </p:blipFill>
         <p:spPr>
           <a:xfrm>
-            <a:off x="5166360" y="1417320"/>
-            <a:ext cx="6766560" cy="4511040"/>
+            <a:off x="5806440" y="1920240"/>
+            <a:ext cx="6126480" cy="4084320"/>
           </a:xfrm>
           <a:prstGeom prst="rect">
             <a:avLst/>
@@ -4768,14 +5234,14 @@
       </p:pic>
       <p:sp>
         <p:nvSpPr>
-          <p:cNvPr id="6" name="TextBox 5"/>
+          <p:cNvPr id="8" name="TextBox 7"/>
           <p:cNvSpPr txBox="1"/>
           <p:nvPr/>
         </p:nvSpPr>
         <p:spPr>
           <a:xfrm>
-            <a:off x="5166360" y="5989320"/>
-            <a:ext cx="6766560" cy="320040"/>
+            <a:off x="5806440" y="5943600"/>
+            <a:ext cx="6126480" cy="320040"/>
           </a:xfrm>
           <a:prstGeom prst="rect">
             <a:avLst/>
@@ -4795,7 +5261,7 @@
                   <a:srgbClr val="1B2A4A"/>
                 </a:solidFill>
               </a:rPr>
-              <a:t>백엔드별 hit rate: default 4090 붕괴 vs tr 균형</a:t>
+              <a:t>백엔드별 hit rate: default 4090만 붕괴</a:t>
             </a:r>
           </a:p>
         </p:txBody>
@@ -4902,8 +5368,8 @@
         </p:nvSpPr>
         <p:spPr>
           <a:xfrm>
-            <a:off x="502920" y="1280160"/>
-            <a:ext cx="5486400" cy="4754880"/>
+            <a:off x="502920" y="1234440"/>
+            <a:ext cx="5577840" cy="1554480"/>
           </a:xfrm>
           <a:prstGeom prst="rect">
             <a:avLst/>
@@ -4922,12 +5388,12 @@
               </a:spcAft>
             </a:pPr>
             <a:r>
-              <a:rPr sz="1500" b="1">
+              <a:rPr sz="1400" b="1">
                 <a:solidFill>
                   <a:srgbClr val="1B2A4A"/>
                 </a:solidFill>
               </a:rPr>
-              <a:t>사전 가설 H1: 'tr의 절대-토큰 균형 배분이 작은 4090을 먼저 포화시킨다'</a:t>
+              <a:t>사전 가설 H1: 'tr의 절대-토큰 균형이 작은 4090을 먼저 포화'</a:t>
             </a:r>
           </a:p>
           <a:p>
@@ -4937,12 +5403,12 @@
               </a:spcAft>
             </a:pPr>
             <a:r>
-              <a:rPr sz="1500" b="1">
+              <a:rPr sz="1400" b="1">
                 <a:solidFill>
                   <a:srgbClr val="B12A2A"/>
                 </a:solidFill>
               </a:rPr>
-              <a:t>실측: tr의 4090·5090 hit rate가 유사(≈0.67) → 사전 등록한 반증 조건 충족</a:t>
+              <a:t>실측: tr 4090·5090 hit 유사(≈0.67) → 사전 등록 반증 조건 충족 → H1 기각</a:t>
             </a:r>
           </a:p>
           <a:p>
@@ -4952,49 +5418,351 @@
               </a:spcAft>
             </a:pPr>
             <a:r>
-              <a:rPr sz="1300" b="0">
+              <a:rPr sz="1200" b="0">
                 <a:solidFill>
                   <a:srgbClr val="1B2A4A"/>
                 </a:solidFill>
               </a:rPr>
-              <a:t>즉 tr은 소형 GPU를 혹사하지 않는다. 소형-GPU 혹사 병리는 default의 문제.</a:t>
-            </a:r>
-          </a:p>
-          <a:p>
-            <a:pPr>
-              <a:spcAft>
-                <a:spcPts val="700"/>
-              </a:spcAft>
-            </a:pPr>
-            <a:r>
-              <a:rPr sz="1500" b="1">
+              <a:t>소형-GPU 혹사는 default 병리. 단 tr은 큰 5090을 다 못 씀 ↓</a:t>
+            </a:r>
+          </a:p>
+        </p:txBody>
+      </p:sp>
+      <p:graphicFrame>
+        <p:nvGraphicFramePr>
+          <p:cNvPr id="5" name="Table 4"/>
+          <p:cNvGraphicFramePr>
+            <a:graphicFrameLocks noGrp="1"/>
+          </p:cNvGraphicFramePr>
+          <p:nvPr/>
+        </p:nvGraphicFramePr>
+        <p:xfrm>
+          <a:off x="548640" y="3017520"/>
+          <a:ext cx="5486400" cy="877824"/>
+        </p:xfrm>
+        <a:graphic>
+          <a:graphicData uri="http://schemas.openxmlformats.org/drawingml/2006/table">
+            <a:tbl>
+              <a:tblPr>
+                <a:tableStyleId>{5C22544A-7EE6-4342-B048-85BDC9FD1C3A}</a:tableStyleId>
+              </a:tblPr>
+              <a:tblGrid>
+                <a:gridCol w="1737360"/>
+                <a:gridCol w="1097280"/>
+                <a:gridCol w="1097280"/>
+                <a:gridCol w="1554480"/>
+              </a:tblGrid>
+              <a:tr h="292608">
+                <a:tc>
+                  <a:txBody>
+                    <a:bodyPr/>
+                    <a:lstStyle/>
+                    <a:p>
+                      <a:pPr algn="ctr"/>
+                      <a:r>
+                        <a:rPr sz="1300" b="1">
+                          <a:solidFill>
+                            <a:srgbClr val="FFFFFF"/>
+                          </a:solidFill>
+                        </a:rPr>
+                        <a:t/>
+                      </a:r>
+                    </a:p>
+                  </a:txBody>
+                  <a:tcPr marT="12700" marB="12700">
+                    <a:solidFill>
+                      <a:srgbClr val="1B2A4A"/>
+                    </a:solidFill>
+                  </a:tcPr>
+                </a:tc>
+                <a:tc>
+                  <a:txBody>
+                    <a:bodyPr/>
+                    <a:lstStyle/>
+                    <a:p>
+                      <a:pPr algn="ctr"/>
+                      <a:r>
+                        <a:rPr sz="1300" b="1">
+                          <a:solidFill>
+                            <a:srgbClr val="FFFFFF"/>
+                          </a:solidFill>
+                        </a:rPr>
+                        <a:t>4090</a:t>
+                      </a:r>
+                    </a:p>
+                  </a:txBody>
+                  <a:tcPr marT="12700" marB="12700">
+                    <a:solidFill>
+                      <a:srgbClr val="1B2A4A"/>
+                    </a:solidFill>
+                  </a:tcPr>
+                </a:tc>
+                <a:tc>
+                  <a:txBody>
+                    <a:bodyPr/>
+                    <a:lstStyle/>
+                    <a:p>
+                      <a:pPr algn="ctr"/>
+                      <a:r>
+                        <a:rPr sz="1300" b="1">
+                          <a:solidFill>
+                            <a:srgbClr val="FFFFFF"/>
+                          </a:solidFill>
+                        </a:rPr>
+                        <a:t>5090</a:t>
+                      </a:r>
+                    </a:p>
+                  </a:txBody>
+                  <a:tcPr marT="12700" marB="12700">
+                    <a:solidFill>
+                      <a:srgbClr val="1B2A4A"/>
+                    </a:solidFill>
+                  </a:tcPr>
+                </a:tc>
+                <a:tc>
+                  <a:txBody>
+                    <a:bodyPr/>
+                    <a:lstStyle/>
+                    <a:p>
+                      <a:pPr algn="ctr"/>
+                      <a:r>
+                        <a:rPr sz="1300" b="1">
+                          <a:solidFill>
+                            <a:srgbClr val="FFFFFF"/>
+                          </a:solidFill>
+                        </a:rPr>
+                        <a:t>비율</a:t>
+                      </a:r>
+                    </a:p>
+                  </a:txBody>
+                  <a:tcPr marT="12700" marB="12700">
+                    <a:solidFill>
+                      <a:srgbClr val="1B2A4A"/>
+                    </a:solidFill>
+                  </a:tcPr>
+                </a:tc>
+              </a:tr>
+              <a:tr h="292608">
+                <a:tc>
+                  <a:txBody>
+                    <a:bodyPr/>
+                    <a:lstStyle/>
+                    <a:p>
+                      <a:pPr algn="ctr"/>
+                      <a:r>
+                        <a:rPr sz="1300" b="0">
+                          <a:solidFill>
+                            <a:srgbClr val="1B2A4A"/>
+                          </a:solidFill>
+                        </a:rPr>
+                        <a:t>KV 풀 (GiB)</a:t>
+                      </a:r>
+                    </a:p>
+                  </a:txBody>
+                  <a:tcPr marT="12700" marB="12700">
+                    <a:solidFill>
+                      <a:srgbClr val="FFFFFF"/>
+                    </a:solidFill>
+                  </a:tcPr>
+                </a:tc>
+                <a:tc>
+                  <a:txBody>
+                    <a:bodyPr/>
+                    <a:lstStyle/>
+                    <a:p>
+                      <a:pPr algn="ctr"/>
+                      <a:r>
+                        <a:rPr sz="1300" b="0">
+                          <a:solidFill>
+                            <a:srgbClr val="1B2A4A"/>
+                          </a:solidFill>
+                        </a:rPr>
+                        <a:t>6.03</a:t>
+                      </a:r>
+                    </a:p>
+                  </a:txBody>
+                  <a:tcPr marT="12700" marB="12700">
+                    <a:solidFill>
+                      <a:srgbClr val="FFFFFF"/>
+                    </a:solidFill>
+                  </a:tcPr>
+                </a:tc>
+                <a:tc>
+                  <a:txBody>
+                    <a:bodyPr/>
+                    <a:lstStyle/>
+                    <a:p>
+                      <a:pPr algn="ctr"/>
+                      <a:r>
+                        <a:rPr sz="1300" b="0">
+                          <a:solidFill>
+                            <a:srgbClr val="1B2A4A"/>
+                          </a:solidFill>
+                        </a:rPr>
+                        <a:t>12.23</a:t>
+                      </a:r>
+                    </a:p>
+                  </a:txBody>
+                  <a:tcPr marT="12700" marB="12700">
+                    <a:solidFill>
+                      <a:srgbClr val="FFFFFF"/>
+                    </a:solidFill>
+                  </a:tcPr>
+                </a:tc>
+                <a:tc>
+                  <a:txBody>
+                    <a:bodyPr/>
+                    <a:lstStyle/>
+                    <a:p>
+                      <a:pPr algn="ctr"/>
+                      <a:r>
+                        <a:rPr sz="1300" b="0">
+                          <a:solidFill>
+                            <a:srgbClr val="1B2A4A"/>
+                          </a:solidFill>
+                        </a:rPr>
+                        <a:t>1 : 2.03</a:t>
+                      </a:r>
+                    </a:p>
+                  </a:txBody>
+                  <a:tcPr marT="12700" marB="12700">
+                    <a:solidFill>
+                      <a:srgbClr val="FFFFFF"/>
+                    </a:solidFill>
+                  </a:tcPr>
+                </a:tc>
+              </a:tr>
+              <a:tr h="292608">
+                <a:tc>
+                  <a:txBody>
+                    <a:bodyPr/>
+                    <a:lstStyle/>
+                    <a:p>
+                      <a:pPr algn="ctr"/>
+                      <a:r>
+                        <a:rPr sz="1300" b="0">
+                          <a:solidFill>
+                            <a:srgbClr val="1B2A4A"/>
+                          </a:solidFill>
+                        </a:rPr>
+                        <a:t>tr split (q, M)</a:t>
+                      </a:r>
+                    </a:p>
+                  </a:txBody>
+                  <a:tcPr marT="12700" marB="12700">
+                    <a:solidFill>
+                      <a:srgbClr val="FFFFFF"/>
+                    </a:solidFill>
+                  </a:tcPr>
+                </a:tc>
+                <a:tc>
+                  <a:txBody>
+                    <a:bodyPr/>
+                    <a:lstStyle/>
+                    <a:p>
+                      <a:pPr algn="ctr"/>
+                      <a:r>
+                        <a:rPr sz="1300" b="0">
+                          <a:solidFill>
+                            <a:srgbClr val="1B2A4A"/>
+                          </a:solidFill>
+                        </a:rPr>
+                        <a:t>0.80</a:t>
+                      </a:r>
+                    </a:p>
+                  </a:txBody>
+                  <a:tcPr marT="12700" marB="12700">
+                    <a:solidFill>
+                      <a:srgbClr val="FFFFFF"/>
+                    </a:solidFill>
+                  </a:tcPr>
+                </a:tc>
+                <a:tc>
+                  <a:txBody>
+                    <a:bodyPr/>
+                    <a:lstStyle/>
+                    <a:p>
+                      <a:pPr algn="ctr"/>
+                      <a:r>
+                        <a:rPr sz="1300" b="0">
+                          <a:solidFill>
+                            <a:srgbClr val="1B2A4A"/>
+                          </a:solidFill>
+                        </a:rPr>
+                        <a:t>1.29</a:t>
+                      </a:r>
+                    </a:p>
+                  </a:txBody>
+                  <a:tcPr marT="12700" marB="12700">
+                    <a:solidFill>
+                      <a:srgbClr val="FFFFFF"/>
+                    </a:solidFill>
+                  </a:tcPr>
+                </a:tc>
+                <a:tc>
+                  <a:txBody>
+                    <a:bodyPr/>
+                    <a:lstStyle/>
+                    <a:p>
+                      <a:pPr algn="ctr"/>
+                      <a:r>
+                        <a:rPr sz="1300" b="1">
+                          <a:solidFill>
+                            <a:srgbClr val="B12A2A"/>
+                          </a:solidFill>
+                        </a:rPr>
+                        <a:t>1 : 1.6</a:t>
+                      </a:r>
+                    </a:p>
+                  </a:txBody>
+                  <a:tcPr marT="12700" marB="12700">
+                    <a:solidFill>
+                      <a:srgbClr val="FFFFFF"/>
+                    </a:solidFill>
+                  </a:tcPr>
+                </a:tc>
+              </a:tr>
+            </a:tbl>
+          </a:graphicData>
+        </a:graphic>
+      </p:graphicFrame>
+      <p:sp>
+        <p:nvSpPr>
+          <p:cNvPr id="6" name="TextBox 5"/>
+          <p:cNvSpPr txBox="1"/>
+          <p:nvPr/>
+        </p:nvSpPr>
+        <p:spPr>
+          <a:xfrm>
+            <a:off x="548640" y="3977639"/>
+            <a:ext cx="4160520" cy="320040"/>
+          </a:xfrm>
+          <a:prstGeom prst="rect">
+            <a:avLst/>
+          </a:prstGeom>
+          <a:noFill/>
+        </p:spPr>
+        <p:txBody>
+          <a:bodyPr wrap="none">
+            <a:spAutoFit/>
+          </a:bodyPr>
+          <a:lstStyle/>
+          <a:p>
+            <a:pPr algn="ctr"/>
+            <a:r>
+              <a:rPr sz="1100" b="1">
                 <a:solidFill>
                   <a:srgbClr val="1B2A4A"/>
                 </a:solidFill>
               </a:rPr>
-              <a:t>재해석: tr split ≈ 1:1.6 &lt; 실제 용량비 1:2.03 → 큰 5090을 완전히 활용 못 함</a:t>
-            </a:r>
-          </a:p>
-          <a:p>
-            <a:pPr lvl="1">
-              <a:spcAft>
-                <a:spcPts val="700"/>
-              </a:spcAft>
-            </a:pPr>
-            <a:r>
-              <a:rPr sz="1300" b="0">
-                <a:solidFill>
-                  <a:srgbClr val="4A4A4A"/>
-                </a:solidFill>
-              </a:rPr>
-              <a:t>throughput가 5090 추가 용량(+51%)만큼 안 오르고 +31%에 그침 (vs 2×4090 §9 tr).</a:t>
+              <a:t>tr split(1:1.6) &lt; 용량비(1:2.03) → 5090 과소활용</a:t>
             </a:r>
           </a:p>
         </p:txBody>
       </p:sp>
       <p:pic>
         <p:nvPicPr>
-          <p:cNvPr id="5" name="Picture 4" descr="homo_hetero_perbackend_reprefill.png"/>
+          <p:cNvPr id="7" name="Picture 6" descr="homo_hetero_perbackend_reprefill.png"/>
           <p:cNvPicPr>
             <a:picLocks noChangeAspect="1"/>
           </p:cNvPicPr>
@@ -5008,8 +5776,8 @@
         </p:blipFill>
         <p:spPr>
           <a:xfrm>
-            <a:off x="6355080" y="1737360"/>
-            <a:ext cx="5669280" cy="3779520"/>
+            <a:off x="6446520" y="1691640"/>
+            <a:ext cx="5486400" cy="3657600"/>
           </a:xfrm>
           <a:prstGeom prst="rect">
             <a:avLst/>
@@ -5018,14 +5786,14 @@
       </p:pic>
       <p:sp>
         <p:nvSpPr>
-          <p:cNvPr id="6" name="TextBox 5"/>
+          <p:cNvPr id="8" name="TextBox 7"/>
           <p:cNvSpPr txBox="1"/>
           <p:nvPr/>
         </p:nvSpPr>
         <p:spPr>
           <a:xfrm>
-            <a:off x="6355080" y="5806440"/>
-            <a:ext cx="5669280" cy="320040"/>
+            <a:off x="6446520" y="5669280"/>
+            <a:ext cx="5486400" cy="320040"/>
           </a:xfrm>
           <a:prstGeom prst="rect">
             <a:avLst/>
@@ -5045,7 +5813,7 @@
                   <a:srgbClr val="1B2A4A"/>
                 </a:solidFill>
               </a:rPr>
-              <a:t>백엔드별 재프리필: default 4090이 5090의 ~4배</a:t>
+              <a:t>백엔드별 재프리필: default 4090이 ~4배</a:t>
             </a:r>
           </a:p>
         </p:txBody>
@@ -7343,8 +8111,8 @@
         </p:nvSpPr>
         <p:spPr>
           <a:xfrm>
-            <a:off x="548640" y="1280160"/>
-            <a:ext cx="4754880" cy="4572000"/>
+            <a:off x="502920" y="1234440"/>
+            <a:ext cx="4937760" cy="1463040"/>
           </a:xfrm>
           <a:prstGeom prst="rect">
             <a:avLst/>
@@ -7363,7 +8131,7 @@
               </a:spcAft>
             </a:pPr>
             <a:r>
-              <a:rPr sz="1600" b="1">
+              <a:rPr sz="1500" b="1">
                 <a:solidFill>
                   <a:srgbClr val="1B2A4A"/>
                 </a:solidFill>
@@ -7378,12 +8146,12 @@
               </a:spcAft>
             </a:pPr>
             <a:r>
-              <a:rPr sz="1400" b="0">
+              <a:rPr sz="1300" b="0">
                 <a:solidFill>
-                  <a:srgbClr val="4A4A4A"/>
+                  <a:srgbClr val="1B2A4A"/>
                 </a:solidFill>
               </a:rPr>
-              <a:t>tr: hit rate 0.77~0.80 부하 무관 유지</a:t>
+              <a:t>tr: 0.77~0.80 부하 무관 유지  |  default: 0.82 → 0.026 붕괴</a:t>
             </a:r>
           </a:p>
           <a:p>
@@ -7393,49 +8161,488 @@
               </a:spcAft>
             </a:pPr>
             <a:r>
-              <a:rPr sz="1400" b="0">
-                <a:solidFill>
-                  <a:srgbClr val="B12A2A"/>
-                </a:solidFill>
-              </a:rPr>
-              <a:t>default: 0.82 → 0.026 붕괴</a:t>
-            </a:r>
-          </a:p>
-          <a:p>
-            <a:pPr lvl="1">
-              <a:spcAft>
-                <a:spcPts val="700"/>
-              </a:spcAft>
-            </a:pPr>
-            <a:r>
-              <a:rPr sz="1400" b="0">
+              <a:rPr sz="1300" b="0">
                 <a:solidFill>
                   <a:srgbClr val="1E7A3C"/>
                 </a:solidFill>
               </a:rPr>
-              <a:t>c=48에서 30× 차이</a:t>
-            </a:r>
-          </a:p>
-          <a:p>
-            <a:pPr>
-              <a:spcAft>
-                <a:spcPts val="700"/>
-              </a:spcAft>
-            </a:pPr>
-            <a:r>
-              <a:rPr sz="1600" b="1">
+              <a:t>c=48에서 30× 차이 → 스래싱 억제 실데이터 재현</a:t>
+            </a:r>
+          </a:p>
+        </p:txBody>
+      </p:sp>
+      <p:graphicFrame>
+        <p:nvGraphicFramePr>
+          <p:cNvPr id="5" name="Table 4"/>
+          <p:cNvGraphicFramePr>
+            <a:graphicFrameLocks noGrp="1"/>
+          </p:cNvGraphicFramePr>
+          <p:nvPr/>
+        </p:nvGraphicFramePr>
+        <p:xfrm>
+          <a:off x="640080" y="2834640"/>
+          <a:ext cx="4206240" cy="1755648"/>
+        </p:xfrm>
+        <a:graphic>
+          <a:graphicData uri="http://schemas.openxmlformats.org/drawingml/2006/table">
+            <a:tbl>
+              <a:tblPr>
+                <a:tableStyleId>{5C22544A-7EE6-4342-B048-85BDC9FD1C3A}</a:tableStyleId>
+              </a:tblPr>
+              <a:tblGrid>
+                <a:gridCol w="1097280"/>
+                <a:gridCol w="1554480"/>
+                <a:gridCol w="1554480"/>
+              </a:tblGrid>
+              <a:tr h="292608">
+                <a:tc>
+                  <a:txBody>
+                    <a:bodyPr/>
+                    <a:lstStyle/>
+                    <a:p>
+                      <a:pPr algn="ctr"/>
+                      <a:r>
+                        <a:rPr sz="1300" b="1">
+                          <a:solidFill>
+                            <a:srgbClr val="FFFFFF"/>
+                          </a:solidFill>
+                        </a:rPr>
+                        <a:t>C</a:t>
+                      </a:r>
+                    </a:p>
+                  </a:txBody>
+                  <a:tcPr marT="12700" marB="12700">
+                    <a:solidFill>
+                      <a:srgbClr val="1B2A4A"/>
+                    </a:solidFill>
+                  </a:tcPr>
+                </a:tc>
+                <a:tc>
+                  <a:txBody>
+                    <a:bodyPr/>
+                    <a:lstStyle/>
+                    <a:p>
+                      <a:pPr algn="ctr"/>
+                      <a:r>
+                        <a:rPr sz="1300" b="1">
+                          <a:solidFill>
+                            <a:srgbClr val="FFFFFF"/>
+                          </a:solidFill>
+                        </a:rPr>
+                        <a:t>tr hit</a:t>
+                      </a:r>
+                    </a:p>
+                  </a:txBody>
+                  <a:tcPr marT="12700" marB="12700">
+                    <a:solidFill>
+                      <a:srgbClr val="1B2A4A"/>
+                    </a:solidFill>
+                  </a:tcPr>
+                </a:tc>
+                <a:tc>
+                  <a:txBody>
+                    <a:bodyPr/>
+                    <a:lstStyle/>
+                    <a:p>
+                      <a:pPr algn="ctr"/>
+                      <a:r>
+                        <a:rPr sz="1300" b="1">
+                          <a:solidFill>
+                            <a:srgbClr val="FFFFFF"/>
+                          </a:solidFill>
+                        </a:rPr>
+                        <a:t>default hit</a:t>
+                      </a:r>
+                    </a:p>
+                  </a:txBody>
+                  <a:tcPr marT="12700" marB="12700">
+                    <a:solidFill>
+                      <a:srgbClr val="1B2A4A"/>
+                    </a:solidFill>
+                  </a:tcPr>
+                </a:tc>
+              </a:tr>
+              <a:tr h="292608">
+                <a:tc>
+                  <a:txBody>
+                    <a:bodyPr/>
+                    <a:lstStyle/>
+                    <a:p>
+                      <a:pPr algn="ctr"/>
+                      <a:r>
+                        <a:rPr sz="1300" b="0">
+                          <a:solidFill>
+                            <a:srgbClr val="1B2A4A"/>
+                          </a:solidFill>
+                        </a:rPr>
+                        <a:t>2</a:t>
+                      </a:r>
+                    </a:p>
+                  </a:txBody>
+                  <a:tcPr marT="12700" marB="12700">
+                    <a:solidFill>
+                      <a:srgbClr val="FFFFFF"/>
+                    </a:solidFill>
+                  </a:tcPr>
+                </a:tc>
+                <a:tc>
+                  <a:txBody>
+                    <a:bodyPr/>
+                    <a:lstStyle/>
+                    <a:p>
+                      <a:pPr algn="ctr"/>
+                      <a:r>
+                        <a:rPr sz="1300" b="0">
+                          <a:solidFill>
+                            <a:srgbClr val="1B2A4A"/>
+                          </a:solidFill>
+                        </a:rPr>
+                        <a:t>0.823</a:t>
+                      </a:r>
+                    </a:p>
+                  </a:txBody>
+                  <a:tcPr marT="12700" marB="12700">
+                    <a:solidFill>
+                      <a:srgbClr val="FFFFFF"/>
+                    </a:solidFill>
+                  </a:tcPr>
+                </a:tc>
+                <a:tc>
+                  <a:txBody>
+                    <a:bodyPr/>
+                    <a:lstStyle/>
+                    <a:p>
+                      <a:pPr algn="ctr"/>
+                      <a:r>
+                        <a:rPr sz="1300" b="0">
+                          <a:solidFill>
+                            <a:srgbClr val="1B2A4A"/>
+                          </a:solidFill>
+                        </a:rPr>
+                        <a:t>0.823</a:t>
+                      </a:r>
+                    </a:p>
+                  </a:txBody>
+                  <a:tcPr marT="12700" marB="12700">
+                    <a:solidFill>
+                      <a:srgbClr val="FFFFFF"/>
+                    </a:solidFill>
+                  </a:tcPr>
+                </a:tc>
+              </a:tr>
+              <a:tr h="292608">
+                <a:tc>
+                  <a:txBody>
+                    <a:bodyPr/>
+                    <a:lstStyle/>
+                    <a:p>
+                      <a:pPr algn="ctr"/>
+                      <a:r>
+                        <a:rPr sz="1300" b="0">
+                          <a:solidFill>
+                            <a:srgbClr val="1B2A4A"/>
+                          </a:solidFill>
+                        </a:rPr>
+                        <a:t>8</a:t>
+                      </a:r>
+                    </a:p>
+                  </a:txBody>
+                  <a:tcPr marT="12700" marB="12700">
+                    <a:solidFill>
+                      <a:srgbClr val="FFFFFF"/>
+                    </a:solidFill>
+                  </a:tcPr>
+                </a:tc>
+                <a:tc>
+                  <a:txBody>
+                    <a:bodyPr/>
+                    <a:lstStyle/>
+                    <a:p>
+                      <a:pPr algn="ctr"/>
+                      <a:r>
+                        <a:rPr sz="1300" b="0">
+                          <a:solidFill>
+                            <a:srgbClr val="1B2A4A"/>
+                          </a:solidFill>
+                        </a:rPr>
+                        <a:t>0.800</a:t>
+                      </a:r>
+                    </a:p>
+                  </a:txBody>
+                  <a:tcPr marT="12700" marB="12700">
+                    <a:solidFill>
+                      <a:srgbClr val="FFFFFF"/>
+                    </a:solidFill>
+                  </a:tcPr>
+                </a:tc>
+                <a:tc>
+                  <a:txBody>
+                    <a:bodyPr/>
+                    <a:lstStyle/>
+                    <a:p>
+                      <a:pPr algn="ctr"/>
+                      <a:r>
+                        <a:rPr sz="1300" b="0">
+                          <a:solidFill>
+                            <a:srgbClr val="1B2A4A"/>
+                          </a:solidFill>
+                        </a:rPr>
+                        <a:t>0.210</a:t>
+                      </a:r>
+                    </a:p>
+                  </a:txBody>
+                  <a:tcPr marT="12700" marB="12700">
+                    <a:solidFill>
+                      <a:srgbClr val="FFFFFF"/>
+                    </a:solidFill>
+                  </a:tcPr>
+                </a:tc>
+              </a:tr>
+              <a:tr h="292608">
+                <a:tc>
+                  <a:txBody>
+                    <a:bodyPr/>
+                    <a:lstStyle/>
+                    <a:p>
+                      <a:pPr algn="ctr"/>
+                      <a:r>
+                        <a:rPr sz="1300" b="0">
+                          <a:solidFill>
+                            <a:srgbClr val="1B2A4A"/>
+                          </a:solidFill>
+                        </a:rPr>
+                        <a:t>16</a:t>
+                      </a:r>
+                    </a:p>
+                  </a:txBody>
+                  <a:tcPr marT="12700" marB="12700">
+                    <a:solidFill>
+                      <a:srgbClr val="FFFFFF"/>
+                    </a:solidFill>
+                  </a:tcPr>
+                </a:tc>
+                <a:tc>
+                  <a:txBody>
+                    <a:bodyPr/>
+                    <a:lstStyle/>
+                    <a:p>
+                      <a:pPr algn="ctr"/>
+                      <a:r>
+                        <a:rPr sz="1300" b="0">
+                          <a:solidFill>
+                            <a:srgbClr val="1B2A4A"/>
+                          </a:solidFill>
+                        </a:rPr>
+                        <a:t>0.799</a:t>
+                      </a:r>
+                    </a:p>
+                  </a:txBody>
+                  <a:tcPr marT="12700" marB="12700">
+                    <a:solidFill>
+                      <a:srgbClr val="FFFFFF"/>
+                    </a:solidFill>
+                  </a:tcPr>
+                </a:tc>
+                <a:tc>
+                  <a:txBody>
+                    <a:bodyPr/>
+                    <a:lstStyle/>
+                    <a:p>
+                      <a:pPr algn="ctr"/>
+                      <a:r>
+                        <a:rPr sz="1300" b="1">
+                          <a:solidFill>
+                            <a:srgbClr val="B12A2A"/>
+                          </a:solidFill>
+                        </a:rPr>
+                        <a:t>0.047</a:t>
+                      </a:r>
+                    </a:p>
+                  </a:txBody>
+                  <a:tcPr marT="12700" marB="12700">
+                    <a:solidFill>
+                      <a:srgbClr val="FFFFFF"/>
+                    </a:solidFill>
+                  </a:tcPr>
+                </a:tc>
+              </a:tr>
+              <a:tr h="292608">
+                <a:tc>
+                  <a:txBody>
+                    <a:bodyPr/>
+                    <a:lstStyle/>
+                    <a:p>
+                      <a:pPr algn="ctr"/>
+                      <a:r>
+                        <a:rPr sz="1300" b="0">
+                          <a:solidFill>
+                            <a:srgbClr val="1B2A4A"/>
+                          </a:solidFill>
+                        </a:rPr>
+                        <a:t>32</a:t>
+                      </a:r>
+                    </a:p>
+                  </a:txBody>
+                  <a:tcPr marT="12700" marB="12700">
+                    <a:solidFill>
+                      <a:srgbClr val="FFFFFF"/>
+                    </a:solidFill>
+                  </a:tcPr>
+                </a:tc>
+                <a:tc>
+                  <a:txBody>
+                    <a:bodyPr/>
+                    <a:lstStyle/>
+                    <a:p>
+                      <a:pPr algn="ctr"/>
+                      <a:r>
+                        <a:rPr sz="1300" b="0">
+                          <a:solidFill>
+                            <a:srgbClr val="1B2A4A"/>
+                          </a:solidFill>
+                        </a:rPr>
+                        <a:t>0.774</a:t>
+                      </a:r>
+                    </a:p>
+                  </a:txBody>
+                  <a:tcPr marT="12700" marB="12700">
+                    <a:solidFill>
+                      <a:srgbClr val="FFFFFF"/>
+                    </a:solidFill>
+                  </a:tcPr>
+                </a:tc>
+                <a:tc>
+                  <a:txBody>
+                    <a:bodyPr/>
+                    <a:lstStyle/>
+                    <a:p>
+                      <a:pPr algn="ctr"/>
+                      <a:r>
+                        <a:rPr sz="1300" b="1">
+                          <a:solidFill>
+                            <a:srgbClr val="B12A2A"/>
+                          </a:solidFill>
+                        </a:rPr>
+                        <a:t>0.032</a:t>
+                      </a:r>
+                    </a:p>
+                  </a:txBody>
+                  <a:tcPr marT="12700" marB="12700">
+                    <a:solidFill>
+                      <a:srgbClr val="FFFFFF"/>
+                    </a:solidFill>
+                  </a:tcPr>
+                </a:tc>
+              </a:tr>
+              <a:tr h="292608">
+                <a:tc>
+                  <a:txBody>
+                    <a:bodyPr/>
+                    <a:lstStyle/>
+                    <a:p>
+                      <a:pPr algn="ctr"/>
+                      <a:r>
+                        <a:rPr sz="1300" b="0">
+                          <a:solidFill>
+                            <a:srgbClr val="1B2A4A"/>
+                          </a:solidFill>
+                        </a:rPr>
+                        <a:t>48</a:t>
+                      </a:r>
+                    </a:p>
+                  </a:txBody>
+                  <a:tcPr marT="12700" marB="12700">
+                    <a:solidFill>
+                      <a:srgbClr val="FFFFFF"/>
+                    </a:solidFill>
+                  </a:tcPr>
+                </a:tc>
+                <a:tc>
+                  <a:txBody>
+                    <a:bodyPr/>
+                    <a:lstStyle/>
+                    <a:p>
+                      <a:pPr algn="ctr"/>
+                      <a:r>
+                        <a:rPr sz="1300" b="0">
+                          <a:solidFill>
+                            <a:srgbClr val="1B2A4A"/>
+                          </a:solidFill>
+                        </a:rPr>
+                        <a:t>0.772</a:t>
+                      </a:r>
+                    </a:p>
+                  </a:txBody>
+                  <a:tcPr marT="12700" marB="12700">
+                    <a:solidFill>
+                      <a:srgbClr val="FFFFFF"/>
+                    </a:solidFill>
+                  </a:tcPr>
+                </a:tc>
+                <a:tc>
+                  <a:txBody>
+                    <a:bodyPr/>
+                    <a:lstStyle/>
+                    <a:p>
+                      <a:pPr algn="ctr"/>
+                      <a:r>
+                        <a:rPr sz="1300" b="1">
+                          <a:solidFill>
+                            <a:srgbClr val="B12A2A"/>
+                          </a:solidFill>
+                        </a:rPr>
+                        <a:t>0.026</a:t>
+                      </a:r>
+                    </a:p>
+                  </a:txBody>
+                  <a:tcPr marT="12700" marB="12700">
+                    <a:solidFill>
+                      <a:srgbClr val="FFFFFF"/>
+                    </a:solidFill>
+                  </a:tcPr>
+                </a:tc>
+              </a:tr>
+            </a:tbl>
+          </a:graphicData>
+        </a:graphic>
+      </p:graphicFrame>
+      <p:sp>
+        <p:nvSpPr>
+          <p:cNvPr id="6" name="TextBox 5"/>
+          <p:cNvSpPr txBox="1"/>
+          <p:nvPr/>
+        </p:nvSpPr>
+        <p:spPr>
+          <a:xfrm>
+            <a:off x="640080" y="5532120"/>
+            <a:ext cx="4206240" cy="320040"/>
+          </a:xfrm>
+          <a:prstGeom prst="rect">
+            <a:avLst/>
+          </a:prstGeom>
+          <a:noFill/>
+        </p:spPr>
+        <p:txBody>
+          <a:bodyPr wrap="none">
+            <a:spAutoFit/>
+          </a:bodyPr>
+          <a:lstStyle/>
+          <a:p>
+            <a:pPr algn="ctr"/>
+            <a:r>
+              <a:rPr sz="1100" b="1">
                 <a:solidFill>
                   <a:srgbClr val="1B2A4A"/>
                 </a:solidFill>
               </a:rPr>
-              <a:t>논문 핵심 주장(program-aware 스케줄링이 스래싱을 막는다)을 합성이 아닌 실데이터로 재현.</a:t>
+              <a:t>KV hit rate (3회 평균)</a:t>
             </a:r>
           </a:p>
         </p:txBody>
       </p:sp>
       <p:pic>
         <p:nvPicPr>
-          <p:cNvPr id="5" name="Picture 4" descr="hetero_homo_tracelab_hit_rate.png"/>
+          <p:cNvPr id="7" name="Picture 6" descr="hetero_homo_tracelab_hit_rate.png"/>
           <p:cNvPicPr>
             <a:picLocks noChangeAspect="1"/>
           </p:cNvPicPr>
@@ -7449,8 +8656,8 @@
         </p:blipFill>
         <p:spPr>
           <a:xfrm>
-            <a:off x="5486400" y="1554480"/>
-            <a:ext cx="6400800" cy="4336026"/>
+            <a:off x="5394960" y="1600200"/>
+            <a:ext cx="6492240" cy="4397969"/>
           </a:xfrm>
           <a:prstGeom prst="rect">
             <a:avLst/>
@@ -7559,8 +8766,8 @@
         </p:nvSpPr>
         <p:spPr>
           <a:xfrm>
-            <a:off x="548640" y="1280160"/>
-            <a:ext cx="5486400" cy="4754880"/>
+            <a:off x="502920" y="1234440"/>
+            <a:ext cx="5577840" cy="1737360"/>
           </a:xfrm>
           <a:prstGeom prst="rect">
             <a:avLst/>
@@ -7579,12 +8786,12 @@
               </a:spcAft>
             </a:pPr>
             <a:r>
-              <a:rPr sz="1500" b="1">
+              <a:rPr sz="1400" b="1">
                 <a:solidFill>
                   <a:srgbClr val="1B2A4A"/>
                 </a:solidFill>
               </a:rPr>
-              <a:t>같은 실험에서 throughput/latency는 default가 더 좋다:</a:t>
+              <a:t>같은 실험인데 throughput/latency는 default가 더 좋다 (반전):</a:t>
             </a:r>
           </a:p>
           <a:p>
@@ -7594,12 +8801,12 @@
               </a:spcAft>
             </a:pPr>
             <a:r>
-              <a:rPr sz="1300" b="0">
+              <a:rPr sz="1200" b="0">
                 <a:solidFill>
-                  <a:srgbClr val="B12A2A"/>
+                  <a:srgbClr val="1B2A4A"/>
                 </a:solidFill>
               </a:rPr>
-              <a:t>c=48: throughput tr 0.067 vs default 0.102  /  p95 727s vs 481s</a:t>
+              <a:t>원인=슬6: 프로그램이 4090 KV에 육박(~2개). tr은 초과분 pause→병렬성 희생, default는 스래싱하며 다 돌림</a:t>
             </a:r>
           </a:p>
           <a:p>
@@ -7609,64 +8816,530 @@
               </a:spcAft>
             </a:pPr>
             <a:r>
-              <a:rPr sz="1500" b="1">
+              <a:rPr sz="1400" b="1">
                 <a:solidFill>
                   <a:srgbClr val="1B2A4A"/>
                 </a:solidFill>
               </a:rPr>
-              <a:t>원인 = 슬라이드 6 (프로그램이 4090 KV에 육박, ~2개만 적재)</a:t>
-            </a:r>
-          </a:p>
-          <a:p>
-            <a:pPr lvl="1">
-              <a:spcAft>
-                <a:spcPts val="700"/>
-              </a:spcAft>
-            </a:pPr>
-            <a:r>
-              <a:rPr sz="1300" b="0">
-                <a:solidFill>
-                  <a:srgbClr val="4A4A4A"/>
-                </a:solidFill>
-              </a:rPr>
-              <a:t>tr은 용량 초과분을 pause/queue → 캐시는 지키나 병렬성 희생 (closed-loop이라 대기)</a:t>
-            </a:r>
-          </a:p>
-          <a:p>
-            <a:pPr lvl="1">
-              <a:spcAft>
-                <a:spcPts val="700"/>
-              </a:spcAft>
-            </a:pPr>
-            <a:r>
-              <a:rPr sz="1300" b="0">
-                <a:solidFill>
-                  <a:srgbClr val="4A4A4A"/>
-                </a:solidFill>
-              </a:rPr>
-              <a:t>default는 캐시를 갈아엎지만(reprefill↑) 병렬성 유지 → wall-clock throughput↑</a:t>
-            </a:r>
-          </a:p>
-          <a:p>
-            <a:pPr>
-              <a:spcAft>
-                <a:spcPts val="700"/>
-              </a:spcAft>
-            </a:pPr>
-            <a:r>
-              <a:rPr sz="1500" b="1">
+              <a:t>합성 §9(tr +57%)와 정반대 → tr 이득은 '프로그램/KV 비율'에 좌우됨.</a:t>
+            </a:r>
+          </a:p>
+        </p:txBody>
+      </p:sp>
+      <p:graphicFrame>
+        <p:nvGraphicFramePr>
+          <p:cNvPr id="5" name="Table 4"/>
+          <p:cNvGraphicFramePr>
+            <a:graphicFrameLocks noGrp="1"/>
+          </p:cNvGraphicFramePr>
+          <p:nvPr/>
+        </p:nvGraphicFramePr>
+        <p:xfrm>
+          <a:off x="548640" y="3200400"/>
+          <a:ext cx="5577840" cy="1170432"/>
+        </p:xfrm>
+        <a:graphic>
+          <a:graphicData uri="http://schemas.openxmlformats.org/drawingml/2006/table">
+            <a:tbl>
+              <a:tblPr>
+                <a:tableStyleId>{5C22544A-7EE6-4342-B048-85BDC9FD1C3A}</a:tableStyleId>
+              </a:tblPr>
+              <a:tblGrid>
+                <a:gridCol w="822960"/>
+                <a:gridCol w="1188720"/>
+                <a:gridCol w="1188720"/>
+                <a:gridCol w="1188720"/>
+                <a:gridCol w="1188720"/>
+              </a:tblGrid>
+              <a:tr h="292608">
+                <a:tc>
+                  <a:txBody>
+                    <a:bodyPr/>
+                    <a:lstStyle/>
+                    <a:p>
+                      <a:pPr algn="ctr"/>
+                      <a:r>
+                        <a:rPr sz="1300" b="1">
+                          <a:solidFill>
+                            <a:srgbClr val="FFFFFF"/>
+                          </a:solidFill>
+                        </a:rPr>
+                        <a:t>C</a:t>
+                      </a:r>
+                    </a:p>
+                  </a:txBody>
+                  <a:tcPr marT="12700" marB="12700">
+                    <a:solidFill>
+                      <a:srgbClr val="1B2A4A"/>
+                    </a:solidFill>
+                  </a:tcPr>
+                </a:tc>
+                <a:tc>
+                  <a:txBody>
+                    <a:bodyPr/>
+                    <a:lstStyle/>
+                    <a:p>
+                      <a:pPr algn="ctr"/>
+                      <a:r>
+                        <a:rPr sz="1300" b="1">
+                          <a:solidFill>
+                            <a:srgbClr val="FFFFFF"/>
+                          </a:solidFill>
+                        </a:rPr>
+                        <a:t>thru tr</a:t>
+                      </a:r>
+                    </a:p>
+                  </a:txBody>
+                  <a:tcPr marT="12700" marB="12700">
+                    <a:solidFill>
+                      <a:srgbClr val="1B2A4A"/>
+                    </a:solidFill>
+                  </a:tcPr>
+                </a:tc>
+                <a:tc>
+                  <a:txBody>
+                    <a:bodyPr/>
+                    <a:lstStyle/>
+                    <a:p>
+                      <a:pPr algn="ctr"/>
+                      <a:r>
+                        <a:rPr sz="1300" b="1">
+                          <a:solidFill>
+                            <a:srgbClr val="FFFFFF"/>
+                          </a:solidFill>
+                        </a:rPr>
+                        <a:t>thru def</a:t>
+                      </a:r>
+                    </a:p>
+                  </a:txBody>
+                  <a:tcPr marT="12700" marB="12700">
+                    <a:solidFill>
+                      <a:srgbClr val="1B2A4A"/>
+                    </a:solidFill>
+                  </a:tcPr>
+                </a:tc>
+                <a:tc>
+                  <a:txBody>
+                    <a:bodyPr/>
+                    <a:lstStyle/>
+                    <a:p>
+                      <a:pPr algn="ctr"/>
+                      <a:r>
+                        <a:rPr sz="1300" b="1">
+                          <a:solidFill>
+                            <a:srgbClr val="FFFFFF"/>
+                          </a:solidFill>
+                        </a:rPr>
+                        <a:t>p95 tr</a:t>
+                      </a:r>
+                    </a:p>
+                  </a:txBody>
+                  <a:tcPr marT="12700" marB="12700">
+                    <a:solidFill>
+                      <a:srgbClr val="1B2A4A"/>
+                    </a:solidFill>
+                  </a:tcPr>
+                </a:tc>
+                <a:tc>
+                  <a:txBody>
+                    <a:bodyPr/>
+                    <a:lstStyle/>
+                    <a:p>
+                      <a:pPr algn="ctr"/>
+                      <a:r>
+                        <a:rPr sz="1300" b="1">
+                          <a:solidFill>
+                            <a:srgbClr val="FFFFFF"/>
+                          </a:solidFill>
+                        </a:rPr>
+                        <a:t>p95 def</a:t>
+                      </a:r>
+                    </a:p>
+                  </a:txBody>
+                  <a:tcPr marT="12700" marB="12700">
+                    <a:solidFill>
+                      <a:srgbClr val="1B2A4A"/>
+                    </a:solidFill>
+                  </a:tcPr>
+                </a:tc>
+              </a:tr>
+              <a:tr h="292608">
+                <a:tc>
+                  <a:txBody>
+                    <a:bodyPr/>
+                    <a:lstStyle/>
+                    <a:p>
+                      <a:pPr algn="ctr"/>
+                      <a:r>
+                        <a:rPr sz="1300" b="0">
+                          <a:solidFill>
+                            <a:srgbClr val="1B2A4A"/>
+                          </a:solidFill>
+                        </a:rPr>
+                        <a:t>8</a:t>
+                      </a:r>
+                    </a:p>
+                  </a:txBody>
+                  <a:tcPr marT="12700" marB="12700">
+                    <a:solidFill>
+                      <a:srgbClr val="FFFFFF"/>
+                    </a:solidFill>
+                  </a:tcPr>
+                </a:tc>
+                <a:tc>
+                  <a:txBody>
+                    <a:bodyPr/>
+                    <a:lstStyle/>
+                    <a:p>
+                      <a:pPr algn="ctr"/>
+                      <a:r>
+                        <a:rPr sz="1300" b="1">
+                          <a:solidFill>
+                            <a:srgbClr val="B12A2A"/>
+                          </a:solidFill>
+                        </a:rPr>
+                        <a:t>0.078</a:t>
+                      </a:r>
+                    </a:p>
+                  </a:txBody>
+                  <a:tcPr marT="12700" marB="12700">
+                    <a:solidFill>
+                      <a:srgbClr val="FFFFFF"/>
+                    </a:solidFill>
+                  </a:tcPr>
+                </a:tc>
+                <a:tc>
+                  <a:txBody>
+                    <a:bodyPr/>
+                    <a:lstStyle/>
+                    <a:p>
+                      <a:pPr algn="ctr"/>
+                      <a:r>
+                        <a:rPr sz="1300" b="0">
+                          <a:solidFill>
+                            <a:srgbClr val="1B2A4A"/>
+                          </a:solidFill>
+                        </a:rPr>
+                        <a:t>0.120</a:t>
+                      </a:r>
+                    </a:p>
+                  </a:txBody>
+                  <a:tcPr marT="12700" marB="12700">
+                    <a:solidFill>
+                      <a:srgbClr val="FFFFFF"/>
+                    </a:solidFill>
+                  </a:tcPr>
+                </a:tc>
+                <a:tc>
+                  <a:txBody>
+                    <a:bodyPr/>
+                    <a:lstStyle/>
+                    <a:p>
+                      <a:pPr algn="ctr"/>
+                      <a:r>
+                        <a:rPr sz="1300" b="1">
+                          <a:solidFill>
+                            <a:srgbClr val="B12A2A"/>
+                          </a:solidFill>
+                        </a:rPr>
+                        <a:t>184s</a:t>
+                      </a:r>
+                    </a:p>
+                  </a:txBody>
+                  <a:tcPr marT="12700" marB="12700">
+                    <a:solidFill>
+                      <a:srgbClr val="FFFFFF"/>
+                    </a:solidFill>
+                  </a:tcPr>
+                </a:tc>
+                <a:tc>
+                  <a:txBody>
+                    <a:bodyPr/>
+                    <a:lstStyle/>
+                    <a:p>
+                      <a:pPr algn="ctr"/>
+                      <a:r>
+                        <a:rPr sz="1300" b="0">
+                          <a:solidFill>
+                            <a:srgbClr val="1B2A4A"/>
+                          </a:solidFill>
+                        </a:rPr>
+                        <a:t>153s</a:t>
+                      </a:r>
+                    </a:p>
+                  </a:txBody>
+                  <a:tcPr marT="12700" marB="12700">
+                    <a:solidFill>
+                      <a:srgbClr val="FFFFFF"/>
+                    </a:solidFill>
+                  </a:tcPr>
+                </a:tc>
+              </a:tr>
+              <a:tr h="292608">
+                <a:tc>
+                  <a:txBody>
+                    <a:bodyPr/>
+                    <a:lstStyle/>
+                    <a:p>
+                      <a:pPr algn="ctr"/>
+                      <a:r>
+                        <a:rPr sz="1300" b="0">
+                          <a:solidFill>
+                            <a:srgbClr val="1B2A4A"/>
+                          </a:solidFill>
+                        </a:rPr>
+                        <a:t>16</a:t>
+                      </a:r>
+                    </a:p>
+                  </a:txBody>
+                  <a:tcPr marT="12700" marB="12700">
+                    <a:solidFill>
+                      <a:srgbClr val="FFFFFF"/>
+                    </a:solidFill>
+                  </a:tcPr>
+                </a:tc>
+                <a:tc>
+                  <a:txBody>
+                    <a:bodyPr/>
+                    <a:lstStyle/>
+                    <a:p>
+                      <a:pPr algn="ctr"/>
+                      <a:r>
+                        <a:rPr sz="1300" b="1">
+                          <a:solidFill>
+                            <a:srgbClr val="B12A2A"/>
+                          </a:solidFill>
+                        </a:rPr>
+                        <a:t>0.073</a:t>
+                      </a:r>
+                    </a:p>
+                  </a:txBody>
+                  <a:tcPr marT="12700" marB="12700">
+                    <a:solidFill>
+                      <a:srgbClr val="FFFFFF"/>
+                    </a:solidFill>
+                  </a:tcPr>
+                </a:tc>
+                <a:tc>
+                  <a:txBody>
+                    <a:bodyPr/>
+                    <a:lstStyle/>
+                    <a:p>
+                      <a:pPr algn="ctr"/>
+                      <a:r>
+                        <a:rPr sz="1300" b="0">
+                          <a:solidFill>
+                            <a:srgbClr val="1B2A4A"/>
+                          </a:solidFill>
+                        </a:rPr>
+                        <a:t>0.107</a:t>
+                      </a:r>
+                    </a:p>
+                  </a:txBody>
+                  <a:tcPr marT="12700" marB="12700">
+                    <a:solidFill>
+                      <a:srgbClr val="FFFFFF"/>
+                    </a:solidFill>
+                  </a:tcPr>
+                </a:tc>
+                <a:tc>
+                  <a:txBody>
+                    <a:bodyPr/>
+                    <a:lstStyle/>
+                    <a:p>
+                      <a:pPr algn="ctr"/>
+                      <a:r>
+                        <a:rPr sz="1300" b="1">
+                          <a:solidFill>
+                            <a:srgbClr val="B12A2A"/>
+                          </a:solidFill>
+                        </a:rPr>
+                        <a:t>595s</a:t>
+                      </a:r>
+                    </a:p>
+                  </a:txBody>
+                  <a:tcPr marT="12700" marB="12700">
+                    <a:solidFill>
+                      <a:srgbClr val="FFFFFF"/>
+                    </a:solidFill>
+                  </a:tcPr>
+                </a:tc>
+                <a:tc>
+                  <a:txBody>
+                    <a:bodyPr/>
+                    <a:lstStyle/>
+                    <a:p>
+                      <a:pPr algn="ctr"/>
+                      <a:r>
+                        <a:rPr sz="1300" b="0">
+                          <a:solidFill>
+                            <a:srgbClr val="1B2A4A"/>
+                          </a:solidFill>
+                        </a:rPr>
+                        <a:t>289s</a:t>
+                      </a:r>
+                    </a:p>
+                  </a:txBody>
+                  <a:tcPr marT="12700" marB="12700">
+                    <a:solidFill>
+                      <a:srgbClr val="FFFFFF"/>
+                    </a:solidFill>
+                  </a:tcPr>
+                </a:tc>
+              </a:tr>
+              <a:tr h="292608">
+                <a:tc>
+                  <a:txBody>
+                    <a:bodyPr/>
+                    <a:lstStyle/>
+                    <a:p>
+                      <a:pPr algn="ctr"/>
+                      <a:r>
+                        <a:rPr sz="1300" b="0">
+                          <a:solidFill>
+                            <a:srgbClr val="1B2A4A"/>
+                          </a:solidFill>
+                        </a:rPr>
+                        <a:t>48</a:t>
+                      </a:r>
+                    </a:p>
+                  </a:txBody>
+                  <a:tcPr marT="12700" marB="12700">
+                    <a:solidFill>
+                      <a:srgbClr val="FFFFFF"/>
+                    </a:solidFill>
+                  </a:tcPr>
+                </a:tc>
+                <a:tc>
+                  <a:txBody>
+                    <a:bodyPr/>
+                    <a:lstStyle/>
+                    <a:p>
+                      <a:pPr algn="ctr"/>
+                      <a:r>
+                        <a:rPr sz="1300" b="1">
+                          <a:solidFill>
+                            <a:srgbClr val="B12A2A"/>
+                          </a:solidFill>
+                        </a:rPr>
+                        <a:t>0.067</a:t>
+                      </a:r>
+                    </a:p>
+                  </a:txBody>
+                  <a:tcPr marT="12700" marB="12700">
+                    <a:solidFill>
+                      <a:srgbClr val="FFFFFF"/>
+                    </a:solidFill>
+                  </a:tcPr>
+                </a:tc>
+                <a:tc>
+                  <a:txBody>
+                    <a:bodyPr/>
+                    <a:lstStyle/>
+                    <a:p>
+                      <a:pPr algn="ctr"/>
+                      <a:r>
+                        <a:rPr sz="1300" b="0">
+                          <a:solidFill>
+                            <a:srgbClr val="1B2A4A"/>
+                          </a:solidFill>
+                        </a:rPr>
+                        <a:t>0.102</a:t>
+                      </a:r>
+                    </a:p>
+                  </a:txBody>
+                  <a:tcPr marT="12700" marB="12700">
+                    <a:solidFill>
+                      <a:srgbClr val="FFFFFF"/>
+                    </a:solidFill>
+                  </a:tcPr>
+                </a:tc>
+                <a:tc>
+                  <a:txBody>
+                    <a:bodyPr/>
+                    <a:lstStyle/>
+                    <a:p>
+                      <a:pPr algn="ctr"/>
+                      <a:r>
+                        <a:rPr sz="1300" b="1">
+                          <a:solidFill>
+                            <a:srgbClr val="B12A2A"/>
+                          </a:solidFill>
+                        </a:rPr>
+                        <a:t>727s</a:t>
+                      </a:r>
+                    </a:p>
+                  </a:txBody>
+                  <a:tcPr marT="12700" marB="12700">
+                    <a:solidFill>
+                      <a:srgbClr val="FFFFFF"/>
+                    </a:solidFill>
+                  </a:tcPr>
+                </a:tc>
+                <a:tc>
+                  <a:txBody>
+                    <a:bodyPr/>
+                    <a:lstStyle/>
+                    <a:p>
+                      <a:pPr algn="ctr"/>
+                      <a:r>
+                        <a:rPr sz="1300" b="0">
+                          <a:solidFill>
+                            <a:srgbClr val="1B2A4A"/>
+                          </a:solidFill>
+                        </a:rPr>
+                        <a:t>481s</a:t>
+                      </a:r>
+                    </a:p>
+                  </a:txBody>
+                  <a:tcPr marT="12700" marB="12700">
+                    <a:solidFill>
+                      <a:srgbClr val="FFFFFF"/>
+                    </a:solidFill>
+                  </a:tcPr>
+                </a:tc>
+              </a:tr>
+            </a:tbl>
+          </a:graphicData>
+        </a:graphic>
+      </p:graphicFrame>
+      <p:sp>
+        <p:nvSpPr>
+          <p:cNvPr id="6" name="TextBox 5"/>
+          <p:cNvSpPr txBox="1"/>
+          <p:nvPr/>
+        </p:nvSpPr>
+        <p:spPr>
+          <a:xfrm>
+            <a:off x="548640" y="5074920"/>
+            <a:ext cx="5577840" cy="320040"/>
+          </a:xfrm>
+          <a:prstGeom prst="rect">
+            <a:avLst/>
+          </a:prstGeom>
+          <a:noFill/>
+        </p:spPr>
+        <p:txBody>
+          <a:bodyPr wrap="none">
+            <a:spAutoFit/>
+          </a:bodyPr>
+          <a:lstStyle/>
+          <a:p>
+            <a:pPr algn="ctr"/>
+            <a:r>
+              <a:rPr sz="1100" b="1">
                 <a:solidFill>
                   <a:srgbClr val="1B2A4A"/>
                 </a:solidFill>
               </a:rPr>
-              <a:t>합성 §9(tr +57%)와 정반대. → tr 이득은 '프로그램/KV 비율'에 좌우됨.</a:t>
+              <a:t>throughput(p/s)·p95 — tr(빨강)이 열세</a:t>
             </a:r>
           </a:p>
         </p:txBody>
       </p:sp>
       <p:pic>
         <p:nvPicPr>
-          <p:cNvPr id="5" name="Picture 4" descr="hetero_homo_tracelab_throughput.png"/>
+          <p:cNvPr id="7" name="Picture 6" descr="hetero_homo_tracelab_throughput.png"/>
           <p:cNvPicPr>
             <a:picLocks noChangeAspect="1"/>
           </p:cNvPicPr>
@@ -7680,8 +9353,8 @@
         </p:blipFill>
         <p:spPr>
           <a:xfrm>
-            <a:off x="6217920" y="1417320"/>
-            <a:ext cx="5760720" cy="3902423"/>
+            <a:off x="6400800" y="1554480"/>
+            <a:ext cx="5577840" cy="3778537"/>
           </a:xfrm>
           <a:prstGeom prst="rect">
             <a:avLst/>
@@ -7690,14 +9363,14 @@
       </p:pic>
       <p:sp>
         <p:nvSpPr>
-          <p:cNvPr id="6" name="TextBox 5"/>
+          <p:cNvPr id="8" name="TextBox 7"/>
           <p:cNvSpPr txBox="1"/>
           <p:nvPr/>
         </p:nvSpPr>
         <p:spPr>
           <a:xfrm>
-            <a:off x="6217920" y="5989320"/>
-            <a:ext cx="5760720" cy="320040"/>
+            <a:off x="6400800" y="5806440"/>
+            <a:ext cx="5577840" cy="320040"/>
           </a:xfrm>
           <a:prstGeom prst="rect">
             <a:avLst/>
@@ -7717,7 +9390,7 @@
                   <a:srgbClr val="1B2A4A"/>
                 </a:solidFill>
               </a:rPr>
-              <a:t>throughput vs concurrency (tr vs default)</a:t>
+              <a:t>throughput vs concurrency</a:t>
             </a:r>
           </a:p>
         </p:txBody>
@@ -7824,8 +9497,8 @@
         </p:nvSpPr>
         <p:spPr>
           <a:xfrm>
-            <a:off x="548640" y="1280160"/>
-            <a:ext cx="4754880" cy="4206240"/>
+            <a:off x="502920" y="1234440"/>
+            <a:ext cx="4937760" cy="1463040"/>
           </a:xfrm>
           <a:prstGeom prst="rect">
             <a:avLst/>
@@ -7844,7 +9517,7 @@
               </a:spcAft>
             </a:pPr>
             <a:r>
-              <a:rPr sz="1600" b="1">
+              <a:rPr sz="1500" b="1">
                 <a:solidFill>
                   <a:srgbClr val="1B2A4A"/>
                 </a:solidFill>
@@ -7859,27 +9532,12 @@
               </a:spcAft>
             </a:pPr>
             <a:r>
-              <a:rPr sz="1400" b="0">
+              <a:rPr sz="1300" b="0">
                 <a:solidFill>
                   <a:srgbClr val="1E7A3C"/>
                 </a:solidFill>
               </a:rPr>
-              <a:t>고부하 throughput: tr 0.64 vs default 0.32 (≈2×)</a:t>
-            </a:r>
-          </a:p>
-          <a:p>
-            <a:pPr lvl="1">
-              <a:spcAft>
-                <a:spcPts val="700"/>
-              </a:spcAft>
-            </a:pPr>
-            <a:r>
-              <a:rPr sz="1400" b="0">
-                <a:solidFill>
-                  <a:srgbClr val="4A4A4A"/>
-                </a:solidFill>
-              </a:rPr>
-              <a:t>전역 hit rate: 0.67 vs 0.02</a:t>
+              <a:t>고부하 throughput tr≈2×, hit 0.67 vs 0.02</a:t>
             </a:r>
           </a:p>
           <a:p>
@@ -7889,19 +9547,642 @@
               </a:spcAft>
             </a:pPr>
             <a:r>
-              <a:rPr sz="1600" b="1">
+              <a:rPr sz="1500" b="1">
                 <a:solidFill>
                   <a:srgbClr val="1B2A4A"/>
                 </a:solidFill>
               </a:rPr>
-              <a:t>합성 워크로드에선 이종에서도 tr이 명확히 우세 (D의 실데이터와 대조).</a:t>
+              <a:t>합성에선 이종에서도 tr이 명확히 우세 (실데이터 D와 대조).</a:t>
+            </a:r>
+          </a:p>
+        </p:txBody>
+      </p:sp>
+      <p:graphicFrame>
+        <p:nvGraphicFramePr>
+          <p:cNvPr id="5" name="Table 4"/>
+          <p:cNvGraphicFramePr>
+            <a:graphicFrameLocks noGrp="1"/>
+          </p:cNvGraphicFramePr>
+          <p:nvPr/>
+        </p:nvGraphicFramePr>
+        <p:xfrm>
+          <a:off x="594360" y="2834640"/>
+          <a:ext cx="4754880" cy="1463040"/>
+        </p:xfrm>
+        <a:graphic>
+          <a:graphicData uri="http://schemas.openxmlformats.org/drawingml/2006/table">
+            <a:tbl>
+              <a:tblPr>
+                <a:tableStyleId>{5C22544A-7EE6-4342-B048-85BDC9FD1C3A}</a:tableStyleId>
+              </a:tblPr>
+              <a:tblGrid>
+                <a:gridCol w="731520"/>
+                <a:gridCol w="1051560"/>
+                <a:gridCol w="1051560"/>
+                <a:gridCol w="960120"/>
+                <a:gridCol w="960120"/>
+              </a:tblGrid>
+              <a:tr h="292608">
+                <a:tc>
+                  <a:txBody>
+                    <a:bodyPr/>
+                    <a:lstStyle/>
+                    <a:p>
+                      <a:pPr algn="ctr"/>
+                      <a:r>
+                        <a:rPr sz="1300" b="1">
+                          <a:solidFill>
+                            <a:srgbClr val="FFFFFF"/>
+                          </a:solidFill>
+                        </a:rPr>
+                        <a:t>C</a:t>
+                      </a:r>
+                    </a:p>
+                  </a:txBody>
+                  <a:tcPr marT="12700" marB="12700">
+                    <a:solidFill>
+                      <a:srgbClr val="1B2A4A"/>
+                    </a:solidFill>
+                  </a:tcPr>
+                </a:tc>
+                <a:tc>
+                  <a:txBody>
+                    <a:bodyPr/>
+                    <a:lstStyle/>
+                    <a:p>
+                      <a:pPr algn="ctr"/>
+                      <a:r>
+                        <a:rPr sz="1300" b="1">
+                          <a:solidFill>
+                            <a:srgbClr val="FFFFFF"/>
+                          </a:solidFill>
+                        </a:rPr>
+                        <a:t>thru tr</a:t>
+                      </a:r>
+                    </a:p>
+                  </a:txBody>
+                  <a:tcPr marT="12700" marB="12700">
+                    <a:solidFill>
+                      <a:srgbClr val="1B2A4A"/>
+                    </a:solidFill>
+                  </a:tcPr>
+                </a:tc>
+                <a:tc>
+                  <a:txBody>
+                    <a:bodyPr/>
+                    <a:lstStyle/>
+                    <a:p>
+                      <a:pPr algn="ctr"/>
+                      <a:r>
+                        <a:rPr sz="1300" b="1">
+                          <a:solidFill>
+                            <a:srgbClr val="FFFFFF"/>
+                          </a:solidFill>
+                        </a:rPr>
+                        <a:t>thru def</a:t>
+                      </a:r>
+                    </a:p>
+                  </a:txBody>
+                  <a:tcPr marT="12700" marB="12700">
+                    <a:solidFill>
+                      <a:srgbClr val="1B2A4A"/>
+                    </a:solidFill>
+                  </a:tcPr>
+                </a:tc>
+                <a:tc>
+                  <a:txBody>
+                    <a:bodyPr/>
+                    <a:lstStyle/>
+                    <a:p>
+                      <a:pPr algn="ctr"/>
+                      <a:r>
+                        <a:rPr sz="1300" b="1">
+                          <a:solidFill>
+                            <a:srgbClr val="FFFFFF"/>
+                          </a:solidFill>
+                        </a:rPr>
+                        <a:t>hit tr</a:t>
+                      </a:r>
+                    </a:p>
+                  </a:txBody>
+                  <a:tcPr marT="12700" marB="12700">
+                    <a:solidFill>
+                      <a:srgbClr val="1B2A4A"/>
+                    </a:solidFill>
+                  </a:tcPr>
+                </a:tc>
+                <a:tc>
+                  <a:txBody>
+                    <a:bodyPr/>
+                    <a:lstStyle/>
+                    <a:p>
+                      <a:pPr algn="ctr"/>
+                      <a:r>
+                        <a:rPr sz="1300" b="1">
+                          <a:solidFill>
+                            <a:srgbClr val="FFFFFF"/>
+                          </a:solidFill>
+                        </a:rPr>
+                        <a:t>hit def</a:t>
+                      </a:r>
+                    </a:p>
+                  </a:txBody>
+                  <a:tcPr marT="12700" marB="12700">
+                    <a:solidFill>
+                      <a:srgbClr val="1B2A4A"/>
+                    </a:solidFill>
+                  </a:tcPr>
+                </a:tc>
+              </a:tr>
+              <a:tr h="292608">
+                <a:tc>
+                  <a:txBody>
+                    <a:bodyPr/>
+                    <a:lstStyle/>
+                    <a:p>
+                      <a:pPr algn="ctr"/>
+                      <a:r>
+                        <a:rPr sz="1300" b="0">
+                          <a:solidFill>
+                            <a:srgbClr val="1B2A4A"/>
+                          </a:solidFill>
+                        </a:rPr>
+                        <a:t>8</a:t>
+                      </a:r>
+                    </a:p>
+                  </a:txBody>
+                  <a:tcPr marT="12700" marB="12700">
+                    <a:solidFill>
+                      <a:srgbClr val="FFFFFF"/>
+                    </a:solidFill>
+                  </a:tcPr>
+                </a:tc>
+                <a:tc>
+                  <a:txBody>
+                    <a:bodyPr/>
+                    <a:lstStyle/>
+                    <a:p>
+                      <a:pPr algn="ctr"/>
+                      <a:r>
+                        <a:rPr sz="1300" b="0">
+                          <a:solidFill>
+                            <a:srgbClr val="1B2A4A"/>
+                          </a:solidFill>
+                        </a:rPr>
+                        <a:t>0.67</a:t>
+                      </a:r>
+                    </a:p>
+                  </a:txBody>
+                  <a:tcPr marT="12700" marB="12700">
+                    <a:solidFill>
+                      <a:srgbClr val="FFFFFF"/>
+                    </a:solidFill>
+                  </a:tcPr>
+                </a:tc>
+                <a:tc>
+                  <a:txBody>
+                    <a:bodyPr/>
+                    <a:lstStyle/>
+                    <a:p>
+                      <a:pPr algn="ctr"/>
+                      <a:r>
+                        <a:rPr sz="1300" b="0">
+                          <a:solidFill>
+                            <a:srgbClr val="1B2A4A"/>
+                          </a:solidFill>
+                        </a:rPr>
+                        <a:t>0.62</a:t>
+                      </a:r>
+                    </a:p>
+                  </a:txBody>
+                  <a:tcPr marT="12700" marB="12700">
+                    <a:solidFill>
+                      <a:srgbClr val="FFFFFF"/>
+                    </a:solidFill>
+                  </a:tcPr>
+                </a:tc>
+                <a:tc>
+                  <a:txBody>
+                    <a:bodyPr/>
+                    <a:lstStyle/>
+                    <a:p>
+                      <a:pPr algn="ctr"/>
+                      <a:r>
+                        <a:rPr sz="1300" b="0">
+                          <a:solidFill>
+                            <a:srgbClr val="1B2A4A"/>
+                          </a:solidFill>
+                        </a:rPr>
+                        <a:t>0.56</a:t>
+                      </a:r>
+                    </a:p>
+                  </a:txBody>
+                  <a:tcPr marT="12700" marB="12700">
+                    <a:solidFill>
+                      <a:srgbClr val="FFFFFF"/>
+                    </a:solidFill>
+                  </a:tcPr>
+                </a:tc>
+                <a:tc>
+                  <a:txBody>
+                    <a:bodyPr/>
+                    <a:lstStyle/>
+                    <a:p>
+                      <a:pPr algn="ctr"/>
+                      <a:r>
+                        <a:rPr sz="1300" b="0">
+                          <a:solidFill>
+                            <a:srgbClr val="1B2A4A"/>
+                          </a:solidFill>
+                        </a:rPr>
+                        <a:t>0.23</a:t>
+                      </a:r>
+                    </a:p>
+                  </a:txBody>
+                  <a:tcPr marT="12700" marB="12700">
+                    <a:solidFill>
+                      <a:srgbClr val="FFFFFF"/>
+                    </a:solidFill>
+                  </a:tcPr>
+                </a:tc>
+              </a:tr>
+              <a:tr h="292608">
+                <a:tc>
+                  <a:txBody>
+                    <a:bodyPr/>
+                    <a:lstStyle/>
+                    <a:p>
+                      <a:pPr algn="ctr"/>
+                      <a:r>
+                        <a:rPr sz="1300" b="0">
+                          <a:solidFill>
+                            <a:srgbClr val="1B2A4A"/>
+                          </a:solidFill>
+                        </a:rPr>
+                        <a:t>16</a:t>
+                      </a:r>
+                    </a:p>
+                  </a:txBody>
+                  <a:tcPr marT="12700" marB="12700">
+                    <a:solidFill>
+                      <a:srgbClr val="FFFFFF"/>
+                    </a:solidFill>
+                  </a:tcPr>
+                </a:tc>
+                <a:tc>
+                  <a:txBody>
+                    <a:bodyPr/>
+                    <a:lstStyle/>
+                    <a:p>
+                      <a:pPr algn="ctr"/>
+                      <a:r>
+                        <a:rPr sz="1300" b="0">
+                          <a:solidFill>
+                            <a:srgbClr val="1B2A4A"/>
+                          </a:solidFill>
+                        </a:rPr>
+                        <a:t>0.64</a:t>
+                      </a:r>
+                    </a:p>
+                  </a:txBody>
+                  <a:tcPr marT="12700" marB="12700">
+                    <a:solidFill>
+                      <a:srgbClr val="FFFFFF"/>
+                    </a:solidFill>
+                  </a:tcPr>
+                </a:tc>
+                <a:tc>
+                  <a:txBody>
+                    <a:bodyPr/>
+                    <a:lstStyle/>
+                    <a:p>
+                      <a:pPr algn="ctr"/>
+                      <a:r>
+                        <a:rPr sz="1300" b="1">
+                          <a:solidFill>
+                            <a:srgbClr val="B12A2A"/>
+                          </a:solidFill>
+                        </a:rPr>
+                        <a:t>0.34</a:t>
+                      </a:r>
+                    </a:p>
+                  </a:txBody>
+                  <a:tcPr marT="12700" marB="12700">
+                    <a:solidFill>
+                      <a:srgbClr val="FFFFFF"/>
+                    </a:solidFill>
+                  </a:tcPr>
+                </a:tc>
+                <a:tc>
+                  <a:txBody>
+                    <a:bodyPr/>
+                    <a:lstStyle/>
+                    <a:p>
+                      <a:pPr algn="ctr"/>
+                      <a:r>
+                        <a:rPr sz="1300" b="0">
+                          <a:solidFill>
+                            <a:srgbClr val="1B2A4A"/>
+                          </a:solidFill>
+                        </a:rPr>
+                        <a:t>0.67</a:t>
+                      </a:r>
+                    </a:p>
+                  </a:txBody>
+                  <a:tcPr marT="12700" marB="12700">
+                    <a:solidFill>
+                      <a:srgbClr val="FFFFFF"/>
+                    </a:solidFill>
+                  </a:tcPr>
+                </a:tc>
+                <a:tc>
+                  <a:txBody>
+                    <a:bodyPr/>
+                    <a:lstStyle/>
+                    <a:p>
+                      <a:pPr algn="ctr"/>
+                      <a:r>
+                        <a:rPr sz="1300" b="1">
+                          <a:solidFill>
+                            <a:srgbClr val="B12A2A"/>
+                          </a:solidFill>
+                        </a:rPr>
+                        <a:t>0.03</a:t>
+                      </a:r>
+                    </a:p>
+                  </a:txBody>
+                  <a:tcPr marT="12700" marB="12700">
+                    <a:solidFill>
+                      <a:srgbClr val="FFFFFF"/>
+                    </a:solidFill>
+                  </a:tcPr>
+                </a:tc>
+              </a:tr>
+              <a:tr h="292608">
+                <a:tc>
+                  <a:txBody>
+                    <a:bodyPr/>
+                    <a:lstStyle/>
+                    <a:p>
+                      <a:pPr algn="ctr"/>
+                      <a:r>
+                        <a:rPr sz="1300" b="0">
+                          <a:solidFill>
+                            <a:srgbClr val="1B2A4A"/>
+                          </a:solidFill>
+                        </a:rPr>
+                        <a:t>32</a:t>
+                      </a:r>
+                    </a:p>
+                  </a:txBody>
+                  <a:tcPr marT="12700" marB="12700">
+                    <a:solidFill>
+                      <a:srgbClr val="FFFFFF"/>
+                    </a:solidFill>
+                  </a:tcPr>
+                </a:tc>
+                <a:tc>
+                  <a:txBody>
+                    <a:bodyPr/>
+                    <a:lstStyle/>
+                    <a:p>
+                      <a:pPr algn="ctr"/>
+                      <a:r>
+                        <a:rPr sz="1300" b="0">
+                          <a:solidFill>
+                            <a:srgbClr val="1B2A4A"/>
+                          </a:solidFill>
+                        </a:rPr>
+                        <a:t>0.64</a:t>
+                      </a:r>
+                    </a:p>
+                  </a:txBody>
+                  <a:tcPr marT="12700" marB="12700">
+                    <a:solidFill>
+                      <a:srgbClr val="FFFFFF"/>
+                    </a:solidFill>
+                  </a:tcPr>
+                </a:tc>
+                <a:tc>
+                  <a:txBody>
+                    <a:bodyPr/>
+                    <a:lstStyle/>
+                    <a:p>
+                      <a:pPr algn="ctr"/>
+                      <a:r>
+                        <a:rPr sz="1300" b="1">
+                          <a:solidFill>
+                            <a:srgbClr val="B12A2A"/>
+                          </a:solidFill>
+                        </a:rPr>
+                        <a:t>0.35</a:t>
+                      </a:r>
+                    </a:p>
+                  </a:txBody>
+                  <a:tcPr marT="12700" marB="12700">
+                    <a:solidFill>
+                      <a:srgbClr val="FFFFFF"/>
+                    </a:solidFill>
+                  </a:tcPr>
+                </a:tc>
+                <a:tc>
+                  <a:txBody>
+                    <a:bodyPr/>
+                    <a:lstStyle/>
+                    <a:p>
+                      <a:pPr algn="ctr"/>
+                      <a:r>
+                        <a:rPr sz="1300" b="0">
+                          <a:solidFill>
+                            <a:srgbClr val="1B2A4A"/>
+                          </a:solidFill>
+                        </a:rPr>
+                        <a:t>0.67</a:t>
+                      </a:r>
+                    </a:p>
+                  </a:txBody>
+                  <a:tcPr marT="12700" marB="12700">
+                    <a:solidFill>
+                      <a:srgbClr val="FFFFFF"/>
+                    </a:solidFill>
+                  </a:tcPr>
+                </a:tc>
+                <a:tc>
+                  <a:txBody>
+                    <a:bodyPr/>
+                    <a:lstStyle/>
+                    <a:p>
+                      <a:pPr algn="ctr"/>
+                      <a:r>
+                        <a:rPr sz="1300" b="1">
+                          <a:solidFill>
+                            <a:srgbClr val="B12A2A"/>
+                          </a:solidFill>
+                        </a:rPr>
+                        <a:t>0.03</a:t>
+                      </a:r>
+                    </a:p>
+                  </a:txBody>
+                  <a:tcPr marT="12700" marB="12700">
+                    <a:solidFill>
+                      <a:srgbClr val="FFFFFF"/>
+                    </a:solidFill>
+                  </a:tcPr>
+                </a:tc>
+              </a:tr>
+              <a:tr h="292608">
+                <a:tc>
+                  <a:txBody>
+                    <a:bodyPr/>
+                    <a:lstStyle/>
+                    <a:p>
+                      <a:pPr algn="ctr"/>
+                      <a:r>
+                        <a:rPr sz="1300" b="0">
+                          <a:solidFill>
+                            <a:srgbClr val="1B2A4A"/>
+                          </a:solidFill>
+                        </a:rPr>
+                        <a:t>48</a:t>
+                      </a:r>
+                    </a:p>
+                  </a:txBody>
+                  <a:tcPr marT="12700" marB="12700">
+                    <a:solidFill>
+                      <a:srgbClr val="FFFFFF"/>
+                    </a:solidFill>
+                  </a:tcPr>
+                </a:tc>
+                <a:tc>
+                  <a:txBody>
+                    <a:bodyPr/>
+                    <a:lstStyle/>
+                    <a:p>
+                      <a:pPr algn="ctr"/>
+                      <a:r>
+                        <a:rPr sz="1300" b="0">
+                          <a:solidFill>
+                            <a:srgbClr val="1B2A4A"/>
+                          </a:solidFill>
+                        </a:rPr>
+                        <a:t>0.64</a:t>
+                      </a:r>
+                    </a:p>
+                  </a:txBody>
+                  <a:tcPr marT="12700" marB="12700">
+                    <a:solidFill>
+                      <a:srgbClr val="FFFFFF"/>
+                    </a:solidFill>
+                  </a:tcPr>
+                </a:tc>
+                <a:tc>
+                  <a:txBody>
+                    <a:bodyPr/>
+                    <a:lstStyle/>
+                    <a:p>
+                      <a:pPr algn="ctr"/>
+                      <a:r>
+                        <a:rPr sz="1300" b="1">
+                          <a:solidFill>
+                            <a:srgbClr val="B12A2A"/>
+                          </a:solidFill>
+                        </a:rPr>
+                        <a:t>0.32</a:t>
+                      </a:r>
+                    </a:p>
+                  </a:txBody>
+                  <a:tcPr marT="12700" marB="12700">
+                    <a:solidFill>
+                      <a:srgbClr val="FFFFFF"/>
+                    </a:solidFill>
+                  </a:tcPr>
+                </a:tc>
+                <a:tc>
+                  <a:txBody>
+                    <a:bodyPr/>
+                    <a:lstStyle/>
+                    <a:p>
+                      <a:pPr algn="ctr"/>
+                      <a:r>
+                        <a:rPr sz="1300" b="0">
+                          <a:solidFill>
+                            <a:srgbClr val="1B2A4A"/>
+                          </a:solidFill>
+                        </a:rPr>
+                        <a:t>0.67</a:t>
+                      </a:r>
+                    </a:p>
+                  </a:txBody>
+                  <a:tcPr marT="12700" marB="12700">
+                    <a:solidFill>
+                      <a:srgbClr val="FFFFFF"/>
+                    </a:solidFill>
+                  </a:tcPr>
+                </a:tc>
+                <a:tc>
+                  <a:txBody>
+                    <a:bodyPr/>
+                    <a:lstStyle/>
+                    <a:p>
+                      <a:pPr algn="ctr"/>
+                      <a:r>
+                        <a:rPr sz="1300" b="1">
+                          <a:solidFill>
+                            <a:srgbClr val="B12A2A"/>
+                          </a:solidFill>
+                        </a:rPr>
+                        <a:t>0.02</a:t>
+                      </a:r>
+                    </a:p>
+                  </a:txBody>
+                  <a:tcPr marT="12700" marB="12700">
+                    <a:solidFill>
+                      <a:srgbClr val="FFFFFF"/>
+                    </a:solidFill>
+                  </a:tcPr>
+                </a:tc>
+              </a:tr>
+            </a:tbl>
+          </a:graphicData>
+        </a:graphic>
+      </p:graphicFrame>
+      <p:sp>
+        <p:nvSpPr>
+          <p:cNvPr id="6" name="TextBox 5"/>
+          <p:cNvSpPr txBox="1"/>
+          <p:nvPr/>
+        </p:nvSpPr>
+        <p:spPr>
+          <a:xfrm>
+            <a:off x="594360" y="5486400"/>
+            <a:ext cx="4754880" cy="320040"/>
+          </a:xfrm>
+          <a:prstGeom prst="rect">
+            <a:avLst/>
+          </a:prstGeom>
+          <a:noFill/>
+        </p:spPr>
+        <p:txBody>
+          <a:bodyPr wrap="none">
+            <a:spAutoFit/>
+          </a:bodyPr>
+          <a:lstStyle/>
+          <a:p>
+            <a:pPr algn="ctr"/>
+            <a:r>
+              <a:rPr sz="1100" b="1">
+                <a:solidFill>
+                  <a:srgbClr val="1B2A4A"/>
+                </a:solidFill>
+              </a:rPr>
+              <a:t>전역 throughput(p/s)·hit (3회 평균)</a:t>
             </a:r>
           </a:p>
         </p:txBody>
       </p:sp>
       <p:pic>
         <p:nvPicPr>
-          <p:cNvPr id="5" name="Picture 4" descr="homo_hetero_throughput.png"/>
+          <p:cNvPr id="7" name="Picture 6" descr="homo_hetero_throughput.png"/>
           <p:cNvPicPr>
             <a:picLocks noChangeAspect="1"/>
           </p:cNvPicPr>
@@ -7915,8 +10196,8 @@
         </p:blipFill>
         <p:spPr>
           <a:xfrm>
-            <a:off x="5486400" y="1554480"/>
-            <a:ext cx="6400800" cy="4336026"/>
+            <a:off x="5669280" y="1600200"/>
+            <a:ext cx="6309360" cy="4274083"/>
           </a:xfrm>
           <a:prstGeom prst="rect">
             <a:avLst/>

</xml_diff>

<commit_message>
F: add p95 latency (tr vs default) - graph + deck table, from existing run data
homo_hetero_*.jsonl already store per-run latency_p95_s (no rerun needed). Aggregated
3-repeat p95: tr beats default across load, gap widens (c48 tr 70.2s vs def 149.0s =
0.47x). Opposite of D (2x4090) where tr lost p95 -> the bigger 5090 converts tr's
pausing into a latency win too. Added figures/homo_hetero_p95.png, p95 panel in
plot_hetero, p95 table on deck slide 9, log F-2. (Also: run_hetero_sweep gained a
--trace load-source option for the pending hetero-hetero sweep.)

Co-Authored-By: Claude Opus 4.8 (1M context) <noreply@anthropic.com>
</commit_message>
<xml_diff>
--- a/meeting_hetero_yunuikang.pptx
+++ b/meeting_hetero_yunuikang.pptx
@@ -9441,7 +9441,7 @@
                   <a:srgbClr val="1B2A4A"/>
                 </a:solidFill>
               </a:rPr>
-              <a:t>F 결과 ① — 이종 4090+5090, 전역: tr이 2배</a:t>
+              <a:t>F 결과 ① — 이종 4090+5090, 전역: tr이 throughput·p95 모두 우세</a:t>
             </a:r>
           </a:p>
         </p:txBody>
@@ -9497,8 +9497,8 @@
         </p:nvSpPr>
         <p:spPr>
           <a:xfrm>
-            <a:off x="502920" y="1234440"/>
-            <a:ext cx="4937760" cy="1463040"/>
+            <a:off x="502920" y="1188720"/>
+            <a:ext cx="5029200" cy="1463040"/>
           </a:xfrm>
           <a:prstGeom prst="rect">
             <a:avLst/>
@@ -9517,7 +9517,7 @@
               </a:spcAft>
             </a:pPr>
             <a:r>
-              <a:rPr sz="1500" b="1">
+              <a:rPr sz="1400" b="1">
                 <a:solidFill>
                   <a:srgbClr val="1B2A4A"/>
                 </a:solidFill>
@@ -9532,12 +9532,12 @@
               </a:spcAft>
             </a:pPr>
             <a:r>
-              <a:rPr sz="1300" b="0">
+              <a:rPr sz="1200" b="0">
                 <a:solidFill>
                   <a:srgbClr val="1E7A3C"/>
                 </a:solidFill>
               </a:rPr>
-              <a:t>고부하 throughput tr≈2×, hit 0.67 vs 0.02</a:t>
+              <a:t>고부하 throughput tr≈2×, hit 0.67 vs 0.02, p95도 tr이 절반 이하(c48 70 vs 149s)</a:t>
             </a:r>
           </a:p>
           <a:p>
@@ -9547,12 +9547,12 @@
               </a:spcAft>
             </a:pPr>
             <a:r>
-              <a:rPr sz="1500" b="1">
+              <a:rPr sz="1400" b="1">
                 <a:solidFill>
                   <a:srgbClr val="1B2A4A"/>
                 </a:solidFill>
               </a:rPr>
-              <a:t>합성에선 이종에서도 tr이 명확히 우세 (실데이터 D와 대조).</a:t>
+              <a:t>합성에선 이종에서도 tr 우세 (실데이터 D와 대조; D는 tr이 p95 열세였음).</a:t>
             </a:r>
           </a:p>
         </p:txBody>
@@ -9566,7 +9566,7 @@
           <p:nvPr/>
         </p:nvGraphicFramePr>
         <p:xfrm>
-          <a:off x="594360" y="2834640"/>
+          <a:off x="548640" y="2697480"/>
           <a:ext cx="4754880" cy="1463040"/>
         </p:xfrm>
         <a:graphic>
@@ -9590,7 +9590,7 @@
                     <a:p>
                       <a:pPr algn="ctr"/>
                       <a:r>
-                        <a:rPr sz="1300" b="1">
+                        <a:rPr sz="1200" b="1">
                           <a:solidFill>
                             <a:srgbClr val="FFFFFF"/>
                           </a:solidFill>
@@ -9612,7 +9612,7 @@
                     <a:p>
                       <a:pPr algn="ctr"/>
                       <a:r>
-                        <a:rPr sz="1300" b="1">
+                        <a:rPr sz="1200" b="1">
                           <a:solidFill>
                             <a:srgbClr val="FFFFFF"/>
                           </a:solidFill>
@@ -9634,7 +9634,7 @@
                     <a:p>
                       <a:pPr algn="ctr"/>
                       <a:r>
-                        <a:rPr sz="1300" b="1">
+                        <a:rPr sz="1200" b="1">
                           <a:solidFill>
                             <a:srgbClr val="FFFFFF"/>
                           </a:solidFill>
@@ -9656,7 +9656,7 @@
                     <a:p>
                       <a:pPr algn="ctr"/>
                       <a:r>
-                        <a:rPr sz="1300" b="1">
+                        <a:rPr sz="1200" b="1">
                           <a:solidFill>
                             <a:srgbClr val="FFFFFF"/>
                           </a:solidFill>
@@ -9678,7 +9678,7 @@
                     <a:p>
                       <a:pPr algn="ctr"/>
                       <a:r>
-                        <a:rPr sz="1300" b="1">
+                        <a:rPr sz="1200" b="1">
                           <a:solidFill>
                             <a:srgbClr val="FFFFFF"/>
                           </a:solidFill>
@@ -9702,7 +9702,7 @@
                     <a:p>
                       <a:pPr algn="ctr"/>
                       <a:r>
-                        <a:rPr sz="1300" b="0">
+                        <a:rPr sz="1200" b="0">
                           <a:solidFill>
                             <a:srgbClr val="1B2A4A"/>
                           </a:solidFill>
@@ -9724,7 +9724,7 @@
                     <a:p>
                       <a:pPr algn="ctr"/>
                       <a:r>
-                        <a:rPr sz="1300" b="0">
+                        <a:rPr sz="1200" b="0">
                           <a:solidFill>
                             <a:srgbClr val="1B2A4A"/>
                           </a:solidFill>
@@ -9746,7 +9746,7 @@
                     <a:p>
                       <a:pPr algn="ctr"/>
                       <a:r>
-                        <a:rPr sz="1300" b="0">
+                        <a:rPr sz="1200" b="0">
                           <a:solidFill>
                             <a:srgbClr val="1B2A4A"/>
                           </a:solidFill>
@@ -9768,7 +9768,7 @@
                     <a:p>
                       <a:pPr algn="ctr"/>
                       <a:r>
-                        <a:rPr sz="1300" b="0">
+                        <a:rPr sz="1200" b="0">
                           <a:solidFill>
                             <a:srgbClr val="1B2A4A"/>
                           </a:solidFill>
@@ -9790,7 +9790,7 @@
                     <a:p>
                       <a:pPr algn="ctr"/>
                       <a:r>
-                        <a:rPr sz="1300" b="0">
+                        <a:rPr sz="1200" b="0">
                           <a:solidFill>
                             <a:srgbClr val="1B2A4A"/>
                           </a:solidFill>
@@ -9814,7 +9814,7 @@
                     <a:p>
                       <a:pPr algn="ctr"/>
                       <a:r>
-                        <a:rPr sz="1300" b="0">
+                        <a:rPr sz="1200" b="0">
                           <a:solidFill>
                             <a:srgbClr val="1B2A4A"/>
                           </a:solidFill>
@@ -9836,7 +9836,7 @@
                     <a:p>
                       <a:pPr algn="ctr"/>
                       <a:r>
-                        <a:rPr sz="1300" b="0">
+                        <a:rPr sz="1200" b="0">
                           <a:solidFill>
                             <a:srgbClr val="1B2A4A"/>
                           </a:solidFill>
@@ -9858,7 +9858,7 @@
                     <a:p>
                       <a:pPr algn="ctr"/>
                       <a:r>
-                        <a:rPr sz="1300" b="1">
+                        <a:rPr sz="1200" b="1">
                           <a:solidFill>
                             <a:srgbClr val="B12A2A"/>
                           </a:solidFill>
@@ -9880,7 +9880,7 @@
                     <a:p>
                       <a:pPr algn="ctr"/>
                       <a:r>
-                        <a:rPr sz="1300" b="0">
+                        <a:rPr sz="1200" b="0">
                           <a:solidFill>
                             <a:srgbClr val="1B2A4A"/>
                           </a:solidFill>
@@ -9902,7 +9902,7 @@
                     <a:p>
                       <a:pPr algn="ctr"/>
                       <a:r>
-                        <a:rPr sz="1300" b="1">
+                        <a:rPr sz="1200" b="1">
                           <a:solidFill>
                             <a:srgbClr val="B12A2A"/>
                           </a:solidFill>
@@ -9926,7 +9926,7 @@
                     <a:p>
                       <a:pPr algn="ctr"/>
                       <a:r>
-                        <a:rPr sz="1300" b="0">
+                        <a:rPr sz="1200" b="0">
                           <a:solidFill>
                             <a:srgbClr val="1B2A4A"/>
                           </a:solidFill>
@@ -9948,7 +9948,7 @@
                     <a:p>
                       <a:pPr algn="ctr"/>
                       <a:r>
-                        <a:rPr sz="1300" b="0">
+                        <a:rPr sz="1200" b="0">
                           <a:solidFill>
                             <a:srgbClr val="1B2A4A"/>
                           </a:solidFill>
@@ -9970,7 +9970,7 @@
                     <a:p>
                       <a:pPr algn="ctr"/>
                       <a:r>
-                        <a:rPr sz="1300" b="1">
+                        <a:rPr sz="1200" b="1">
                           <a:solidFill>
                             <a:srgbClr val="B12A2A"/>
                           </a:solidFill>
@@ -9992,7 +9992,7 @@
                     <a:p>
                       <a:pPr algn="ctr"/>
                       <a:r>
-                        <a:rPr sz="1300" b="0">
+                        <a:rPr sz="1200" b="0">
                           <a:solidFill>
                             <a:srgbClr val="1B2A4A"/>
                           </a:solidFill>
@@ -10014,7 +10014,7 @@
                     <a:p>
                       <a:pPr algn="ctr"/>
                       <a:r>
-                        <a:rPr sz="1300" b="1">
+                        <a:rPr sz="1200" b="1">
                           <a:solidFill>
                             <a:srgbClr val="B12A2A"/>
                           </a:solidFill>
@@ -10038,7 +10038,7 @@
                     <a:p>
                       <a:pPr algn="ctr"/>
                       <a:r>
-                        <a:rPr sz="1300" b="0">
+                        <a:rPr sz="1200" b="0">
                           <a:solidFill>
                             <a:srgbClr val="1B2A4A"/>
                           </a:solidFill>
@@ -10060,7 +10060,7 @@
                     <a:p>
                       <a:pPr algn="ctr"/>
                       <a:r>
-                        <a:rPr sz="1300" b="0">
+                        <a:rPr sz="1200" b="0">
                           <a:solidFill>
                             <a:srgbClr val="1B2A4A"/>
                           </a:solidFill>
@@ -10082,7 +10082,7 @@
                     <a:p>
                       <a:pPr algn="ctr"/>
                       <a:r>
-                        <a:rPr sz="1300" b="1">
+                        <a:rPr sz="1200" b="1">
                           <a:solidFill>
                             <a:srgbClr val="B12A2A"/>
                           </a:solidFill>
@@ -10104,7 +10104,7 @@
                     <a:p>
                       <a:pPr algn="ctr"/>
                       <a:r>
-                        <a:rPr sz="1300" b="0">
+                        <a:rPr sz="1200" b="0">
                           <a:solidFill>
                             <a:srgbClr val="1B2A4A"/>
                           </a:solidFill>
@@ -10126,7 +10126,7 @@
                     <a:p>
                       <a:pPr algn="ctr"/>
                       <a:r>
-                        <a:rPr sz="1300" b="1">
+                        <a:rPr sz="1200" b="1">
                           <a:solidFill>
                             <a:srgbClr val="B12A2A"/>
                           </a:solidFill>
@@ -10146,15 +10146,493 @@
           </a:graphicData>
         </a:graphic>
       </p:graphicFrame>
-      <p:sp>
-        <p:nvSpPr>
-          <p:cNvPr id="6" name="TextBox 5"/>
+      <p:graphicFrame>
+        <p:nvGraphicFramePr>
+          <p:cNvPr id="6" name="Table 5"/>
+          <p:cNvGraphicFramePr>
+            <a:graphicFrameLocks noGrp="1"/>
+          </p:cNvGraphicFramePr>
+          <p:nvPr/>
+        </p:nvGraphicFramePr>
+        <p:xfrm>
+          <a:off x="548640" y="4434840"/>
+          <a:ext cx="4114800" cy="1463040"/>
+        </p:xfrm>
+        <a:graphic>
+          <a:graphicData uri="http://schemas.openxmlformats.org/drawingml/2006/table">
+            <a:tbl>
+              <a:tblPr>
+                <a:tableStyleId>{5C22544A-7EE6-4342-B048-85BDC9FD1C3A}</a:tableStyleId>
+              </a:tblPr>
+              <a:tblGrid>
+                <a:gridCol w="731520"/>
+                <a:gridCol w="1143000"/>
+                <a:gridCol w="1234440"/>
+                <a:gridCol w="1005840"/>
+              </a:tblGrid>
+              <a:tr h="292608">
+                <a:tc>
+                  <a:txBody>
+                    <a:bodyPr/>
+                    <a:lstStyle/>
+                    <a:p>
+                      <a:pPr algn="ctr"/>
+                      <a:r>
+                        <a:rPr sz="1200" b="1">
+                          <a:solidFill>
+                            <a:srgbClr val="FFFFFF"/>
+                          </a:solidFill>
+                        </a:rPr>
+                        <a:t>C</a:t>
+                      </a:r>
+                    </a:p>
+                  </a:txBody>
+                  <a:tcPr marT="12700" marB="12700">
+                    <a:solidFill>
+                      <a:srgbClr val="1B2A4A"/>
+                    </a:solidFill>
+                  </a:tcPr>
+                </a:tc>
+                <a:tc>
+                  <a:txBody>
+                    <a:bodyPr/>
+                    <a:lstStyle/>
+                    <a:p>
+                      <a:pPr algn="ctr"/>
+                      <a:r>
+                        <a:rPr sz="1200" b="1">
+                          <a:solidFill>
+                            <a:srgbClr val="FFFFFF"/>
+                          </a:solidFill>
+                        </a:rPr>
+                        <a:t>p95 tr</a:t>
+                      </a:r>
+                    </a:p>
+                  </a:txBody>
+                  <a:tcPr marT="12700" marB="12700">
+                    <a:solidFill>
+                      <a:srgbClr val="1B2A4A"/>
+                    </a:solidFill>
+                  </a:tcPr>
+                </a:tc>
+                <a:tc>
+                  <a:txBody>
+                    <a:bodyPr/>
+                    <a:lstStyle/>
+                    <a:p>
+                      <a:pPr algn="ctr"/>
+                      <a:r>
+                        <a:rPr sz="1200" b="1">
+                          <a:solidFill>
+                            <a:srgbClr val="FFFFFF"/>
+                          </a:solidFill>
+                        </a:rPr>
+                        <a:t>p95 def</a:t>
+                      </a:r>
+                    </a:p>
+                  </a:txBody>
+                  <a:tcPr marT="12700" marB="12700">
+                    <a:solidFill>
+                      <a:srgbClr val="1B2A4A"/>
+                    </a:solidFill>
+                  </a:tcPr>
+                </a:tc>
+                <a:tc>
+                  <a:txBody>
+                    <a:bodyPr/>
+                    <a:lstStyle/>
+                    <a:p>
+                      <a:pPr algn="ctr"/>
+                      <a:r>
+                        <a:rPr sz="1200" b="1">
+                          <a:solidFill>
+                            <a:srgbClr val="FFFFFF"/>
+                          </a:solidFill>
+                        </a:rPr>
+                        <a:t>tr/def</a:t>
+                      </a:r>
+                    </a:p>
+                  </a:txBody>
+                  <a:tcPr marT="12700" marB="12700">
+                    <a:solidFill>
+                      <a:srgbClr val="1B2A4A"/>
+                    </a:solidFill>
+                  </a:tcPr>
+                </a:tc>
+              </a:tr>
+              <a:tr h="292608">
+                <a:tc>
+                  <a:txBody>
+                    <a:bodyPr/>
+                    <a:lstStyle/>
+                    <a:p>
+                      <a:pPr algn="ctr"/>
+                      <a:r>
+                        <a:rPr sz="1200" b="0">
+                          <a:solidFill>
+                            <a:srgbClr val="1B2A4A"/>
+                          </a:solidFill>
+                        </a:rPr>
+                        <a:t>8</a:t>
+                      </a:r>
+                    </a:p>
+                  </a:txBody>
+                  <a:tcPr marT="12700" marB="12700">
+                    <a:solidFill>
+                      <a:srgbClr val="FFFFFF"/>
+                    </a:solidFill>
+                  </a:tcPr>
+                </a:tc>
+                <a:tc>
+                  <a:txBody>
+                    <a:bodyPr/>
+                    <a:lstStyle/>
+                    <a:p>
+                      <a:pPr algn="ctr"/>
+                      <a:r>
+                        <a:rPr sz="1200" b="0">
+                          <a:solidFill>
+                            <a:srgbClr val="1B2A4A"/>
+                          </a:solidFill>
+                        </a:rPr>
+                        <a:t>20.6s</a:t>
+                      </a:r>
+                    </a:p>
+                  </a:txBody>
+                  <a:tcPr marT="12700" marB="12700">
+                    <a:solidFill>
+                      <a:srgbClr val="FFFFFF"/>
+                    </a:solidFill>
+                  </a:tcPr>
+                </a:tc>
+                <a:tc>
+                  <a:txBody>
+                    <a:bodyPr/>
+                    <a:lstStyle/>
+                    <a:p>
+                      <a:pPr algn="ctr"/>
+                      <a:r>
+                        <a:rPr sz="1200" b="0">
+                          <a:solidFill>
+                            <a:srgbClr val="1B2A4A"/>
+                          </a:solidFill>
+                        </a:rPr>
+                        <a:t>25.7s</a:t>
+                      </a:r>
+                    </a:p>
+                  </a:txBody>
+                  <a:tcPr marT="12700" marB="12700">
+                    <a:solidFill>
+                      <a:srgbClr val="FFFFFF"/>
+                    </a:solidFill>
+                  </a:tcPr>
+                </a:tc>
+                <a:tc>
+                  <a:txBody>
+                    <a:bodyPr/>
+                    <a:lstStyle/>
+                    <a:p>
+                      <a:pPr algn="ctr"/>
+                      <a:r>
+                        <a:rPr sz="1200" b="1">
+                          <a:solidFill>
+                            <a:srgbClr val="B12A2A"/>
+                          </a:solidFill>
+                        </a:rPr>
+                        <a:t>0.80×</a:t>
+                      </a:r>
+                    </a:p>
+                  </a:txBody>
+                  <a:tcPr marT="12700" marB="12700">
+                    <a:solidFill>
+                      <a:srgbClr val="FFFFFF"/>
+                    </a:solidFill>
+                  </a:tcPr>
+                </a:tc>
+              </a:tr>
+              <a:tr h="292608">
+                <a:tc>
+                  <a:txBody>
+                    <a:bodyPr/>
+                    <a:lstStyle/>
+                    <a:p>
+                      <a:pPr algn="ctr"/>
+                      <a:r>
+                        <a:rPr sz="1200" b="0">
+                          <a:solidFill>
+                            <a:srgbClr val="1B2A4A"/>
+                          </a:solidFill>
+                        </a:rPr>
+                        <a:t>16</a:t>
+                      </a:r>
+                    </a:p>
+                  </a:txBody>
+                  <a:tcPr marT="12700" marB="12700">
+                    <a:solidFill>
+                      <a:srgbClr val="FFFFFF"/>
+                    </a:solidFill>
+                  </a:tcPr>
+                </a:tc>
+                <a:tc>
+                  <a:txBody>
+                    <a:bodyPr/>
+                    <a:lstStyle/>
+                    <a:p>
+                      <a:pPr algn="ctr"/>
+                      <a:r>
+                        <a:rPr sz="1200" b="0">
+                          <a:solidFill>
+                            <a:srgbClr val="1B2A4A"/>
+                          </a:solidFill>
+                        </a:rPr>
+                        <a:t>34.9s</a:t>
+                      </a:r>
+                    </a:p>
+                  </a:txBody>
+                  <a:tcPr marT="12700" marB="12700">
+                    <a:solidFill>
+                      <a:srgbClr val="FFFFFF"/>
+                    </a:solidFill>
+                  </a:tcPr>
+                </a:tc>
+                <a:tc>
+                  <a:txBody>
+                    <a:bodyPr/>
+                    <a:lstStyle/>
+                    <a:p>
+                      <a:pPr algn="ctr"/>
+                      <a:r>
+                        <a:rPr sz="1200" b="0">
+                          <a:solidFill>
+                            <a:srgbClr val="1B2A4A"/>
+                          </a:solidFill>
+                        </a:rPr>
+                        <a:t>52.2s</a:t>
+                      </a:r>
+                    </a:p>
+                  </a:txBody>
+                  <a:tcPr marT="12700" marB="12700">
+                    <a:solidFill>
+                      <a:srgbClr val="FFFFFF"/>
+                    </a:solidFill>
+                  </a:tcPr>
+                </a:tc>
+                <a:tc>
+                  <a:txBody>
+                    <a:bodyPr/>
+                    <a:lstStyle/>
+                    <a:p>
+                      <a:pPr algn="ctr"/>
+                      <a:r>
+                        <a:rPr sz="1200" b="1">
+                          <a:solidFill>
+                            <a:srgbClr val="B12A2A"/>
+                          </a:solidFill>
+                        </a:rPr>
+                        <a:t>0.67×</a:t>
+                      </a:r>
+                    </a:p>
+                  </a:txBody>
+                  <a:tcPr marT="12700" marB="12700">
+                    <a:solidFill>
+                      <a:srgbClr val="FFFFFF"/>
+                    </a:solidFill>
+                  </a:tcPr>
+                </a:tc>
+              </a:tr>
+              <a:tr h="292608">
+                <a:tc>
+                  <a:txBody>
+                    <a:bodyPr/>
+                    <a:lstStyle/>
+                    <a:p>
+                      <a:pPr algn="ctr"/>
+                      <a:r>
+                        <a:rPr sz="1200" b="0">
+                          <a:solidFill>
+                            <a:srgbClr val="1B2A4A"/>
+                          </a:solidFill>
+                        </a:rPr>
+                        <a:t>32</a:t>
+                      </a:r>
+                    </a:p>
+                  </a:txBody>
+                  <a:tcPr marT="12700" marB="12700">
+                    <a:solidFill>
+                      <a:srgbClr val="FFFFFF"/>
+                    </a:solidFill>
+                  </a:tcPr>
+                </a:tc>
+                <a:tc>
+                  <a:txBody>
+                    <a:bodyPr/>
+                    <a:lstStyle/>
+                    <a:p>
+                      <a:pPr algn="ctr"/>
+                      <a:r>
+                        <a:rPr sz="1200" b="0">
+                          <a:solidFill>
+                            <a:srgbClr val="1B2A4A"/>
+                          </a:solidFill>
+                        </a:rPr>
+                        <a:t>55.1s</a:t>
+                      </a:r>
+                    </a:p>
+                  </a:txBody>
+                  <a:tcPr marT="12700" marB="12700">
+                    <a:solidFill>
+                      <a:srgbClr val="FFFFFF"/>
+                    </a:solidFill>
+                  </a:tcPr>
+                </a:tc>
+                <a:tc>
+                  <a:txBody>
+                    <a:bodyPr/>
+                    <a:lstStyle/>
+                    <a:p>
+                      <a:pPr algn="ctr"/>
+                      <a:r>
+                        <a:rPr sz="1200" b="0">
+                          <a:solidFill>
+                            <a:srgbClr val="1B2A4A"/>
+                          </a:solidFill>
+                        </a:rPr>
+                        <a:t>99.0s</a:t>
+                      </a:r>
+                    </a:p>
+                  </a:txBody>
+                  <a:tcPr marT="12700" marB="12700">
+                    <a:solidFill>
+                      <a:srgbClr val="FFFFFF"/>
+                    </a:solidFill>
+                  </a:tcPr>
+                </a:tc>
+                <a:tc>
+                  <a:txBody>
+                    <a:bodyPr/>
+                    <a:lstStyle/>
+                    <a:p>
+                      <a:pPr algn="ctr"/>
+                      <a:r>
+                        <a:rPr sz="1200" b="1">
+                          <a:solidFill>
+                            <a:srgbClr val="B12A2A"/>
+                          </a:solidFill>
+                        </a:rPr>
+                        <a:t>0.56×</a:t>
+                      </a:r>
+                    </a:p>
+                  </a:txBody>
+                  <a:tcPr marT="12700" marB="12700">
+                    <a:solidFill>
+                      <a:srgbClr val="FFFFFF"/>
+                    </a:solidFill>
+                  </a:tcPr>
+                </a:tc>
+              </a:tr>
+              <a:tr h="292608">
+                <a:tc>
+                  <a:txBody>
+                    <a:bodyPr/>
+                    <a:lstStyle/>
+                    <a:p>
+                      <a:pPr algn="ctr"/>
+                      <a:r>
+                        <a:rPr sz="1200" b="0">
+                          <a:solidFill>
+                            <a:srgbClr val="1B2A4A"/>
+                          </a:solidFill>
+                        </a:rPr>
+                        <a:t>48</a:t>
+                      </a:r>
+                    </a:p>
+                  </a:txBody>
+                  <a:tcPr marT="12700" marB="12700">
+                    <a:solidFill>
+                      <a:srgbClr val="FFFFFF"/>
+                    </a:solidFill>
+                  </a:tcPr>
+                </a:tc>
+                <a:tc>
+                  <a:txBody>
+                    <a:bodyPr/>
+                    <a:lstStyle/>
+                    <a:p>
+                      <a:pPr algn="ctr"/>
+                      <a:r>
+                        <a:rPr sz="1200" b="0">
+                          <a:solidFill>
+                            <a:srgbClr val="1B2A4A"/>
+                          </a:solidFill>
+                        </a:rPr>
+                        <a:t>70.2s</a:t>
+                      </a:r>
+                    </a:p>
+                  </a:txBody>
+                  <a:tcPr marT="12700" marB="12700">
+                    <a:solidFill>
+                      <a:srgbClr val="FFFFFF"/>
+                    </a:solidFill>
+                  </a:tcPr>
+                </a:tc>
+                <a:tc>
+                  <a:txBody>
+                    <a:bodyPr/>
+                    <a:lstStyle/>
+                    <a:p>
+                      <a:pPr algn="ctr"/>
+                      <a:r>
+                        <a:rPr sz="1200" b="0">
+                          <a:solidFill>
+                            <a:srgbClr val="1B2A4A"/>
+                          </a:solidFill>
+                        </a:rPr>
+                        <a:t>149.0s</a:t>
+                      </a:r>
+                    </a:p>
+                  </a:txBody>
+                  <a:tcPr marT="12700" marB="12700">
+                    <a:solidFill>
+                      <a:srgbClr val="FFFFFF"/>
+                    </a:solidFill>
+                  </a:tcPr>
+                </a:tc>
+                <a:tc>
+                  <a:txBody>
+                    <a:bodyPr/>
+                    <a:lstStyle/>
+                    <a:p>
+                      <a:pPr algn="ctr"/>
+                      <a:r>
+                        <a:rPr sz="1200" b="1">
+                          <a:solidFill>
+                            <a:srgbClr val="B12A2A"/>
+                          </a:solidFill>
+                        </a:rPr>
+                        <a:t>0.47×</a:t>
+                      </a:r>
+                    </a:p>
+                  </a:txBody>
+                  <a:tcPr marT="12700" marB="12700">
+                    <a:solidFill>
+                      <a:srgbClr val="FFFFFF"/>
+                    </a:solidFill>
+                  </a:tcPr>
+                </a:tc>
+              </a:tr>
+            </a:tbl>
+          </a:graphicData>
+        </a:graphic>
+      </p:graphicFrame>
+      <p:sp>
+        <p:nvSpPr>
+          <p:cNvPr id="7" name="TextBox 6"/>
           <p:cNvSpPr txBox="1"/>
           <p:nvPr/>
         </p:nvSpPr>
         <p:spPr>
           <a:xfrm>
-            <a:off x="594360" y="5486400"/>
+            <a:off x="548640" y="6172200"/>
             <a:ext cx="4754880" cy="320040"/>
           </a:xfrm>
           <a:prstGeom prst="rect">
@@ -10175,14 +10653,14 @@
                   <a:srgbClr val="1B2A4A"/>
                 </a:solidFill>
               </a:rPr>
-              <a:t>전역 throughput(p/s)·hit (3회 평균)</a:t>
+              <a:t>위=throughput·hit / 아래=p95 지연 (3회 평균)</a:t>
             </a:r>
           </a:p>
         </p:txBody>
       </p:sp>
       <p:pic>
         <p:nvPicPr>
-          <p:cNvPr id="7" name="Picture 6" descr="homo_hetero_throughput.png"/>
+          <p:cNvPr id="8" name="Picture 7" descr="homo_hetero_throughput.png"/>
           <p:cNvPicPr>
             <a:picLocks noChangeAspect="1"/>
           </p:cNvPicPr>

</xml_diff>

<commit_message>
deck: expand result tables to all concurrency points
Slide 7 (D hit) and 8 (D throughput/p95): C=2,4,8,16,32,48 (full D axis).
Slide 9 (F global): C=8,16,24,32,48 (full F axis, added c=24) as one combined
thru/hit/p95 table. No overflow/overlap.

Co-Authored-By: Claude Opus 4.8 (1M context) <noreply@anthropic.com>
</commit_message>
<xml_diff>
--- a/meeting_hetero_yunuikang.pptx
+++ b/meeting_hetero_yunuikang.pptx
@@ -8180,8 +8180,8 @@
           <p:nvPr/>
         </p:nvGraphicFramePr>
         <p:xfrm>
-          <a:off x="640080" y="2834640"/>
-          <a:ext cx="4206240" cy="1755648"/>
+          <a:off x="640080" y="2788920"/>
+          <a:ext cx="4206240" cy="1920240"/>
         </p:xfrm>
         <a:graphic>
           <a:graphicData uri="http://schemas.openxmlformats.org/drawingml/2006/table">
@@ -8194,15 +8194,15 @@
                 <a:gridCol w="1554480"/>
                 <a:gridCol w="1554480"/>
               </a:tblGrid>
-              <a:tr h="292608">
-                <a:tc>
-                  <a:txBody>
-                    <a:bodyPr/>
-                    <a:lstStyle/>
-                    <a:p>
-                      <a:pPr algn="ctr"/>
-                      <a:r>
-                        <a:rPr sz="1300" b="1">
+              <a:tr h="274320">
+                <a:tc>
+                  <a:txBody>
+                    <a:bodyPr/>
+                    <a:lstStyle/>
+                    <a:p>
+                      <a:pPr algn="ctr"/>
+                      <a:r>
+                        <a:rPr sz="1200" b="1">
                           <a:solidFill>
                             <a:srgbClr val="FFFFFF"/>
                           </a:solidFill>
@@ -8224,7 +8224,7 @@
                     <a:p>
                       <a:pPr algn="ctr"/>
                       <a:r>
-                        <a:rPr sz="1300" b="1">
+                        <a:rPr sz="1200" b="1">
                           <a:solidFill>
                             <a:srgbClr val="FFFFFF"/>
                           </a:solidFill>
@@ -8246,7 +8246,7 @@
                     <a:p>
                       <a:pPr algn="ctr"/>
                       <a:r>
-                        <a:rPr sz="1300" b="1">
+                        <a:rPr sz="1200" b="1">
                           <a:solidFill>
                             <a:srgbClr val="FFFFFF"/>
                           </a:solidFill>
@@ -8262,15 +8262,15 @@
                   </a:tcPr>
                 </a:tc>
               </a:tr>
-              <a:tr h="292608">
-                <a:tc>
-                  <a:txBody>
-                    <a:bodyPr/>
-                    <a:lstStyle/>
-                    <a:p>
-                      <a:pPr algn="ctr"/>
-                      <a:r>
-                        <a:rPr sz="1300" b="0">
+              <a:tr h="274320">
+                <a:tc>
+                  <a:txBody>
+                    <a:bodyPr/>
+                    <a:lstStyle/>
+                    <a:p>
+                      <a:pPr algn="ctr"/>
+                      <a:r>
+                        <a:rPr sz="1200" b="0">
                           <a:solidFill>
                             <a:srgbClr val="1B2A4A"/>
                           </a:solidFill>
@@ -8292,7 +8292,7 @@
                     <a:p>
                       <a:pPr algn="ctr"/>
                       <a:r>
-                        <a:rPr sz="1300" b="0">
+                        <a:rPr sz="1200" b="0">
                           <a:solidFill>
                             <a:srgbClr val="1B2A4A"/>
                           </a:solidFill>
@@ -8314,7 +8314,7 @@
                     <a:p>
                       <a:pPr algn="ctr"/>
                       <a:r>
-                        <a:rPr sz="1300" b="0">
+                        <a:rPr sz="1200" b="0">
                           <a:solidFill>
                             <a:srgbClr val="1B2A4A"/>
                           </a:solidFill>
@@ -8330,19 +8330,87 @@
                   </a:tcPr>
                 </a:tc>
               </a:tr>
-              <a:tr h="292608">
-                <a:tc>
-                  <a:txBody>
-                    <a:bodyPr/>
-                    <a:lstStyle/>
-                    <a:p>
-                      <a:pPr algn="ctr"/>
-                      <a:r>
-                        <a:rPr sz="1300" b="0">
+              <a:tr h="274320">
+                <a:tc>
+                  <a:txBody>
+                    <a:bodyPr/>
+                    <a:lstStyle/>
+                    <a:p>
+                      <a:pPr algn="ctr"/>
+                      <a:r>
+                        <a:rPr sz="1200" b="0">
                           <a:solidFill>
                             <a:srgbClr val="1B2A4A"/>
                           </a:solidFill>
                         </a:rPr>
+                        <a:t>4</a:t>
+                      </a:r>
+                    </a:p>
+                  </a:txBody>
+                  <a:tcPr marT="12700" marB="12700">
+                    <a:solidFill>
+                      <a:srgbClr val="FFFFFF"/>
+                    </a:solidFill>
+                  </a:tcPr>
+                </a:tc>
+                <a:tc>
+                  <a:txBody>
+                    <a:bodyPr/>
+                    <a:lstStyle/>
+                    <a:p>
+                      <a:pPr algn="ctr"/>
+                      <a:r>
+                        <a:rPr sz="1200" b="0">
+                          <a:solidFill>
+                            <a:srgbClr val="1B2A4A"/>
+                          </a:solidFill>
+                        </a:rPr>
+                        <a:t>0.786</a:t>
+                      </a:r>
+                    </a:p>
+                  </a:txBody>
+                  <a:tcPr marT="12700" marB="12700">
+                    <a:solidFill>
+                      <a:srgbClr val="FFFFFF"/>
+                    </a:solidFill>
+                  </a:tcPr>
+                </a:tc>
+                <a:tc>
+                  <a:txBody>
+                    <a:bodyPr/>
+                    <a:lstStyle/>
+                    <a:p>
+                      <a:pPr algn="ctr"/>
+                      <a:r>
+                        <a:rPr sz="1200" b="0">
+                          <a:solidFill>
+                            <a:srgbClr val="1B2A4A"/>
+                          </a:solidFill>
+                        </a:rPr>
+                        <a:t>0.611</a:t>
+                      </a:r>
+                    </a:p>
+                  </a:txBody>
+                  <a:tcPr marT="12700" marB="12700">
+                    <a:solidFill>
+                      <a:srgbClr val="FFFFFF"/>
+                    </a:solidFill>
+                  </a:tcPr>
+                </a:tc>
+              </a:tr>
+              <a:tr h="274320">
+                <a:tc>
+                  <a:txBody>
+                    <a:bodyPr/>
+                    <a:lstStyle/>
+                    <a:p>
+                      <a:pPr algn="ctr"/>
+                      <a:r>
+                        <a:rPr sz="1200" b="0">
+                          <a:solidFill>
+                            <a:srgbClr val="1B2A4A"/>
+                          </a:solidFill>
+                        </a:rPr>
                         <a:t>8</a:t>
                       </a:r>
                     </a:p>
@@ -8360,7 +8428,7 @@
                     <a:p>
                       <a:pPr algn="ctr"/>
                       <a:r>
-                        <a:rPr sz="1300" b="0">
+                        <a:rPr sz="1200" b="0">
                           <a:solidFill>
                             <a:srgbClr val="1B2A4A"/>
                           </a:solidFill>
@@ -8382,7 +8450,7 @@
                     <a:p>
                       <a:pPr algn="ctr"/>
                       <a:r>
-                        <a:rPr sz="1300" b="0">
+                        <a:rPr sz="1200" b="0">
                           <a:solidFill>
                             <a:srgbClr val="1B2A4A"/>
                           </a:solidFill>
@@ -8398,15 +8466,15 @@
                   </a:tcPr>
                 </a:tc>
               </a:tr>
-              <a:tr h="292608">
-                <a:tc>
-                  <a:txBody>
-                    <a:bodyPr/>
-                    <a:lstStyle/>
-                    <a:p>
-                      <a:pPr algn="ctr"/>
-                      <a:r>
-                        <a:rPr sz="1300" b="0">
+              <a:tr h="274320">
+                <a:tc>
+                  <a:txBody>
+                    <a:bodyPr/>
+                    <a:lstStyle/>
+                    <a:p>
+                      <a:pPr algn="ctr"/>
+                      <a:r>
+                        <a:rPr sz="1200" b="0">
                           <a:solidFill>
                             <a:srgbClr val="1B2A4A"/>
                           </a:solidFill>
@@ -8428,7 +8496,7 @@
                     <a:p>
                       <a:pPr algn="ctr"/>
                       <a:r>
-                        <a:rPr sz="1300" b="0">
+                        <a:rPr sz="1200" b="0">
                           <a:solidFill>
                             <a:srgbClr val="1B2A4A"/>
                           </a:solidFill>
@@ -8450,7 +8518,7 @@
                     <a:p>
                       <a:pPr algn="ctr"/>
                       <a:r>
-                        <a:rPr sz="1300" b="1">
+                        <a:rPr sz="1200" b="1">
                           <a:solidFill>
                             <a:srgbClr val="B12A2A"/>
                           </a:solidFill>
@@ -8466,15 +8534,15 @@
                   </a:tcPr>
                 </a:tc>
               </a:tr>
-              <a:tr h="292608">
-                <a:tc>
-                  <a:txBody>
-                    <a:bodyPr/>
-                    <a:lstStyle/>
-                    <a:p>
-                      <a:pPr algn="ctr"/>
-                      <a:r>
-                        <a:rPr sz="1300" b="0">
+              <a:tr h="274320">
+                <a:tc>
+                  <a:txBody>
+                    <a:bodyPr/>
+                    <a:lstStyle/>
+                    <a:p>
+                      <a:pPr algn="ctr"/>
+                      <a:r>
+                        <a:rPr sz="1200" b="0">
                           <a:solidFill>
                             <a:srgbClr val="1B2A4A"/>
                           </a:solidFill>
@@ -8496,7 +8564,7 @@
                     <a:p>
                       <a:pPr algn="ctr"/>
                       <a:r>
-                        <a:rPr sz="1300" b="0">
+                        <a:rPr sz="1200" b="0">
                           <a:solidFill>
                             <a:srgbClr val="1B2A4A"/>
                           </a:solidFill>
@@ -8518,7 +8586,7 @@
                     <a:p>
                       <a:pPr algn="ctr"/>
                       <a:r>
-                        <a:rPr sz="1300" b="1">
+                        <a:rPr sz="1200" b="1">
                           <a:solidFill>
                             <a:srgbClr val="B12A2A"/>
                           </a:solidFill>
@@ -8534,15 +8602,15 @@
                   </a:tcPr>
                 </a:tc>
               </a:tr>
-              <a:tr h="292608">
-                <a:tc>
-                  <a:txBody>
-                    <a:bodyPr/>
-                    <a:lstStyle/>
-                    <a:p>
-                      <a:pPr algn="ctr"/>
-                      <a:r>
-                        <a:rPr sz="1300" b="0">
+              <a:tr h="274320">
+                <a:tc>
+                  <a:txBody>
+                    <a:bodyPr/>
+                    <a:lstStyle/>
+                    <a:p>
+                      <a:pPr algn="ctr"/>
+                      <a:r>
+                        <a:rPr sz="1200" b="0">
                           <a:solidFill>
                             <a:srgbClr val="1B2A4A"/>
                           </a:solidFill>
@@ -8564,7 +8632,7 @@
                     <a:p>
                       <a:pPr algn="ctr"/>
                       <a:r>
-                        <a:rPr sz="1300" b="0">
+                        <a:rPr sz="1200" b="0">
                           <a:solidFill>
                             <a:srgbClr val="1B2A4A"/>
                           </a:solidFill>
@@ -8586,7 +8654,7 @@
                     <a:p>
                       <a:pPr algn="ctr"/>
                       <a:r>
-                        <a:rPr sz="1300" b="1">
+                        <a:rPr sz="1200" b="1">
                           <a:solidFill>
                             <a:srgbClr val="B12A2A"/>
                           </a:solidFill>
@@ -8614,7 +8682,7 @@
         </p:nvSpPr>
         <p:spPr>
           <a:xfrm>
-            <a:off x="640080" y="5532120"/>
+            <a:off x="640080" y="4846320"/>
             <a:ext cx="4206240" cy="320040"/>
           </a:xfrm>
           <a:prstGeom prst="rect">
@@ -8635,7 +8703,7 @@
                   <a:srgbClr val="1B2A4A"/>
                 </a:solidFill>
               </a:rPr>
-              <a:t>KV hit rate (3회 평균)</a:t>
+              <a:t>KV hit rate, C=2~48 (3회 평균)</a:t>
             </a:r>
           </a:p>
         </p:txBody>
@@ -8835,8 +8903,8 @@
           <p:nvPr/>
         </p:nvGraphicFramePr>
         <p:xfrm>
-          <a:off x="548640" y="3200400"/>
-          <a:ext cx="5577840" cy="1170432"/>
+          <a:off x="502920" y="2971800"/>
+          <a:ext cx="5669280" cy="1920240"/>
         </p:xfrm>
         <a:graphic>
           <a:graphicData uri="http://schemas.openxmlformats.org/drawingml/2006/table">
@@ -8845,21 +8913,21 @@
                 <a:tableStyleId>{5C22544A-7EE6-4342-B048-85BDC9FD1C3A}</a:tableStyleId>
               </a:tblPr>
               <a:tblGrid>
-                <a:gridCol w="822960"/>
-                <a:gridCol w="1188720"/>
-                <a:gridCol w="1188720"/>
-                <a:gridCol w="1188720"/>
-                <a:gridCol w="1188720"/>
+                <a:gridCol w="731520"/>
+                <a:gridCol w="1234440"/>
+                <a:gridCol w="1234440"/>
+                <a:gridCol w="1234440"/>
+                <a:gridCol w="1234440"/>
               </a:tblGrid>
-              <a:tr h="292608">
-                <a:tc>
-                  <a:txBody>
-                    <a:bodyPr/>
-                    <a:lstStyle/>
-                    <a:p>
-                      <a:pPr algn="ctr"/>
-                      <a:r>
-                        <a:rPr sz="1300" b="1">
+              <a:tr h="274320">
+                <a:tc>
+                  <a:txBody>
+                    <a:bodyPr/>
+                    <a:lstStyle/>
+                    <a:p>
+                      <a:pPr algn="ctr"/>
+                      <a:r>
+                        <a:rPr sz="1200" b="1">
                           <a:solidFill>
                             <a:srgbClr val="FFFFFF"/>
                           </a:solidFill>
@@ -8881,7 +8949,7 @@
                     <a:p>
                       <a:pPr algn="ctr"/>
                       <a:r>
-                        <a:rPr sz="1300" b="1">
+                        <a:rPr sz="1200" b="1">
                           <a:solidFill>
                             <a:srgbClr val="FFFFFF"/>
                           </a:solidFill>
@@ -8903,7 +8971,7 @@
                     <a:p>
                       <a:pPr algn="ctr"/>
                       <a:r>
-                        <a:rPr sz="1300" b="1">
+                        <a:rPr sz="1200" b="1">
                           <a:solidFill>
                             <a:srgbClr val="FFFFFF"/>
                           </a:solidFill>
@@ -8925,7 +8993,7 @@
                     <a:p>
                       <a:pPr algn="ctr"/>
                       <a:r>
-                        <a:rPr sz="1300" b="1">
+                        <a:rPr sz="1200" b="1">
                           <a:solidFill>
                             <a:srgbClr val="FFFFFF"/>
                           </a:solidFill>
@@ -8947,7 +9015,7 @@
                     <a:p>
                       <a:pPr algn="ctr"/>
                       <a:r>
-                        <a:rPr sz="1300" b="1">
+                        <a:rPr sz="1200" b="1">
                           <a:solidFill>
                             <a:srgbClr val="FFFFFF"/>
                           </a:solidFill>
@@ -8963,19 +9031,243 @@
                   </a:tcPr>
                 </a:tc>
               </a:tr>
-              <a:tr h="292608">
-                <a:tc>
-                  <a:txBody>
-                    <a:bodyPr/>
-                    <a:lstStyle/>
-                    <a:p>
-                      <a:pPr algn="ctr"/>
-                      <a:r>
-                        <a:rPr sz="1300" b="0">
+              <a:tr h="274320">
+                <a:tc>
+                  <a:txBody>
+                    <a:bodyPr/>
+                    <a:lstStyle/>
+                    <a:p>
+                      <a:pPr algn="ctr"/>
+                      <a:r>
+                        <a:rPr sz="1200" b="0">
                           <a:solidFill>
                             <a:srgbClr val="1B2A4A"/>
                           </a:solidFill>
                         </a:rPr>
+                        <a:t>2</a:t>
+                      </a:r>
+                    </a:p>
+                  </a:txBody>
+                  <a:tcPr marT="12700" marB="12700">
+                    <a:solidFill>
+                      <a:srgbClr val="FFFFFF"/>
+                    </a:solidFill>
+                  </a:tcPr>
+                </a:tc>
+                <a:tc>
+                  <a:txBody>
+                    <a:bodyPr/>
+                    <a:lstStyle/>
+                    <a:p>
+                      <a:pPr algn="ctr"/>
+                      <a:r>
+                        <a:rPr sz="1200" b="0">
+                          <a:solidFill>
+                            <a:srgbClr val="1B2A4A"/>
+                          </a:solidFill>
+                        </a:rPr>
+                        <a:t>0.048</a:t>
+                      </a:r>
+                    </a:p>
+                  </a:txBody>
+                  <a:tcPr marT="12700" marB="12700">
+                    <a:solidFill>
+                      <a:srgbClr val="FFFFFF"/>
+                    </a:solidFill>
+                  </a:tcPr>
+                </a:tc>
+                <a:tc>
+                  <a:txBody>
+                    <a:bodyPr/>
+                    <a:lstStyle/>
+                    <a:p>
+                      <a:pPr algn="ctr"/>
+                      <a:r>
+                        <a:rPr sz="1200" b="0">
+                          <a:solidFill>
+                            <a:srgbClr val="1B2A4A"/>
+                          </a:solidFill>
+                        </a:rPr>
+                        <a:t>0.048</a:t>
+                      </a:r>
+                    </a:p>
+                  </a:txBody>
+                  <a:tcPr marT="12700" marB="12700">
+                    <a:solidFill>
+                      <a:srgbClr val="FFFFFF"/>
+                    </a:solidFill>
+                  </a:tcPr>
+                </a:tc>
+                <a:tc>
+                  <a:txBody>
+                    <a:bodyPr/>
+                    <a:lstStyle/>
+                    <a:p>
+                      <a:pPr algn="ctr"/>
+                      <a:r>
+                        <a:rPr sz="1200" b="0">
+                          <a:solidFill>
+                            <a:srgbClr val="1B2A4A"/>
+                          </a:solidFill>
+                        </a:rPr>
+                        <a:t>110s</a:t>
+                      </a:r>
+                    </a:p>
+                  </a:txBody>
+                  <a:tcPr marT="12700" marB="12700">
+                    <a:solidFill>
+                      <a:srgbClr val="FFFFFF"/>
+                    </a:solidFill>
+                  </a:tcPr>
+                </a:tc>
+                <a:tc>
+                  <a:txBody>
+                    <a:bodyPr/>
+                    <a:lstStyle/>
+                    <a:p>
+                      <a:pPr algn="ctr"/>
+                      <a:r>
+                        <a:rPr sz="1200" b="0">
+                          <a:solidFill>
+                            <a:srgbClr val="1B2A4A"/>
+                          </a:solidFill>
+                        </a:rPr>
+                        <a:t>110s</a:t>
+                      </a:r>
+                    </a:p>
+                  </a:txBody>
+                  <a:tcPr marT="12700" marB="12700">
+                    <a:solidFill>
+                      <a:srgbClr val="FFFFFF"/>
+                    </a:solidFill>
+                  </a:tcPr>
+                </a:tc>
+              </a:tr>
+              <a:tr h="274320">
+                <a:tc>
+                  <a:txBody>
+                    <a:bodyPr/>
+                    <a:lstStyle/>
+                    <a:p>
+                      <a:pPr algn="ctr"/>
+                      <a:r>
+                        <a:rPr sz="1200" b="0">
+                          <a:solidFill>
+                            <a:srgbClr val="1B2A4A"/>
+                          </a:solidFill>
+                        </a:rPr>
+                        <a:t>4</a:t>
+                      </a:r>
+                    </a:p>
+                  </a:txBody>
+                  <a:tcPr marT="12700" marB="12700">
+                    <a:solidFill>
+                      <a:srgbClr val="FFFFFF"/>
+                    </a:solidFill>
+                  </a:tcPr>
+                </a:tc>
+                <a:tc>
+                  <a:txBody>
+                    <a:bodyPr/>
+                    <a:lstStyle/>
+                    <a:p>
+                      <a:pPr algn="ctr"/>
+                      <a:r>
+                        <a:rPr sz="1200" b="0">
+                          <a:solidFill>
+                            <a:srgbClr val="1B2A4A"/>
+                          </a:solidFill>
+                        </a:rPr>
+                        <a:t>0.084</a:t>
+                      </a:r>
+                    </a:p>
+                  </a:txBody>
+                  <a:tcPr marT="12700" marB="12700">
+                    <a:solidFill>
+                      <a:srgbClr val="FFFFFF"/>
+                    </a:solidFill>
+                  </a:tcPr>
+                </a:tc>
+                <a:tc>
+                  <a:txBody>
+                    <a:bodyPr/>
+                    <a:lstStyle/>
+                    <a:p>
+                      <a:pPr algn="ctr"/>
+                      <a:r>
+                        <a:rPr sz="1200" b="0">
+                          <a:solidFill>
+                            <a:srgbClr val="1B2A4A"/>
+                          </a:solidFill>
+                        </a:rPr>
+                        <a:t>0.093</a:t>
+                      </a:r>
+                    </a:p>
+                  </a:txBody>
+                  <a:tcPr marT="12700" marB="12700">
+                    <a:solidFill>
+                      <a:srgbClr val="FFFFFF"/>
+                    </a:solidFill>
+                  </a:tcPr>
+                </a:tc>
+                <a:tc>
+                  <a:txBody>
+                    <a:bodyPr/>
+                    <a:lstStyle/>
+                    <a:p>
+                      <a:pPr algn="ctr"/>
+                      <a:r>
+                        <a:rPr sz="1200" b="0">
+                          <a:solidFill>
+                            <a:srgbClr val="1B2A4A"/>
+                          </a:solidFill>
+                        </a:rPr>
+                        <a:t>132s</a:t>
+                      </a:r>
+                    </a:p>
+                  </a:txBody>
+                  <a:tcPr marT="12700" marB="12700">
+                    <a:solidFill>
+                      <a:srgbClr val="FFFFFF"/>
+                    </a:solidFill>
+                  </a:tcPr>
+                </a:tc>
+                <a:tc>
+                  <a:txBody>
+                    <a:bodyPr/>
+                    <a:lstStyle/>
+                    <a:p>
+                      <a:pPr algn="ctr"/>
+                      <a:r>
+                        <a:rPr sz="1200" b="0">
+                          <a:solidFill>
+                            <a:srgbClr val="1B2A4A"/>
+                          </a:solidFill>
+                        </a:rPr>
+                        <a:t>113s</a:t>
+                      </a:r>
+                    </a:p>
+                  </a:txBody>
+                  <a:tcPr marT="12700" marB="12700">
+                    <a:solidFill>
+                      <a:srgbClr val="FFFFFF"/>
+                    </a:solidFill>
+                  </a:tcPr>
+                </a:tc>
+              </a:tr>
+              <a:tr h="274320">
+                <a:tc>
+                  <a:txBody>
+                    <a:bodyPr/>
+                    <a:lstStyle/>
+                    <a:p>
+                      <a:pPr algn="ctr"/>
+                      <a:r>
+                        <a:rPr sz="1200" b="0">
+                          <a:solidFill>
+                            <a:srgbClr val="1B2A4A"/>
+                          </a:solidFill>
+                        </a:rPr>
                         <a:t>8</a:t>
                       </a:r>
                     </a:p>
@@ -8993,7 +9285,7 @@
                     <a:p>
                       <a:pPr algn="ctr"/>
                       <a:r>
-                        <a:rPr sz="1300" b="1">
+                        <a:rPr sz="1200" b="1">
                           <a:solidFill>
                             <a:srgbClr val="B12A2A"/>
                           </a:solidFill>
@@ -9015,7 +9307,7 @@
                     <a:p>
                       <a:pPr algn="ctr"/>
                       <a:r>
-                        <a:rPr sz="1300" b="0">
+                        <a:rPr sz="1200" b="0">
                           <a:solidFill>
                             <a:srgbClr val="1B2A4A"/>
                           </a:solidFill>
@@ -9037,7 +9329,7 @@
                     <a:p>
                       <a:pPr algn="ctr"/>
                       <a:r>
-                        <a:rPr sz="1300" b="1">
+                        <a:rPr sz="1200" b="1">
                           <a:solidFill>
                             <a:srgbClr val="B12A2A"/>
                           </a:solidFill>
@@ -9059,7 +9351,7 @@
                     <a:p>
                       <a:pPr algn="ctr"/>
                       <a:r>
-                        <a:rPr sz="1300" b="0">
+                        <a:rPr sz="1200" b="0">
                           <a:solidFill>
                             <a:srgbClr val="1B2A4A"/>
                           </a:solidFill>
@@ -9075,15 +9367,15 @@
                   </a:tcPr>
                 </a:tc>
               </a:tr>
-              <a:tr h="292608">
-                <a:tc>
-                  <a:txBody>
-                    <a:bodyPr/>
-                    <a:lstStyle/>
-                    <a:p>
-                      <a:pPr algn="ctr"/>
-                      <a:r>
-                        <a:rPr sz="1300" b="0">
+              <a:tr h="274320">
+                <a:tc>
+                  <a:txBody>
+                    <a:bodyPr/>
+                    <a:lstStyle/>
+                    <a:p>
+                      <a:pPr algn="ctr"/>
+                      <a:r>
+                        <a:rPr sz="1200" b="0">
                           <a:solidFill>
                             <a:srgbClr val="1B2A4A"/>
                           </a:solidFill>
@@ -9105,7 +9397,7 @@
                     <a:p>
                       <a:pPr algn="ctr"/>
                       <a:r>
-                        <a:rPr sz="1300" b="1">
+                        <a:rPr sz="1200" b="1">
                           <a:solidFill>
                             <a:srgbClr val="B12A2A"/>
                           </a:solidFill>
@@ -9127,7 +9419,7 @@
                     <a:p>
                       <a:pPr algn="ctr"/>
                       <a:r>
-                        <a:rPr sz="1300" b="0">
+                        <a:rPr sz="1200" b="0">
                           <a:solidFill>
                             <a:srgbClr val="1B2A4A"/>
                           </a:solidFill>
@@ -9149,7 +9441,7 @@
                     <a:p>
                       <a:pPr algn="ctr"/>
                       <a:r>
-                        <a:rPr sz="1300" b="1">
+                        <a:rPr sz="1200" b="1">
                           <a:solidFill>
                             <a:srgbClr val="B12A2A"/>
                           </a:solidFill>
@@ -9171,7 +9463,7 @@
                     <a:p>
                       <a:pPr algn="ctr"/>
                       <a:r>
-                        <a:rPr sz="1300" b="0">
+                        <a:rPr sz="1200" b="0">
                           <a:solidFill>
                             <a:srgbClr val="1B2A4A"/>
                           </a:solidFill>
@@ -9187,19 +9479,131 @@
                   </a:tcPr>
                 </a:tc>
               </a:tr>
-              <a:tr h="292608">
-                <a:tc>
-                  <a:txBody>
-                    <a:bodyPr/>
-                    <a:lstStyle/>
-                    <a:p>
-                      <a:pPr algn="ctr"/>
-                      <a:r>
-                        <a:rPr sz="1300" b="0">
+              <a:tr h="274320">
+                <a:tc>
+                  <a:txBody>
+                    <a:bodyPr/>
+                    <a:lstStyle/>
+                    <a:p>
+                      <a:pPr algn="ctr"/>
+                      <a:r>
+                        <a:rPr sz="1200" b="0">
                           <a:solidFill>
                             <a:srgbClr val="1B2A4A"/>
                           </a:solidFill>
                         </a:rPr>
+                        <a:t>32</a:t>
+                      </a:r>
+                    </a:p>
+                  </a:txBody>
+                  <a:tcPr marT="12700" marB="12700">
+                    <a:solidFill>
+                      <a:srgbClr val="FFFFFF"/>
+                    </a:solidFill>
+                  </a:tcPr>
+                </a:tc>
+                <a:tc>
+                  <a:txBody>
+                    <a:bodyPr/>
+                    <a:lstStyle/>
+                    <a:p>
+                      <a:pPr algn="ctr"/>
+                      <a:r>
+                        <a:rPr sz="1200" b="1">
+                          <a:solidFill>
+                            <a:srgbClr val="B12A2A"/>
+                          </a:solidFill>
+                        </a:rPr>
+                        <a:t>0.069</a:t>
+                      </a:r>
+                    </a:p>
+                  </a:txBody>
+                  <a:tcPr marT="12700" marB="12700">
+                    <a:solidFill>
+                      <a:srgbClr val="FFFFFF"/>
+                    </a:solidFill>
+                  </a:tcPr>
+                </a:tc>
+                <a:tc>
+                  <a:txBody>
+                    <a:bodyPr/>
+                    <a:lstStyle/>
+                    <a:p>
+                      <a:pPr algn="ctr"/>
+                      <a:r>
+                        <a:rPr sz="1200" b="0">
+                          <a:solidFill>
+                            <a:srgbClr val="1B2A4A"/>
+                          </a:solidFill>
+                        </a:rPr>
+                        <a:t>0.108</a:t>
+                      </a:r>
+                    </a:p>
+                  </a:txBody>
+                  <a:tcPr marT="12700" marB="12700">
+                    <a:solidFill>
+                      <a:srgbClr val="FFFFFF"/>
+                    </a:solidFill>
+                  </a:tcPr>
+                </a:tc>
+                <a:tc>
+                  <a:txBody>
+                    <a:bodyPr/>
+                    <a:lstStyle/>
+                    <a:p>
+                      <a:pPr algn="ctr"/>
+                      <a:r>
+                        <a:rPr sz="1200" b="1">
+                          <a:solidFill>
+                            <a:srgbClr val="B12A2A"/>
+                          </a:solidFill>
+                        </a:rPr>
+                        <a:t>660s</a:t>
+                      </a:r>
+                    </a:p>
+                  </a:txBody>
+                  <a:tcPr marT="12700" marB="12700">
+                    <a:solidFill>
+                      <a:srgbClr val="FFFFFF"/>
+                    </a:solidFill>
+                  </a:tcPr>
+                </a:tc>
+                <a:tc>
+                  <a:txBody>
+                    <a:bodyPr/>
+                    <a:lstStyle/>
+                    <a:p>
+                      <a:pPr algn="ctr"/>
+                      <a:r>
+                        <a:rPr sz="1200" b="0">
+                          <a:solidFill>
+                            <a:srgbClr val="1B2A4A"/>
+                          </a:solidFill>
+                        </a:rPr>
+                        <a:t>418s</a:t>
+                      </a:r>
+                    </a:p>
+                  </a:txBody>
+                  <a:tcPr marT="12700" marB="12700">
+                    <a:solidFill>
+                      <a:srgbClr val="FFFFFF"/>
+                    </a:solidFill>
+                  </a:tcPr>
+                </a:tc>
+              </a:tr>
+              <a:tr h="274320">
+                <a:tc>
+                  <a:txBody>
+                    <a:bodyPr/>
+                    <a:lstStyle/>
+                    <a:p>
+                      <a:pPr algn="ctr"/>
+                      <a:r>
+                        <a:rPr sz="1200" b="0">
+                          <a:solidFill>
+                            <a:srgbClr val="1B2A4A"/>
+                          </a:solidFill>
+                        </a:rPr>
                         <a:t>48</a:t>
                       </a:r>
                     </a:p>
@@ -9217,7 +9621,7 @@
                     <a:p>
                       <a:pPr algn="ctr"/>
                       <a:r>
-                        <a:rPr sz="1300" b="1">
+                        <a:rPr sz="1200" b="1">
                           <a:solidFill>
                             <a:srgbClr val="B12A2A"/>
                           </a:solidFill>
@@ -9239,7 +9643,7 @@
                     <a:p>
                       <a:pPr algn="ctr"/>
                       <a:r>
-                        <a:rPr sz="1300" b="0">
+                        <a:rPr sz="1200" b="0">
                           <a:solidFill>
                             <a:srgbClr val="1B2A4A"/>
                           </a:solidFill>
@@ -9261,7 +9665,7 @@
                     <a:p>
                       <a:pPr algn="ctr"/>
                       <a:r>
-                        <a:rPr sz="1300" b="1">
+                        <a:rPr sz="1200" b="1">
                           <a:solidFill>
                             <a:srgbClr val="B12A2A"/>
                           </a:solidFill>
@@ -9283,7 +9687,7 @@
                     <a:p>
                       <a:pPr algn="ctr"/>
                       <a:r>
-                        <a:rPr sz="1300" b="0">
+                        <a:rPr sz="1200" b="0">
                           <a:solidFill>
                             <a:srgbClr val="1B2A4A"/>
                           </a:solidFill>
@@ -9311,8 +9715,8 @@
         </p:nvSpPr>
         <p:spPr>
           <a:xfrm>
-            <a:off x="548640" y="5074920"/>
-            <a:ext cx="5577840" cy="320040"/>
+            <a:off x="502920" y="5120640"/>
+            <a:ext cx="5669280" cy="320040"/>
           </a:xfrm>
           <a:prstGeom prst="rect">
             <a:avLst/>
@@ -9332,7 +9736,7 @@
                   <a:srgbClr val="1B2A4A"/>
                 </a:solidFill>
               </a:rPr>
-              <a:t>throughput(p/s)·p95 — tr(빨강)이 열세</a:t>
+              <a:t>throughput(p/s)·p95, C=2~48 — tr(빨강)이 열세</a:t>
             </a:r>
           </a:p>
         </p:txBody>
@@ -9498,7 +9902,7 @@
         <p:spPr>
           <a:xfrm>
             <a:off x="502920" y="1188720"/>
-            <a:ext cx="5029200" cy="1463040"/>
+            <a:ext cx="5760720" cy="1737360"/>
           </a:xfrm>
           <a:prstGeom prst="rect">
             <a:avLst/>
@@ -9522,7 +9926,7 @@
                   <a:srgbClr val="1B2A4A"/>
                 </a:solidFill>
               </a:rPr>
-              <a:t>합성 KV-압박 워크로드, 4090+5090</a:t>
+              <a:t>합성 KV-압박 워크로드, 4090+5090 (F의 concurrency 축 = 8·16·24·32·48)</a:t>
             </a:r>
           </a:p>
           <a:p>
@@ -9557,1110 +9961,9 @@
           </a:p>
         </p:txBody>
       </p:sp>
-      <p:graphicFrame>
-        <p:nvGraphicFramePr>
-          <p:cNvPr id="5" name="Table 4"/>
-          <p:cNvGraphicFramePr>
-            <a:graphicFrameLocks noGrp="1"/>
-          </p:cNvGraphicFramePr>
-          <p:nvPr/>
-        </p:nvGraphicFramePr>
-        <p:xfrm>
-          <a:off x="548640" y="2697480"/>
-          <a:ext cx="4754880" cy="1463040"/>
-        </p:xfrm>
-        <a:graphic>
-          <a:graphicData uri="http://schemas.openxmlformats.org/drawingml/2006/table">
-            <a:tbl>
-              <a:tblPr>
-                <a:tableStyleId>{5C22544A-7EE6-4342-B048-85BDC9FD1C3A}</a:tableStyleId>
-              </a:tblPr>
-              <a:tblGrid>
-                <a:gridCol w="731520"/>
-                <a:gridCol w="1051560"/>
-                <a:gridCol w="1051560"/>
-                <a:gridCol w="960120"/>
-                <a:gridCol w="960120"/>
-              </a:tblGrid>
-              <a:tr h="292608">
-                <a:tc>
-                  <a:txBody>
-                    <a:bodyPr/>
-                    <a:lstStyle/>
-                    <a:p>
-                      <a:pPr algn="ctr"/>
-                      <a:r>
-                        <a:rPr sz="1200" b="1">
-                          <a:solidFill>
-                            <a:srgbClr val="FFFFFF"/>
-                          </a:solidFill>
-                        </a:rPr>
-                        <a:t>C</a:t>
-                      </a:r>
-                    </a:p>
-                  </a:txBody>
-                  <a:tcPr marT="12700" marB="12700">
-                    <a:solidFill>
-                      <a:srgbClr val="1B2A4A"/>
-                    </a:solidFill>
-                  </a:tcPr>
-                </a:tc>
-                <a:tc>
-                  <a:txBody>
-                    <a:bodyPr/>
-                    <a:lstStyle/>
-                    <a:p>
-                      <a:pPr algn="ctr"/>
-                      <a:r>
-                        <a:rPr sz="1200" b="1">
-                          <a:solidFill>
-                            <a:srgbClr val="FFFFFF"/>
-                          </a:solidFill>
-                        </a:rPr>
-                        <a:t>thru tr</a:t>
-                      </a:r>
-                    </a:p>
-                  </a:txBody>
-                  <a:tcPr marT="12700" marB="12700">
-                    <a:solidFill>
-                      <a:srgbClr val="1B2A4A"/>
-                    </a:solidFill>
-                  </a:tcPr>
-                </a:tc>
-                <a:tc>
-                  <a:txBody>
-                    <a:bodyPr/>
-                    <a:lstStyle/>
-                    <a:p>
-                      <a:pPr algn="ctr"/>
-                      <a:r>
-                        <a:rPr sz="1200" b="1">
-                          <a:solidFill>
-                            <a:srgbClr val="FFFFFF"/>
-                          </a:solidFill>
-                        </a:rPr>
-                        <a:t>thru def</a:t>
-                      </a:r>
-                    </a:p>
-                  </a:txBody>
-                  <a:tcPr marT="12700" marB="12700">
-                    <a:solidFill>
-                      <a:srgbClr val="1B2A4A"/>
-                    </a:solidFill>
-                  </a:tcPr>
-                </a:tc>
-                <a:tc>
-                  <a:txBody>
-                    <a:bodyPr/>
-                    <a:lstStyle/>
-                    <a:p>
-                      <a:pPr algn="ctr"/>
-                      <a:r>
-                        <a:rPr sz="1200" b="1">
-                          <a:solidFill>
-                            <a:srgbClr val="FFFFFF"/>
-                          </a:solidFill>
-                        </a:rPr>
-                        <a:t>hit tr</a:t>
-                      </a:r>
-                    </a:p>
-                  </a:txBody>
-                  <a:tcPr marT="12700" marB="12700">
-                    <a:solidFill>
-                      <a:srgbClr val="1B2A4A"/>
-                    </a:solidFill>
-                  </a:tcPr>
-                </a:tc>
-                <a:tc>
-                  <a:txBody>
-                    <a:bodyPr/>
-                    <a:lstStyle/>
-                    <a:p>
-                      <a:pPr algn="ctr"/>
-                      <a:r>
-                        <a:rPr sz="1200" b="1">
-                          <a:solidFill>
-                            <a:srgbClr val="FFFFFF"/>
-                          </a:solidFill>
-                        </a:rPr>
-                        <a:t>hit def</a:t>
-                      </a:r>
-                    </a:p>
-                  </a:txBody>
-                  <a:tcPr marT="12700" marB="12700">
-                    <a:solidFill>
-                      <a:srgbClr val="1B2A4A"/>
-                    </a:solidFill>
-                  </a:tcPr>
-                </a:tc>
-              </a:tr>
-              <a:tr h="292608">
-                <a:tc>
-                  <a:txBody>
-                    <a:bodyPr/>
-                    <a:lstStyle/>
-                    <a:p>
-                      <a:pPr algn="ctr"/>
-                      <a:r>
-                        <a:rPr sz="1200" b="0">
-                          <a:solidFill>
-                            <a:srgbClr val="1B2A4A"/>
-                          </a:solidFill>
-                        </a:rPr>
-                        <a:t>8</a:t>
-                      </a:r>
-                    </a:p>
-                  </a:txBody>
-                  <a:tcPr marT="12700" marB="12700">
-                    <a:solidFill>
-                      <a:srgbClr val="FFFFFF"/>
-                    </a:solidFill>
-                  </a:tcPr>
-                </a:tc>
-                <a:tc>
-                  <a:txBody>
-                    <a:bodyPr/>
-                    <a:lstStyle/>
-                    <a:p>
-                      <a:pPr algn="ctr"/>
-                      <a:r>
-                        <a:rPr sz="1200" b="0">
-                          <a:solidFill>
-                            <a:srgbClr val="1B2A4A"/>
-                          </a:solidFill>
-                        </a:rPr>
-                        <a:t>0.67</a:t>
-                      </a:r>
-                    </a:p>
-                  </a:txBody>
-                  <a:tcPr marT="12700" marB="12700">
-                    <a:solidFill>
-                      <a:srgbClr val="FFFFFF"/>
-                    </a:solidFill>
-                  </a:tcPr>
-                </a:tc>
-                <a:tc>
-                  <a:txBody>
-                    <a:bodyPr/>
-                    <a:lstStyle/>
-                    <a:p>
-                      <a:pPr algn="ctr"/>
-                      <a:r>
-                        <a:rPr sz="1200" b="0">
-                          <a:solidFill>
-                            <a:srgbClr val="1B2A4A"/>
-                          </a:solidFill>
-                        </a:rPr>
-                        <a:t>0.62</a:t>
-                      </a:r>
-                    </a:p>
-                  </a:txBody>
-                  <a:tcPr marT="12700" marB="12700">
-                    <a:solidFill>
-                      <a:srgbClr val="FFFFFF"/>
-                    </a:solidFill>
-                  </a:tcPr>
-                </a:tc>
-                <a:tc>
-                  <a:txBody>
-                    <a:bodyPr/>
-                    <a:lstStyle/>
-                    <a:p>
-                      <a:pPr algn="ctr"/>
-                      <a:r>
-                        <a:rPr sz="1200" b="0">
-                          <a:solidFill>
-                            <a:srgbClr val="1B2A4A"/>
-                          </a:solidFill>
-                        </a:rPr>
-                        <a:t>0.56</a:t>
-                      </a:r>
-                    </a:p>
-                  </a:txBody>
-                  <a:tcPr marT="12700" marB="12700">
-                    <a:solidFill>
-                      <a:srgbClr val="FFFFFF"/>
-                    </a:solidFill>
-                  </a:tcPr>
-                </a:tc>
-                <a:tc>
-                  <a:txBody>
-                    <a:bodyPr/>
-                    <a:lstStyle/>
-                    <a:p>
-                      <a:pPr algn="ctr"/>
-                      <a:r>
-                        <a:rPr sz="1200" b="0">
-                          <a:solidFill>
-                            <a:srgbClr val="1B2A4A"/>
-                          </a:solidFill>
-                        </a:rPr>
-                        <a:t>0.23</a:t>
-                      </a:r>
-                    </a:p>
-                  </a:txBody>
-                  <a:tcPr marT="12700" marB="12700">
-                    <a:solidFill>
-                      <a:srgbClr val="FFFFFF"/>
-                    </a:solidFill>
-                  </a:tcPr>
-                </a:tc>
-              </a:tr>
-              <a:tr h="292608">
-                <a:tc>
-                  <a:txBody>
-                    <a:bodyPr/>
-                    <a:lstStyle/>
-                    <a:p>
-                      <a:pPr algn="ctr"/>
-                      <a:r>
-                        <a:rPr sz="1200" b="0">
-                          <a:solidFill>
-                            <a:srgbClr val="1B2A4A"/>
-                          </a:solidFill>
-                        </a:rPr>
-                        <a:t>16</a:t>
-                      </a:r>
-                    </a:p>
-                  </a:txBody>
-                  <a:tcPr marT="12700" marB="12700">
-                    <a:solidFill>
-                      <a:srgbClr val="FFFFFF"/>
-                    </a:solidFill>
-                  </a:tcPr>
-                </a:tc>
-                <a:tc>
-                  <a:txBody>
-                    <a:bodyPr/>
-                    <a:lstStyle/>
-                    <a:p>
-                      <a:pPr algn="ctr"/>
-                      <a:r>
-                        <a:rPr sz="1200" b="0">
-                          <a:solidFill>
-                            <a:srgbClr val="1B2A4A"/>
-                          </a:solidFill>
-                        </a:rPr>
-                        <a:t>0.64</a:t>
-                      </a:r>
-                    </a:p>
-                  </a:txBody>
-                  <a:tcPr marT="12700" marB="12700">
-                    <a:solidFill>
-                      <a:srgbClr val="FFFFFF"/>
-                    </a:solidFill>
-                  </a:tcPr>
-                </a:tc>
-                <a:tc>
-                  <a:txBody>
-                    <a:bodyPr/>
-                    <a:lstStyle/>
-                    <a:p>
-                      <a:pPr algn="ctr"/>
-                      <a:r>
-                        <a:rPr sz="1200" b="1">
-                          <a:solidFill>
-                            <a:srgbClr val="B12A2A"/>
-                          </a:solidFill>
-                        </a:rPr>
-                        <a:t>0.34</a:t>
-                      </a:r>
-                    </a:p>
-                  </a:txBody>
-                  <a:tcPr marT="12700" marB="12700">
-                    <a:solidFill>
-                      <a:srgbClr val="FFFFFF"/>
-                    </a:solidFill>
-                  </a:tcPr>
-                </a:tc>
-                <a:tc>
-                  <a:txBody>
-                    <a:bodyPr/>
-                    <a:lstStyle/>
-                    <a:p>
-                      <a:pPr algn="ctr"/>
-                      <a:r>
-                        <a:rPr sz="1200" b="0">
-                          <a:solidFill>
-                            <a:srgbClr val="1B2A4A"/>
-                          </a:solidFill>
-                        </a:rPr>
-                        <a:t>0.67</a:t>
-                      </a:r>
-                    </a:p>
-                  </a:txBody>
-                  <a:tcPr marT="12700" marB="12700">
-                    <a:solidFill>
-                      <a:srgbClr val="FFFFFF"/>
-                    </a:solidFill>
-                  </a:tcPr>
-                </a:tc>
-                <a:tc>
-                  <a:txBody>
-                    <a:bodyPr/>
-                    <a:lstStyle/>
-                    <a:p>
-                      <a:pPr algn="ctr"/>
-                      <a:r>
-                        <a:rPr sz="1200" b="1">
-                          <a:solidFill>
-                            <a:srgbClr val="B12A2A"/>
-                          </a:solidFill>
-                        </a:rPr>
-                        <a:t>0.03</a:t>
-                      </a:r>
-                    </a:p>
-                  </a:txBody>
-                  <a:tcPr marT="12700" marB="12700">
-                    <a:solidFill>
-                      <a:srgbClr val="FFFFFF"/>
-                    </a:solidFill>
-                  </a:tcPr>
-                </a:tc>
-              </a:tr>
-              <a:tr h="292608">
-                <a:tc>
-                  <a:txBody>
-                    <a:bodyPr/>
-                    <a:lstStyle/>
-                    <a:p>
-                      <a:pPr algn="ctr"/>
-                      <a:r>
-                        <a:rPr sz="1200" b="0">
-                          <a:solidFill>
-                            <a:srgbClr val="1B2A4A"/>
-                          </a:solidFill>
-                        </a:rPr>
-                        <a:t>32</a:t>
-                      </a:r>
-                    </a:p>
-                  </a:txBody>
-                  <a:tcPr marT="12700" marB="12700">
-                    <a:solidFill>
-                      <a:srgbClr val="FFFFFF"/>
-                    </a:solidFill>
-                  </a:tcPr>
-                </a:tc>
-                <a:tc>
-                  <a:txBody>
-                    <a:bodyPr/>
-                    <a:lstStyle/>
-                    <a:p>
-                      <a:pPr algn="ctr"/>
-                      <a:r>
-                        <a:rPr sz="1200" b="0">
-                          <a:solidFill>
-                            <a:srgbClr val="1B2A4A"/>
-                          </a:solidFill>
-                        </a:rPr>
-                        <a:t>0.64</a:t>
-                      </a:r>
-                    </a:p>
-                  </a:txBody>
-                  <a:tcPr marT="12700" marB="12700">
-                    <a:solidFill>
-                      <a:srgbClr val="FFFFFF"/>
-                    </a:solidFill>
-                  </a:tcPr>
-                </a:tc>
-                <a:tc>
-                  <a:txBody>
-                    <a:bodyPr/>
-                    <a:lstStyle/>
-                    <a:p>
-                      <a:pPr algn="ctr"/>
-                      <a:r>
-                        <a:rPr sz="1200" b="1">
-                          <a:solidFill>
-                            <a:srgbClr val="B12A2A"/>
-                          </a:solidFill>
-                        </a:rPr>
-                        <a:t>0.35</a:t>
-                      </a:r>
-                    </a:p>
-                  </a:txBody>
-                  <a:tcPr marT="12700" marB="12700">
-                    <a:solidFill>
-                      <a:srgbClr val="FFFFFF"/>
-                    </a:solidFill>
-                  </a:tcPr>
-                </a:tc>
-                <a:tc>
-                  <a:txBody>
-                    <a:bodyPr/>
-                    <a:lstStyle/>
-                    <a:p>
-                      <a:pPr algn="ctr"/>
-                      <a:r>
-                        <a:rPr sz="1200" b="0">
-                          <a:solidFill>
-                            <a:srgbClr val="1B2A4A"/>
-                          </a:solidFill>
-                        </a:rPr>
-                        <a:t>0.67</a:t>
-                      </a:r>
-                    </a:p>
-                  </a:txBody>
-                  <a:tcPr marT="12700" marB="12700">
-                    <a:solidFill>
-                      <a:srgbClr val="FFFFFF"/>
-                    </a:solidFill>
-                  </a:tcPr>
-                </a:tc>
-                <a:tc>
-                  <a:txBody>
-                    <a:bodyPr/>
-                    <a:lstStyle/>
-                    <a:p>
-                      <a:pPr algn="ctr"/>
-                      <a:r>
-                        <a:rPr sz="1200" b="1">
-                          <a:solidFill>
-                            <a:srgbClr val="B12A2A"/>
-                          </a:solidFill>
-                        </a:rPr>
-                        <a:t>0.03</a:t>
-                      </a:r>
-                    </a:p>
-                  </a:txBody>
-                  <a:tcPr marT="12700" marB="12700">
-                    <a:solidFill>
-                      <a:srgbClr val="FFFFFF"/>
-                    </a:solidFill>
-                  </a:tcPr>
-                </a:tc>
-              </a:tr>
-              <a:tr h="292608">
-                <a:tc>
-                  <a:txBody>
-                    <a:bodyPr/>
-                    <a:lstStyle/>
-                    <a:p>
-                      <a:pPr algn="ctr"/>
-                      <a:r>
-                        <a:rPr sz="1200" b="0">
-                          <a:solidFill>
-                            <a:srgbClr val="1B2A4A"/>
-                          </a:solidFill>
-                        </a:rPr>
-                        <a:t>48</a:t>
-                      </a:r>
-                    </a:p>
-                  </a:txBody>
-                  <a:tcPr marT="12700" marB="12700">
-                    <a:solidFill>
-                      <a:srgbClr val="FFFFFF"/>
-                    </a:solidFill>
-                  </a:tcPr>
-                </a:tc>
-                <a:tc>
-                  <a:txBody>
-                    <a:bodyPr/>
-                    <a:lstStyle/>
-                    <a:p>
-                      <a:pPr algn="ctr"/>
-                      <a:r>
-                        <a:rPr sz="1200" b="0">
-                          <a:solidFill>
-                            <a:srgbClr val="1B2A4A"/>
-                          </a:solidFill>
-                        </a:rPr>
-                        <a:t>0.64</a:t>
-                      </a:r>
-                    </a:p>
-                  </a:txBody>
-                  <a:tcPr marT="12700" marB="12700">
-                    <a:solidFill>
-                      <a:srgbClr val="FFFFFF"/>
-                    </a:solidFill>
-                  </a:tcPr>
-                </a:tc>
-                <a:tc>
-                  <a:txBody>
-                    <a:bodyPr/>
-                    <a:lstStyle/>
-                    <a:p>
-                      <a:pPr algn="ctr"/>
-                      <a:r>
-                        <a:rPr sz="1200" b="1">
-                          <a:solidFill>
-                            <a:srgbClr val="B12A2A"/>
-                          </a:solidFill>
-                        </a:rPr>
-                        <a:t>0.32</a:t>
-                      </a:r>
-                    </a:p>
-                  </a:txBody>
-                  <a:tcPr marT="12700" marB="12700">
-                    <a:solidFill>
-                      <a:srgbClr val="FFFFFF"/>
-                    </a:solidFill>
-                  </a:tcPr>
-                </a:tc>
-                <a:tc>
-                  <a:txBody>
-                    <a:bodyPr/>
-                    <a:lstStyle/>
-                    <a:p>
-                      <a:pPr algn="ctr"/>
-                      <a:r>
-                        <a:rPr sz="1200" b="0">
-                          <a:solidFill>
-                            <a:srgbClr val="1B2A4A"/>
-                          </a:solidFill>
-                        </a:rPr>
-                        <a:t>0.67</a:t>
-                      </a:r>
-                    </a:p>
-                  </a:txBody>
-                  <a:tcPr marT="12700" marB="12700">
-                    <a:solidFill>
-                      <a:srgbClr val="FFFFFF"/>
-                    </a:solidFill>
-                  </a:tcPr>
-                </a:tc>
-                <a:tc>
-                  <a:txBody>
-                    <a:bodyPr/>
-                    <a:lstStyle/>
-                    <a:p>
-                      <a:pPr algn="ctr"/>
-                      <a:r>
-                        <a:rPr sz="1200" b="1">
-                          <a:solidFill>
-                            <a:srgbClr val="B12A2A"/>
-                          </a:solidFill>
-                        </a:rPr>
-                        <a:t>0.02</a:t>
-                      </a:r>
-                    </a:p>
-                  </a:txBody>
-                  <a:tcPr marT="12700" marB="12700">
-                    <a:solidFill>
-                      <a:srgbClr val="FFFFFF"/>
-                    </a:solidFill>
-                  </a:tcPr>
-                </a:tc>
-              </a:tr>
-            </a:tbl>
-          </a:graphicData>
-        </a:graphic>
-      </p:graphicFrame>
-      <p:graphicFrame>
-        <p:nvGraphicFramePr>
-          <p:cNvPr id="6" name="Table 5"/>
-          <p:cNvGraphicFramePr>
-            <a:graphicFrameLocks noGrp="1"/>
-          </p:cNvGraphicFramePr>
-          <p:nvPr/>
-        </p:nvGraphicFramePr>
-        <p:xfrm>
-          <a:off x="548640" y="4434840"/>
-          <a:ext cx="4114800" cy="1463040"/>
-        </p:xfrm>
-        <a:graphic>
-          <a:graphicData uri="http://schemas.openxmlformats.org/drawingml/2006/table">
-            <a:tbl>
-              <a:tblPr>
-                <a:tableStyleId>{5C22544A-7EE6-4342-B048-85BDC9FD1C3A}</a:tableStyleId>
-              </a:tblPr>
-              <a:tblGrid>
-                <a:gridCol w="731520"/>
-                <a:gridCol w="1143000"/>
-                <a:gridCol w="1234440"/>
-                <a:gridCol w="1005840"/>
-              </a:tblGrid>
-              <a:tr h="292608">
-                <a:tc>
-                  <a:txBody>
-                    <a:bodyPr/>
-                    <a:lstStyle/>
-                    <a:p>
-                      <a:pPr algn="ctr"/>
-                      <a:r>
-                        <a:rPr sz="1200" b="1">
-                          <a:solidFill>
-                            <a:srgbClr val="FFFFFF"/>
-                          </a:solidFill>
-                        </a:rPr>
-                        <a:t>C</a:t>
-                      </a:r>
-                    </a:p>
-                  </a:txBody>
-                  <a:tcPr marT="12700" marB="12700">
-                    <a:solidFill>
-                      <a:srgbClr val="1B2A4A"/>
-                    </a:solidFill>
-                  </a:tcPr>
-                </a:tc>
-                <a:tc>
-                  <a:txBody>
-                    <a:bodyPr/>
-                    <a:lstStyle/>
-                    <a:p>
-                      <a:pPr algn="ctr"/>
-                      <a:r>
-                        <a:rPr sz="1200" b="1">
-                          <a:solidFill>
-                            <a:srgbClr val="FFFFFF"/>
-                          </a:solidFill>
-                        </a:rPr>
-                        <a:t>p95 tr</a:t>
-                      </a:r>
-                    </a:p>
-                  </a:txBody>
-                  <a:tcPr marT="12700" marB="12700">
-                    <a:solidFill>
-                      <a:srgbClr val="1B2A4A"/>
-                    </a:solidFill>
-                  </a:tcPr>
-                </a:tc>
-                <a:tc>
-                  <a:txBody>
-                    <a:bodyPr/>
-                    <a:lstStyle/>
-                    <a:p>
-                      <a:pPr algn="ctr"/>
-                      <a:r>
-                        <a:rPr sz="1200" b="1">
-                          <a:solidFill>
-                            <a:srgbClr val="FFFFFF"/>
-                          </a:solidFill>
-                        </a:rPr>
-                        <a:t>p95 def</a:t>
-                      </a:r>
-                    </a:p>
-                  </a:txBody>
-                  <a:tcPr marT="12700" marB="12700">
-                    <a:solidFill>
-                      <a:srgbClr val="1B2A4A"/>
-                    </a:solidFill>
-                  </a:tcPr>
-                </a:tc>
-                <a:tc>
-                  <a:txBody>
-                    <a:bodyPr/>
-                    <a:lstStyle/>
-                    <a:p>
-                      <a:pPr algn="ctr"/>
-                      <a:r>
-                        <a:rPr sz="1200" b="1">
-                          <a:solidFill>
-                            <a:srgbClr val="FFFFFF"/>
-                          </a:solidFill>
-                        </a:rPr>
-                        <a:t>tr/def</a:t>
-                      </a:r>
-                    </a:p>
-                  </a:txBody>
-                  <a:tcPr marT="12700" marB="12700">
-                    <a:solidFill>
-                      <a:srgbClr val="1B2A4A"/>
-                    </a:solidFill>
-                  </a:tcPr>
-                </a:tc>
-              </a:tr>
-              <a:tr h="292608">
-                <a:tc>
-                  <a:txBody>
-                    <a:bodyPr/>
-                    <a:lstStyle/>
-                    <a:p>
-                      <a:pPr algn="ctr"/>
-                      <a:r>
-                        <a:rPr sz="1200" b="0">
-                          <a:solidFill>
-                            <a:srgbClr val="1B2A4A"/>
-                          </a:solidFill>
-                        </a:rPr>
-                        <a:t>8</a:t>
-                      </a:r>
-                    </a:p>
-                  </a:txBody>
-                  <a:tcPr marT="12700" marB="12700">
-                    <a:solidFill>
-                      <a:srgbClr val="FFFFFF"/>
-                    </a:solidFill>
-                  </a:tcPr>
-                </a:tc>
-                <a:tc>
-                  <a:txBody>
-                    <a:bodyPr/>
-                    <a:lstStyle/>
-                    <a:p>
-                      <a:pPr algn="ctr"/>
-                      <a:r>
-                        <a:rPr sz="1200" b="0">
-                          <a:solidFill>
-                            <a:srgbClr val="1B2A4A"/>
-                          </a:solidFill>
-                        </a:rPr>
-                        <a:t>20.6s</a:t>
-                      </a:r>
-                    </a:p>
-                  </a:txBody>
-                  <a:tcPr marT="12700" marB="12700">
-                    <a:solidFill>
-                      <a:srgbClr val="FFFFFF"/>
-                    </a:solidFill>
-                  </a:tcPr>
-                </a:tc>
-                <a:tc>
-                  <a:txBody>
-                    <a:bodyPr/>
-                    <a:lstStyle/>
-                    <a:p>
-                      <a:pPr algn="ctr"/>
-                      <a:r>
-                        <a:rPr sz="1200" b="0">
-                          <a:solidFill>
-                            <a:srgbClr val="1B2A4A"/>
-                          </a:solidFill>
-                        </a:rPr>
-                        <a:t>25.7s</a:t>
-                      </a:r>
-                    </a:p>
-                  </a:txBody>
-                  <a:tcPr marT="12700" marB="12700">
-                    <a:solidFill>
-                      <a:srgbClr val="FFFFFF"/>
-                    </a:solidFill>
-                  </a:tcPr>
-                </a:tc>
-                <a:tc>
-                  <a:txBody>
-                    <a:bodyPr/>
-                    <a:lstStyle/>
-                    <a:p>
-                      <a:pPr algn="ctr"/>
-                      <a:r>
-                        <a:rPr sz="1200" b="1">
-                          <a:solidFill>
-                            <a:srgbClr val="B12A2A"/>
-                          </a:solidFill>
-                        </a:rPr>
-                        <a:t>0.80×</a:t>
-                      </a:r>
-                    </a:p>
-                  </a:txBody>
-                  <a:tcPr marT="12700" marB="12700">
-                    <a:solidFill>
-                      <a:srgbClr val="FFFFFF"/>
-                    </a:solidFill>
-                  </a:tcPr>
-                </a:tc>
-              </a:tr>
-              <a:tr h="292608">
-                <a:tc>
-                  <a:txBody>
-                    <a:bodyPr/>
-                    <a:lstStyle/>
-                    <a:p>
-                      <a:pPr algn="ctr"/>
-                      <a:r>
-                        <a:rPr sz="1200" b="0">
-                          <a:solidFill>
-                            <a:srgbClr val="1B2A4A"/>
-                          </a:solidFill>
-                        </a:rPr>
-                        <a:t>16</a:t>
-                      </a:r>
-                    </a:p>
-                  </a:txBody>
-                  <a:tcPr marT="12700" marB="12700">
-                    <a:solidFill>
-                      <a:srgbClr val="FFFFFF"/>
-                    </a:solidFill>
-                  </a:tcPr>
-                </a:tc>
-                <a:tc>
-                  <a:txBody>
-                    <a:bodyPr/>
-                    <a:lstStyle/>
-                    <a:p>
-                      <a:pPr algn="ctr"/>
-                      <a:r>
-                        <a:rPr sz="1200" b="0">
-                          <a:solidFill>
-                            <a:srgbClr val="1B2A4A"/>
-                          </a:solidFill>
-                        </a:rPr>
-                        <a:t>34.9s</a:t>
-                      </a:r>
-                    </a:p>
-                  </a:txBody>
-                  <a:tcPr marT="12700" marB="12700">
-                    <a:solidFill>
-                      <a:srgbClr val="FFFFFF"/>
-                    </a:solidFill>
-                  </a:tcPr>
-                </a:tc>
-                <a:tc>
-                  <a:txBody>
-                    <a:bodyPr/>
-                    <a:lstStyle/>
-                    <a:p>
-                      <a:pPr algn="ctr"/>
-                      <a:r>
-                        <a:rPr sz="1200" b="0">
-                          <a:solidFill>
-                            <a:srgbClr val="1B2A4A"/>
-                          </a:solidFill>
-                        </a:rPr>
-                        <a:t>52.2s</a:t>
-                      </a:r>
-                    </a:p>
-                  </a:txBody>
-                  <a:tcPr marT="12700" marB="12700">
-                    <a:solidFill>
-                      <a:srgbClr val="FFFFFF"/>
-                    </a:solidFill>
-                  </a:tcPr>
-                </a:tc>
-                <a:tc>
-                  <a:txBody>
-                    <a:bodyPr/>
-                    <a:lstStyle/>
-                    <a:p>
-                      <a:pPr algn="ctr"/>
-                      <a:r>
-                        <a:rPr sz="1200" b="1">
-                          <a:solidFill>
-                            <a:srgbClr val="B12A2A"/>
-                          </a:solidFill>
-                        </a:rPr>
-                        <a:t>0.67×</a:t>
-                      </a:r>
-                    </a:p>
-                  </a:txBody>
-                  <a:tcPr marT="12700" marB="12700">
-                    <a:solidFill>
-                      <a:srgbClr val="FFFFFF"/>
-                    </a:solidFill>
-                  </a:tcPr>
-                </a:tc>
-              </a:tr>
-              <a:tr h="292608">
-                <a:tc>
-                  <a:txBody>
-                    <a:bodyPr/>
-                    <a:lstStyle/>
-                    <a:p>
-                      <a:pPr algn="ctr"/>
-                      <a:r>
-                        <a:rPr sz="1200" b="0">
-                          <a:solidFill>
-                            <a:srgbClr val="1B2A4A"/>
-                          </a:solidFill>
-                        </a:rPr>
-                        <a:t>32</a:t>
-                      </a:r>
-                    </a:p>
-                  </a:txBody>
-                  <a:tcPr marT="12700" marB="12700">
-                    <a:solidFill>
-                      <a:srgbClr val="FFFFFF"/>
-                    </a:solidFill>
-                  </a:tcPr>
-                </a:tc>
-                <a:tc>
-                  <a:txBody>
-                    <a:bodyPr/>
-                    <a:lstStyle/>
-                    <a:p>
-                      <a:pPr algn="ctr"/>
-                      <a:r>
-                        <a:rPr sz="1200" b="0">
-                          <a:solidFill>
-                            <a:srgbClr val="1B2A4A"/>
-                          </a:solidFill>
-                        </a:rPr>
-                        <a:t>55.1s</a:t>
-                      </a:r>
-                    </a:p>
-                  </a:txBody>
-                  <a:tcPr marT="12700" marB="12700">
-                    <a:solidFill>
-                      <a:srgbClr val="FFFFFF"/>
-                    </a:solidFill>
-                  </a:tcPr>
-                </a:tc>
-                <a:tc>
-                  <a:txBody>
-                    <a:bodyPr/>
-                    <a:lstStyle/>
-                    <a:p>
-                      <a:pPr algn="ctr"/>
-                      <a:r>
-                        <a:rPr sz="1200" b="0">
-                          <a:solidFill>
-                            <a:srgbClr val="1B2A4A"/>
-                          </a:solidFill>
-                        </a:rPr>
-                        <a:t>99.0s</a:t>
-                      </a:r>
-                    </a:p>
-                  </a:txBody>
-                  <a:tcPr marT="12700" marB="12700">
-                    <a:solidFill>
-                      <a:srgbClr val="FFFFFF"/>
-                    </a:solidFill>
-                  </a:tcPr>
-                </a:tc>
-                <a:tc>
-                  <a:txBody>
-                    <a:bodyPr/>
-                    <a:lstStyle/>
-                    <a:p>
-                      <a:pPr algn="ctr"/>
-                      <a:r>
-                        <a:rPr sz="1200" b="1">
-                          <a:solidFill>
-                            <a:srgbClr val="B12A2A"/>
-                          </a:solidFill>
-                        </a:rPr>
-                        <a:t>0.56×</a:t>
-                      </a:r>
-                    </a:p>
-                  </a:txBody>
-                  <a:tcPr marT="12700" marB="12700">
-                    <a:solidFill>
-                      <a:srgbClr val="FFFFFF"/>
-                    </a:solidFill>
-                  </a:tcPr>
-                </a:tc>
-              </a:tr>
-              <a:tr h="292608">
-                <a:tc>
-                  <a:txBody>
-                    <a:bodyPr/>
-                    <a:lstStyle/>
-                    <a:p>
-                      <a:pPr algn="ctr"/>
-                      <a:r>
-                        <a:rPr sz="1200" b="0">
-                          <a:solidFill>
-                            <a:srgbClr val="1B2A4A"/>
-                          </a:solidFill>
-                        </a:rPr>
-                        <a:t>48</a:t>
-                      </a:r>
-                    </a:p>
-                  </a:txBody>
-                  <a:tcPr marT="12700" marB="12700">
-                    <a:solidFill>
-                      <a:srgbClr val="FFFFFF"/>
-                    </a:solidFill>
-                  </a:tcPr>
-                </a:tc>
-                <a:tc>
-                  <a:txBody>
-                    <a:bodyPr/>
-                    <a:lstStyle/>
-                    <a:p>
-                      <a:pPr algn="ctr"/>
-                      <a:r>
-                        <a:rPr sz="1200" b="0">
-                          <a:solidFill>
-                            <a:srgbClr val="1B2A4A"/>
-                          </a:solidFill>
-                        </a:rPr>
-                        <a:t>70.2s</a:t>
-                      </a:r>
-                    </a:p>
-                  </a:txBody>
-                  <a:tcPr marT="12700" marB="12700">
-                    <a:solidFill>
-                      <a:srgbClr val="FFFFFF"/>
-                    </a:solidFill>
-                  </a:tcPr>
-                </a:tc>
-                <a:tc>
-                  <a:txBody>
-                    <a:bodyPr/>
-                    <a:lstStyle/>
-                    <a:p>
-                      <a:pPr algn="ctr"/>
-                      <a:r>
-                        <a:rPr sz="1200" b="0">
-                          <a:solidFill>
-                            <a:srgbClr val="1B2A4A"/>
-                          </a:solidFill>
-                        </a:rPr>
-                        <a:t>149.0s</a:t>
-                      </a:r>
-                    </a:p>
-                  </a:txBody>
-                  <a:tcPr marT="12700" marB="12700">
-                    <a:solidFill>
-                      <a:srgbClr val="FFFFFF"/>
-                    </a:solidFill>
-                  </a:tcPr>
-                </a:tc>
-                <a:tc>
-                  <a:txBody>
-                    <a:bodyPr/>
-                    <a:lstStyle/>
-                    <a:p>
-                      <a:pPr algn="ctr"/>
-                      <a:r>
-                        <a:rPr sz="1200" b="1">
-                          <a:solidFill>
-                            <a:srgbClr val="B12A2A"/>
-                          </a:solidFill>
-                        </a:rPr>
-                        <a:t>0.47×</a:t>
-                      </a:r>
-                    </a:p>
-                  </a:txBody>
-                  <a:tcPr marT="12700" marB="12700">
-                    <a:solidFill>
-                      <a:srgbClr val="FFFFFF"/>
-                    </a:solidFill>
-                  </a:tcPr>
-                </a:tc>
-              </a:tr>
-            </a:tbl>
-          </a:graphicData>
-        </a:graphic>
-      </p:graphicFrame>
-      <p:sp>
-        <p:nvSpPr>
-          <p:cNvPr id="7" name="TextBox 6"/>
-          <p:cNvSpPr txBox="1"/>
-          <p:nvPr/>
-        </p:nvSpPr>
-        <p:spPr>
-          <a:xfrm>
-            <a:off x="548640" y="6172200"/>
-            <a:ext cx="4754880" cy="320040"/>
-          </a:xfrm>
-          <a:prstGeom prst="rect">
-            <a:avLst/>
-          </a:prstGeom>
-          <a:noFill/>
-        </p:spPr>
-        <p:txBody>
-          <a:bodyPr wrap="none">
-            <a:spAutoFit/>
-          </a:bodyPr>
-          <a:lstStyle/>
-          <a:p>
-            <a:pPr algn="ctr"/>
-            <a:r>
-              <a:rPr sz="1100" b="1">
-                <a:solidFill>
-                  <a:srgbClr val="1B2A4A"/>
-                </a:solidFill>
-              </a:rPr>
-              <a:t>위=throughput·hit / 아래=p95 지연 (3회 평균)</a:t>
-            </a:r>
-          </a:p>
-        </p:txBody>
-      </p:sp>
       <p:pic>
         <p:nvPicPr>
-          <p:cNvPr id="8" name="Picture 7" descr="homo_hetero_throughput.png"/>
+          <p:cNvPr id="5" name="Picture 4" descr="homo_hetero_throughput.png"/>
           <p:cNvPicPr>
             <a:picLocks noChangeAspect="1"/>
           </p:cNvPicPr>
@@ -10674,14 +9977,1015 @@
         </p:blipFill>
         <p:spPr>
           <a:xfrm>
-            <a:off x="5669280" y="1600200"/>
-            <a:ext cx="6309360" cy="4274083"/>
+            <a:off x="6720840" y="1371600"/>
+            <a:ext cx="5029200" cy="3406877"/>
           </a:xfrm>
           <a:prstGeom prst="rect">
             <a:avLst/>
           </a:prstGeom>
         </p:spPr>
       </p:pic>
+      <p:graphicFrame>
+        <p:nvGraphicFramePr>
+          <p:cNvPr id="6" name="Table 5"/>
+          <p:cNvGraphicFramePr>
+            <a:graphicFrameLocks noGrp="1"/>
+          </p:cNvGraphicFramePr>
+          <p:nvPr/>
+        </p:nvGraphicFramePr>
+        <p:xfrm>
+          <a:off x="365760" y="4892040"/>
+          <a:ext cx="11429999" cy="1536192"/>
+        </p:xfrm>
+        <a:graphic>
+          <a:graphicData uri="http://schemas.openxmlformats.org/drawingml/2006/table">
+            <a:tbl>
+              <a:tblPr>
+                <a:tableStyleId>{5C22544A-7EE6-4342-B048-85BDC9FD1C3A}</a:tableStyleId>
+              </a:tblPr>
+              <a:tblGrid>
+                <a:gridCol w="822960"/>
+                <a:gridCol w="1737360"/>
+                <a:gridCol w="1737360"/>
+                <a:gridCol w="1737360"/>
+                <a:gridCol w="1737360"/>
+                <a:gridCol w="1783080"/>
+                <a:gridCol w="1874519"/>
+              </a:tblGrid>
+              <a:tr h="256032">
+                <a:tc>
+                  <a:txBody>
+                    <a:bodyPr/>
+                    <a:lstStyle/>
+                    <a:p>
+                      <a:pPr algn="ctr"/>
+                      <a:r>
+                        <a:rPr sz="1200" b="1">
+                          <a:solidFill>
+                            <a:srgbClr val="FFFFFF"/>
+                          </a:solidFill>
+                        </a:rPr>
+                        <a:t>C</a:t>
+                      </a:r>
+                    </a:p>
+                  </a:txBody>
+                  <a:tcPr marT="12700" marB="12700">
+                    <a:solidFill>
+                      <a:srgbClr val="1B2A4A"/>
+                    </a:solidFill>
+                  </a:tcPr>
+                </a:tc>
+                <a:tc>
+                  <a:txBody>
+                    <a:bodyPr/>
+                    <a:lstStyle/>
+                    <a:p>
+                      <a:pPr algn="ctr"/>
+                      <a:r>
+                        <a:rPr sz="1200" b="1">
+                          <a:solidFill>
+                            <a:srgbClr val="FFFFFF"/>
+                          </a:solidFill>
+                        </a:rPr>
+                        <a:t>thru tr</a:t>
+                      </a:r>
+                    </a:p>
+                  </a:txBody>
+                  <a:tcPr marT="12700" marB="12700">
+                    <a:solidFill>
+                      <a:srgbClr val="1B2A4A"/>
+                    </a:solidFill>
+                  </a:tcPr>
+                </a:tc>
+                <a:tc>
+                  <a:txBody>
+                    <a:bodyPr/>
+                    <a:lstStyle/>
+                    <a:p>
+                      <a:pPr algn="ctr"/>
+                      <a:r>
+                        <a:rPr sz="1200" b="1">
+                          <a:solidFill>
+                            <a:srgbClr val="FFFFFF"/>
+                          </a:solidFill>
+                        </a:rPr>
+                        <a:t>thru def</a:t>
+                      </a:r>
+                    </a:p>
+                  </a:txBody>
+                  <a:tcPr marT="12700" marB="12700">
+                    <a:solidFill>
+                      <a:srgbClr val="1B2A4A"/>
+                    </a:solidFill>
+                  </a:tcPr>
+                </a:tc>
+                <a:tc>
+                  <a:txBody>
+                    <a:bodyPr/>
+                    <a:lstStyle/>
+                    <a:p>
+                      <a:pPr algn="ctr"/>
+                      <a:r>
+                        <a:rPr sz="1200" b="1">
+                          <a:solidFill>
+                            <a:srgbClr val="FFFFFF"/>
+                          </a:solidFill>
+                        </a:rPr>
+                        <a:t>hit tr</a:t>
+                      </a:r>
+                    </a:p>
+                  </a:txBody>
+                  <a:tcPr marT="12700" marB="12700">
+                    <a:solidFill>
+                      <a:srgbClr val="1B2A4A"/>
+                    </a:solidFill>
+                  </a:tcPr>
+                </a:tc>
+                <a:tc>
+                  <a:txBody>
+                    <a:bodyPr/>
+                    <a:lstStyle/>
+                    <a:p>
+                      <a:pPr algn="ctr"/>
+                      <a:r>
+                        <a:rPr sz="1200" b="1">
+                          <a:solidFill>
+                            <a:srgbClr val="FFFFFF"/>
+                          </a:solidFill>
+                        </a:rPr>
+                        <a:t>hit def</a:t>
+                      </a:r>
+                    </a:p>
+                  </a:txBody>
+                  <a:tcPr marT="12700" marB="12700">
+                    <a:solidFill>
+                      <a:srgbClr val="1B2A4A"/>
+                    </a:solidFill>
+                  </a:tcPr>
+                </a:tc>
+                <a:tc>
+                  <a:txBody>
+                    <a:bodyPr/>
+                    <a:lstStyle/>
+                    <a:p>
+                      <a:pPr algn="ctr"/>
+                      <a:r>
+                        <a:rPr sz="1200" b="1">
+                          <a:solidFill>
+                            <a:srgbClr val="FFFFFF"/>
+                          </a:solidFill>
+                        </a:rPr>
+                        <a:t>p95 tr</a:t>
+                      </a:r>
+                    </a:p>
+                  </a:txBody>
+                  <a:tcPr marT="12700" marB="12700">
+                    <a:solidFill>
+                      <a:srgbClr val="1B2A4A"/>
+                    </a:solidFill>
+                  </a:tcPr>
+                </a:tc>
+                <a:tc>
+                  <a:txBody>
+                    <a:bodyPr/>
+                    <a:lstStyle/>
+                    <a:p>
+                      <a:pPr algn="ctr"/>
+                      <a:r>
+                        <a:rPr sz="1200" b="1">
+                          <a:solidFill>
+                            <a:srgbClr val="FFFFFF"/>
+                          </a:solidFill>
+                        </a:rPr>
+                        <a:t>p95 def</a:t>
+                      </a:r>
+                    </a:p>
+                  </a:txBody>
+                  <a:tcPr marT="12700" marB="12700">
+                    <a:solidFill>
+                      <a:srgbClr val="1B2A4A"/>
+                    </a:solidFill>
+                  </a:tcPr>
+                </a:tc>
+              </a:tr>
+              <a:tr h="256032">
+                <a:tc>
+                  <a:txBody>
+                    <a:bodyPr/>
+                    <a:lstStyle/>
+                    <a:p>
+                      <a:pPr algn="ctr"/>
+                      <a:r>
+                        <a:rPr sz="1200" b="0">
+                          <a:solidFill>
+                            <a:srgbClr val="1B2A4A"/>
+                          </a:solidFill>
+                        </a:rPr>
+                        <a:t>8</a:t>
+                      </a:r>
+                    </a:p>
+                  </a:txBody>
+                  <a:tcPr marT="12700" marB="12700">
+                    <a:solidFill>
+                      <a:srgbClr val="FFFFFF"/>
+                    </a:solidFill>
+                  </a:tcPr>
+                </a:tc>
+                <a:tc>
+                  <a:txBody>
+                    <a:bodyPr/>
+                    <a:lstStyle/>
+                    <a:p>
+                      <a:pPr algn="ctr"/>
+                      <a:r>
+                        <a:rPr sz="1200" b="0">
+                          <a:solidFill>
+                            <a:srgbClr val="1B2A4A"/>
+                          </a:solidFill>
+                        </a:rPr>
+                        <a:t>0.67</a:t>
+                      </a:r>
+                    </a:p>
+                  </a:txBody>
+                  <a:tcPr marT="12700" marB="12700">
+                    <a:solidFill>
+                      <a:srgbClr val="FFFFFF"/>
+                    </a:solidFill>
+                  </a:tcPr>
+                </a:tc>
+                <a:tc>
+                  <a:txBody>
+                    <a:bodyPr/>
+                    <a:lstStyle/>
+                    <a:p>
+                      <a:pPr algn="ctr"/>
+                      <a:r>
+                        <a:rPr sz="1200" b="0">
+                          <a:solidFill>
+                            <a:srgbClr val="1B2A4A"/>
+                          </a:solidFill>
+                        </a:rPr>
+                        <a:t>0.62</a:t>
+                      </a:r>
+                    </a:p>
+                  </a:txBody>
+                  <a:tcPr marT="12700" marB="12700">
+                    <a:solidFill>
+                      <a:srgbClr val="FFFFFF"/>
+                    </a:solidFill>
+                  </a:tcPr>
+                </a:tc>
+                <a:tc>
+                  <a:txBody>
+                    <a:bodyPr/>
+                    <a:lstStyle/>
+                    <a:p>
+                      <a:pPr algn="ctr"/>
+                      <a:r>
+                        <a:rPr sz="1200" b="0">
+                          <a:solidFill>
+                            <a:srgbClr val="1B2A4A"/>
+                          </a:solidFill>
+                        </a:rPr>
+                        <a:t>0.56</a:t>
+                      </a:r>
+                    </a:p>
+                  </a:txBody>
+                  <a:tcPr marT="12700" marB="12700">
+                    <a:solidFill>
+                      <a:srgbClr val="FFFFFF"/>
+                    </a:solidFill>
+                  </a:tcPr>
+                </a:tc>
+                <a:tc>
+                  <a:txBody>
+                    <a:bodyPr/>
+                    <a:lstStyle/>
+                    <a:p>
+                      <a:pPr algn="ctr"/>
+                      <a:r>
+                        <a:rPr sz="1200" b="0">
+                          <a:solidFill>
+                            <a:srgbClr val="1B2A4A"/>
+                          </a:solidFill>
+                        </a:rPr>
+                        <a:t>0.23</a:t>
+                      </a:r>
+                    </a:p>
+                  </a:txBody>
+                  <a:tcPr marT="12700" marB="12700">
+                    <a:solidFill>
+                      <a:srgbClr val="FFFFFF"/>
+                    </a:solidFill>
+                  </a:tcPr>
+                </a:tc>
+                <a:tc>
+                  <a:txBody>
+                    <a:bodyPr/>
+                    <a:lstStyle/>
+                    <a:p>
+                      <a:pPr algn="ctr"/>
+                      <a:r>
+                        <a:rPr sz="1200" b="0">
+                          <a:solidFill>
+                            <a:srgbClr val="1B2A4A"/>
+                          </a:solidFill>
+                        </a:rPr>
+                        <a:t>20.6s</a:t>
+                      </a:r>
+                    </a:p>
+                  </a:txBody>
+                  <a:tcPr marT="12700" marB="12700">
+                    <a:solidFill>
+                      <a:srgbClr val="FFFFFF"/>
+                    </a:solidFill>
+                  </a:tcPr>
+                </a:tc>
+                <a:tc>
+                  <a:txBody>
+                    <a:bodyPr/>
+                    <a:lstStyle/>
+                    <a:p>
+                      <a:pPr algn="ctr"/>
+                      <a:r>
+                        <a:rPr sz="1200" b="0">
+                          <a:solidFill>
+                            <a:srgbClr val="1B2A4A"/>
+                          </a:solidFill>
+                        </a:rPr>
+                        <a:t>25.7s</a:t>
+                      </a:r>
+                    </a:p>
+                  </a:txBody>
+                  <a:tcPr marT="12700" marB="12700">
+                    <a:solidFill>
+                      <a:srgbClr val="FFFFFF"/>
+                    </a:solidFill>
+                  </a:tcPr>
+                </a:tc>
+              </a:tr>
+              <a:tr h="256032">
+                <a:tc>
+                  <a:txBody>
+                    <a:bodyPr/>
+                    <a:lstStyle/>
+                    <a:p>
+                      <a:pPr algn="ctr"/>
+                      <a:r>
+                        <a:rPr sz="1200" b="0">
+                          <a:solidFill>
+                            <a:srgbClr val="1B2A4A"/>
+                          </a:solidFill>
+                        </a:rPr>
+                        <a:t>16</a:t>
+                      </a:r>
+                    </a:p>
+                  </a:txBody>
+                  <a:tcPr marT="12700" marB="12700">
+                    <a:solidFill>
+                      <a:srgbClr val="FFFFFF"/>
+                    </a:solidFill>
+                  </a:tcPr>
+                </a:tc>
+                <a:tc>
+                  <a:txBody>
+                    <a:bodyPr/>
+                    <a:lstStyle/>
+                    <a:p>
+                      <a:pPr algn="ctr"/>
+                      <a:r>
+                        <a:rPr sz="1200" b="0">
+                          <a:solidFill>
+                            <a:srgbClr val="1B2A4A"/>
+                          </a:solidFill>
+                        </a:rPr>
+                        <a:t>0.64</a:t>
+                      </a:r>
+                    </a:p>
+                  </a:txBody>
+                  <a:tcPr marT="12700" marB="12700">
+                    <a:solidFill>
+                      <a:srgbClr val="FFFFFF"/>
+                    </a:solidFill>
+                  </a:tcPr>
+                </a:tc>
+                <a:tc>
+                  <a:txBody>
+                    <a:bodyPr/>
+                    <a:lstStyle/>
+                    <a:p>
+                      <a:pPr algn="ctr"/>
+                      <a:r>
+                        <a:rPr sz="1200" b="1">
+                          <a:solidFill>
+                            <a:srgbClr val="B12A2A"/>
+                          </a:solidFill>
+                        </a:rPr>
+                        <a:t>0.34</a:t>
+                      </a:r>
+                    </a:p>
+                  </a:txBody>
+                  <a:tcPr marT="12700" marB="12700">
+                    <a:solidFill>
+                      <a:srgbClr val="FFFFFF"/>
+                    </a:solidFill>
+                  </a:tcPr>
+                </a:tc>
+                <a:tc>
+                  <a:txBody>
+                    <a:bodyPr/>
+                    <a:lstStyle/>
+                    <a:p>
+                      <a:pPr algn="ctr"/>
+                      <a:r>
+                        <a:rPr sz="1200" b="0">
+                          <a:solidFill>
+                            <a:srgbClr val="1B2A4A"/>
+                          </a:solidFill>
+                        </a:rPr>
+                        <a:t>0.67</a:t>
+                      </a:r>
+                    </a:p>
+                  </a:txBody>
+                  <a:tcPr marT="12700" marB="12700">
+                    <a:solidFill>
+                      <a:srgbClr val="FFFFFF"/>
+                    </a:solidFill>
+                  </a:tcPr>
+                </a:tc>
+                <a:tc>
+                  <a:txBody>
+                    <a:bodyPr/>
+                    <a:lstStyle/>
+                    <a:p>
+                      <a:pPr algn="ctr"/>
+                      <a:r>
+                        <a:rPr sz="1200" b="1">
+                          <a:solidFill>
+                            <a:srgbClr val="B12A2A"/>
+                          </a:solidFill>
+                        </a:rPr>
+                        <a:t>0.03</a:t>
+                      </a:r>
+                    </a:p>
+                  </a:txBody>
+                  <a:tcPr marT="12700" marB="12700">
+                    <a:solidFill>
+                      <a:srgbClr val="FFFFFF"/>
+                    </a:solidFill>
+                  </a:tcPr>
+                </a:tc>
+                <a:tc>
+                  <a:txBody>
+                    <a:bodyPr/>
+                    <a:lstStyle/>
+                    <a:p>
+                      <a:pPr algn="ctr"/>
+                      <a:r>
+                        <a:rPr sz="1200" b="0">
+                          <a:solidFill>
+                            <a:srgbClr val="1B2A4A"/>
+                          </a:solidFill>
+                        </a:rPr>
+                        <a:t>34.9s</a:t>
+                      </a:r>
+                    </a:p>
+                  </a:txBody>
+                  <a:tcPr marT="12700" marB="12700">
+                    <a:solidFill>
+                      <a:srgbClr val="FFFFFF"/>
+                    </a:solidFill>
+                  </a:tcPr>
+                </a:tc>
+                <a:tc>
+                  <a:txBody>
+                    <a:bodyPr/>
+                    <a:lstStyle/>
+                    <a:p>
+                      <a:pPr algn="ctr"/>
+                      <a:r>
+                        <a:rPr sz="1200" b="0">
+                          <a:solidFill>
+                            <a:srgbClr val="1B2A4A"/>
+                          </a:solidFill>
+                        </a:rPr>
+                        <a:t>52.2s</a:t>
+                      </a:r>
+                    </a:p>
+                  </a:txBody>
+                  <a:tcPr marT="12700" marB="12700">
+                    <a:solidFill>
+                      <a:srgbClr val="FFFFFF"/>
+                    </a:solidFill>
+                  </a:tcPr>
+                </a:tc>
+              </a:tr>
+              <a:tr h="256032">
+                <a:tc>
+                  <a:txBody>
+                    <a:bodyPr/>
+                    <a:lstStyle/>
+                    <a:p>
+                      <a:pPr algn="ctr"/>
+                      <a:r>
+                        <a:rPr sz="1200" b="0">
+                          <a:solidFill>
+                            <a:srgbClr val="1B2A4A"/>
+                          </a:solidFill>
+                        </a:rPr>
+                        <a:t>24</a:t>
+                      </a:r>
+                    </a:p>
+                  </a:txBody>
+                  <a:tcPr marT="12700" marB="12700">
+                    <a:solidFill>
+                      <a:srgbClr val="FFFFFF"/>
+                    </a:solidFill>
+                  </a:tcPr>
+                </a:tc>
+                <a:tc>
+                  <a:txBody>
+                    <a:bodyPr/>
+                    <a:lstStyle/>
+                    <a:p>
+                      <a:pPr algn="ctr"/>
+                      <a:r>
+                        <a:rPr sz="1200" b="0">
+                          <a:solidFill>
+                            <a:srgbClr val="1B2A4A"/>
+                          </a:solidFill>
+                        </a:rPr>
+                        <a:t>0.63</a:t>
+                      </a:r>
+                    </a:p>
+                  </a:txBody>
+                  <a:tcPr marT="12700" marB="12700">
+                    <a:solidFill>
+                      <a:srgbClr val="FFFFFF"/>
+                    </a:solidFill>
+                  </a:tcPr>
+                </a:tc>
+                <a:tc>
+                  <a:txBody>
+                    <a:bodyPr/>
+                    <a:lstStyle/>
+                    <a:p>
+                      <a:pPr algn="ctr"/>
+                      <a:r>
+                        <a:rPr sz="1200" b="1">
+                          <a:solidFill>
+                            <a:srgbClr val="B12A2A"/>
+                          </a:solidFill>
+                        </a:rPr>
+                        <a:t>0.32</a:t>
+                      </a:r>
+                    </a:p>
+                  </a:txBody>
+                  <a:tcPr marT="12700" marB="12700">
+                    <a:solidFill>
+                      <a:srgbClr val="FFFFFF"/>
+                    </a:solidFill>
+                  </a:tcPr>
+                </a:tc>
+                <a:tc>
+                  <a:txBody>
+                    <a:bodyPr/>
+                    <a:lstStyle/>
+                    <a:p>
+                      <a:pPr algn="ctr"/>
+                      <a:r>
+                        <a:rPr sz="1200" b="0">
+                          <a:solidFill>
+                            <a:srgbClr val="1B2A4A"/>
+                          </a:solidFill>
+                        </a:rPr>
+                        <a:t>0.67</a:t>
+                      </a:r>
+                    </a:p>
+                  </a:txBody>
+                  <a:tcPr marT="12700" marB="12700">
+                    <a:solidFill>
+                      <a:srgbClr val="FFFFFF"/>
+                    </a:solidFill>
+                  </a:tcPr>
+                </a:tc>
+                <a:tc>
+                  <a:txBody>
+                    <a:bodyPr/>
+                    <a:lstStyle/>
+                    <a:p>
+                      <a:pPr algn="ctr"/>
+                      <a:r>
+                        <a:rPr sz="1200" b="1">
+                          <a:solidFill>
+                            <a:srgbClr val="B12A2A"/>
+                          </a:solidFill>
+                        </a:rPr>
+                        <a:t>0.02</a:t>
+                      </a:r>
+                    </a:p>
+                  </a:txBody>
+                  <a:tcPr marT="12700" marB="12700">
+                    <a:solidFill>
+                      <a:srgbClr val="FFFFFF"/>
+                    </a:solidFill>
+                  </a:tcPr>
+                </a:tc>
+                <a:tc>
+                  <a:txBody>
+                    <a:bodyPr/>
+                    <a:lstStyle/>
+                    <a:p>
+                      <a:pPr algn="ctr"/>
+                      <a:r>
+                        <a:rPr sz="1200" b="0">
+                          <a:solidFill>
+                            <a:srgbClr val="1B2A4A"/>
+                          </a:solidFill>
+                        </a:rPr>
+                        <a:t>48.9s</a:t>
+                      </a:r>
+                    </a:p>
+                  </a:txBody>
+                  <a:tcPr marT="12700" marB="12700">
+                    <a:solidFill>
+                      <a:srgbClr val="FFFFFF"/>
+                    </a:solidFill>
+                  </a:tcPr>
+                </a:tc>
+                <a:tc>
+                  <a:txBody>
+                    <a:bodyPr/>
+                    <a:lstStyle/>
+                    <a:p>
+                      <a:pPr algn="ctr"/>
+                      <a:r>
+                        <a:rPr sz="1200" b="0">
+                          <a:solidFill>
+                            <a:srgbClr val="1B2A4A"/>
+                          </a:solidFill>
+                        </a:rPr>
+                        <a:t>77.3s</a:t>
+                      </a:r>
+                    </a:p>
+                  </a:txBody>
+                  <a:tcPr marT="12700" marB="12700">
+                    <a:solidFill>
+                      <a:srgbClr val="FFFFFF"/>
+                    </a:solidFill>
+                  </a:tcPr>
+                </a:tc>
+              </a:tr>
+              <a:tr h="256032">
+                <a:tc>
+                  <a:txBody>
+                    <a:bodyPr/>
+                    <a:lstStyle/>
+                    <a:p>
+                      <a:pPr algn="ctr"/>
+                      <a:r>
+                        <a:rPr sz="1200" b="0">
+                          <a:solidFill>
+                            <a:srgbClr val="1B2A4A"/>
+                          </a:solidFill>
+                        </a:rPr>
+                        <a:t>32</a:t>
+                      </a:r>
+                    </a:p>
+                  </a:txBody>
+                  <a:tcPr marT="12700" marB="12700">
+                    <a:solidFill>
+                      <a:srgbClr val="FFFFFF"/>
+                    </a:solidFill>
+                  </a:tcPr>
+                </a:tc>
+                <a:tc>
+                  <a:txBody>
+                    <a:bodyPr/>
+                    <a:lstStyle/>
+                    <a:p>
+                      <a:pPr algn="ctr"/>
+                      <a:r>
+                        <a:rPr sz="1200" b="0">
+                          <a:solidFill>
+                            <a:srgbClr val="1B2A4A"/>
+                          </a:solidFill>
+                        </a:rPr>
+                        <a:t>0.64</a:t>
+                      </a:r>
+                    </a:p>
+                  </a:txBody>
+                  <a:tcPr marT="12700" marB="12700">
+                    <a:solidFill>
+                      <a:srgbClr val="FFFFFF"/>
+                    </a:solidFill>
+                  </a:tcPr>
+                </a:tc>
+                <a:tc>
+                  <a:txBody>
+                    <a:bodyPr/>
+                    <a:lstStyle/>
+                    <a:p>
+                      <a:pPr algn="ctr"/>
+                      <a:r>
+                        <a:rPr sz="1200" b="1">
+                          <a:solidFill>
+                            <a:srgbClr val="B12A2A"/>
+                          </a:solidFill>
+                        </a:rPr>
+                        <a:t>0.35</a:t>
+                      </a:r>
+                    </a:p>
+                  </a:txBody>
+                  <a:tcPr marT="12700" marB="12700">
+                    <a:solidFill>
+                      <a:srgbClr val="FFFFFF"/>
+                    </a:solidFill>
+                  </a:tcPr>
+                </a:tc>
+                <a:tc>
+                  <a:txBody>
+                    <a:bodyPr/>
+                    <a:lstStyle/>
+                    <a:p>
+                      <a:pPr algn="ctr"/>
+                      <a:r>
+                        <a:rPr sz="1200" b="0">
+                          <a:solidFill>
+                            <a:srgbClr val="1B2A4A"/>
+                          </a:solidFill>
+                        </a:rPr>
+                        <a:t>0.67</a:t>
+                      </a:r>
+                    </a:p>
+                  </a:txBody>
+                  <a:tcPr marT="12700" marB="12700">
+                    <a:solidFill>
+                      <a:srgbClr val="FFFFFF"/>
+                    </a:solidFill>
+                  </a:tcPr>
+                </a:tc>
+                <a:tc>
+                  <a:txBody>
+                    <a:bodyPr/>
+                    <a:lstStyle/>
+                    <a:p>
+                      <a:pPr algn="ctr"/>
+                      <a:r>
+                        <a:rPr sz="1200" b="1">
+                          <a:solidFill>
+                            <a:srgbClr val="B12A2A"/>
+                          </a:solidFill>
+                        </a:rPr>
+                        <a:t>0.03</a:t>
+                      </a:r>
+                    </a:p>
+                  </a:txBody>
+                  <a:tcPr marT="12700" marB="12700">
+                    <a:solidFill>
+                      <a:srgbClr val="FFFFFF"/>
+                    </a:solidFill>
+                  </a:tcPr>
+                </a:tc>
+                <a:tc>
+                  <a:txBody>
+                    <a:bodyPr/>
+                    <a:lstStyle/>
+                    <a:p>
+                      <a:pPr algn="ctr"/>
+                      <a:r>
+                        <a:rPr sz="1200" b="0">
+                          <a:solidFill>
+                            <a:srgbClr val="1B2A4A"/>
+                          </a:solidFill>
+                        </a:rPr>
+                        <a:t>55.1s</a:t>
+                      </a:r>
+                    </a:p>
+                  </a:txBody>
+                  <a:tcPr marT="12700" marB="12700">
+                    <a:solidFill>
+                      <a:srgbClr val="FFFFFF"/>
+                    </a:solidFill>
+                  </a:tcPr>
+                </a:tc>
+                <a:tc>
+                  <a:txBody>
+                    <a:bodyPr/>
+                    <a:lstStyle/>
+                    <a:p>
+                      <a:pPr algn="ctr"/>
+                      <a:r>
+                        <a:rPr sz="1200" b="0">
+                          <a:solidFill>
+                            <a:srgbClr val="1B2A4A"/>
+                          </a:solidFill>
+                        </a:rPr>
+                        <a:t>99.0s</a:t>
+                      </a:r>
+                    </a:p>
+                  </a:txBody>
+                  <a:tcPr marT="12700" marB="12700">
+                    <a:solidFill>
+                      <a:srgbClr val="FFFFFF"/>
+                    </a:solidFill>
+                  </a:tcPr>
+                </a:tc>
+              </a:tr>
+              <a:tr h="256032">
+                <a:tc>
+                  <a:txBody>
+                    <a:bodyPr/>
+                    <a:lstStyle/>
+                    <a:p>
+                      <a:pPr algn="ctr"/>
+                      <a:r>
+                        <a:rPr sz="1200" b="0">
+                          <a:solidFill>
+                            <a:srgbClr val="1B2A4A"/>
+                          </a:solidFill>
+                        </a:rPr>
+                        <a:t>48</a:t>
+                      </a:r>
+                    </a:p>
+                  </a:txBody>
+                  <a:tcPr marT="12700" marB="12700">
+                    <a:solidFill>
+                      <a:srgbClr val="FFFFFF"/>
+                    </a:solidFill>
+                  </a:tcPr>
+                </a:tc>
+                <a:tc>
+                  <a:txBody>
+                    <a:bodyPr/>
+                    <a:lstStyle/>
+                    <a:p>
+                      <a:pPr algn="ctr"/>
+                      <a:r>
+                        <a:rPr sz="1200" b="0">
+                          <a:solidFill>
+                            <a:srgbClr val="1B2A4A"/>
+                          </a:solidFill>
+                        </a:rPr>
+                        <a:t>0.64</a:t>
+                      </a:r>
+                    </a:p>
+                  </a:txBody>
+                  <a:tcPr marT="12700" marB="12700">
+                    <a:solidFill>
+                      <a:srgbClr val="FFFFFF"/>
+                    </a:solidFill>
+                  </a:tcPr>
+                </a:tc>
+                <a:tc>
+                  <a:txBody>
+                    <a:bodyPr/>
+                    <a:lstStyle/>
+                    <a:p>
+                      <a:pPr algn="ctr"/>
+                      <a:r>
+                        <a:rPr sz="1200" b="1">
+                          <a:solidFill>
+                            <a:srgbClr val="B12A2A"/>
+                          </a:solidFill>
+                        </a:rPr>
+                        <a:t>0.32</a:t>
+                      </a:r>
+                    </a:p>
+                  </a:txBody>
+                  <a:tcPr marT="12700" marB="12700">
+                    <a:solidFill>
+                      <a:srgbClr val="FFFFFF"/>
+                    </a:solidFill>
+                  </a:tcPr>
+                </a:tc>
+                <a:tc>
+                  <a:txBody>
+                    <a:bodyPr/>
+                    <a:lstStyle/>
+                    <a:p>
+                      <a:pPr algn="ctr"/>
+                      <a:r>
+                        <a:rPr sz="1200" b="0">
+                          <a:solidFill>
+                            <a:srgbClr val="1B2A4A"/>
+                          </a:solidFill>
+                        </a:rPr>
+                        <a:t>0.67</a:t>
+                      </a:r>
+                    </a:p>
+                  </a:txBody>
+                  <a:tcPr marT="12700" marB="12700">
+                    <a:solidFill>
+                      <a:srgbClr val="FFFFFF"/>
+                    </a:solidFill>
+                  </a:tcPr>
+                </a:tc>
+                <a:tc>
+                  <a:txBody>
+                    <a:bodyPr/>
+                    <a:lstStyle/>
+                    <a:p>
+                      <a:pPr algn="ctr"/>
+                      <a:r>
+                        <a:rPr sz="1200" b="1">
+                          <a:solidFill>
+                            <a:srgbClr val="B12A2A"/>
+                          </a:solidFill>
+                        </a:rPr>
+                        <a:t>0.02</a:t>
+                      </a:r>
+                    </a:p>
+                  </a:txBody>
+                  <a:tcPr marT="12700" marB="12700">
+                    <a:solidFill>
+                      <a:srgbClr val="FFFFFF"/>
+                    </a:solidFill>
+                  </a:tcPr>
+                </a:tc>
+                <a:tc>
+                  <a:txBody>
+                    <a:bodyPr/>
+                    <a:lstStyle/>
+                    <a:p>
+                      <a:pPr algn="ctr"/>
+                      <a:r>
+                        <a:rPr sz="1200" b="0">
+                          <a:solidFill>
+                            <a:srgbClr val="1B2A4A"/>
+                          </a:solidFill>
+                        </a:rPr>
+                        <a:t>70.2s</a:t>
+                      </a:r>
+                    </a:p>
+                  </a:txBody>
+                  <a:tcPr marT="12700" marB="12700">
+                    <a:solidFill>
+                      <a:srgbClr val="FFFFFF"/>
+                    </a:solidFill>
+                  </a:tcPr>
+                </a:tc>
+                <a:tc>
+                  <a:txBody>
+                    <a:bodyPr/>
+                    <a:lstStyle/>
+                    <a:p>
+                      <a:pPr algn="ctr"/>
+                      <a:r>
+                        <a:rPr sz="1200" b="0">
+                          <a:solidFill>
+                            <a:srgbClr val="1B2A4A"/>
+                          </a:solidFill>
+                        </a:rPr>
+                        <a:t>149.0s</a:t>
+                      </a:r>
+                    </a:p>
+                  </a:txBody>
+                  <a:tcPr marT="12700" marB="12700">
+                    <a:solidFill>
+                      <a:srgbClr val="FFFFFF"/>
+                    </a:solidFill>
+                  </a:tcPr>
+                </a:tc>
+              </a:tr>
+            </a:tbl>
+          </a:graphicData>
+        </a:graphic>
+      </p:graphicFrame>
+      <p:sp>
+        <p:nvSpPr>
+          <p:cNvPr id="7" name="TextBox 6"/>
+          <p:cNvSpPr txBox="1"/>
+          <p:nvPr/>
+        </p:nvSpPr>
+        <p:spPr>
+          <a:xfrm>
+            <a:off x="365760" y="4617720"/>
+            <a:ext cx="11430000" cy="320040"/>
+          </a:xfrm>
+          <a:prstGeom prst="rect">
+            <a:avLst/>
+          </a:prstGeom>
+          <a:noFill/>
+        </p:spPr>
+        <p:txBody>
+          <a:bodyPr wrap="none">
+            <a:spAutoFit/>
+          </a:bodyPr>
+          <a:lstStyle/>
+          <a:p>
+            <a:pPr algn="ctr"/>
+            <a:r>
+              <a:rPr sz="1100" b="1">
+                <a:solidFill>
+                  <a:srgbClr val="1B2A4A"/>
+                </a:solidFill>
+              </a:rPr>
+              <a:t>F 전역 지표 C=8~48 (3회 평균) — default hit·throughput 붕괴(빨강)</a:t>
+            </a:r>
+          </a:p>
+        </p:txBody>
+      </p:sp>
     </p:spTree>
   </p:cSld>
   <p:clrMapOvr>

</xml_diff>

<commit_message>
deck: add Phase G slides + update 2x2 matrix (14->16 slides)
- G1 (throughput recovery vs D: D-tr->G-tr table + global hit graph)
- G2 (per-backend + three-way conclusion: hit table + perbackend_hitrate graph)
- Slide 2 status + slide 14 comparison rebuilt as a 2x2 (data x GPU) matrix:
  §9 +57% / F +100% / D -34% / G -8%(recovered), hit tr wins all 4 cells.
- 16 speaker notes (new G1/G2 + updated 2x2 note). Verified 16 slides, no overflow/overlap.

Co-Authored-By: Claude Opus 4.8 (1M context) <noreply@anthropic.com>
</commit_message>
<xml_diff>
--- a/meeting_hetero_yunuikang.pptx
+++ b/meeting_hetero_yunuikang.pptx
@@ -19,6 +19,8 @@
     <p:sldId id="267" r:id="rId18"/>
     <p:sldId id="268" r:id="rId19"/>
     <p:sldId id="269" r:id="rId20"/>
+    <p:sldId id="270" r:id="rId21"/>
+    <p:sldId id="271" r:id="rId22"/>
   </p:sldIdLst>
   <p:sldSz cx="12191695" cy="6858000" type="screen4x3"/>
   <p:notesSz cx="6858000" cy="9144000"/>
@@ -725,7 +727,7 @@
           <a:lstStyle/>
           <a:p>
             <a:r>
-              <a:t>세 실험을 나란히 놓고 배운 걸 정리합니다. 합성에 동일 GPU였던 기존 실험에선 tr이 처리량 +57%로 이겼고, 실제 데이터에 동일 GPU였던 D에선 tr이 -34%로 졌고, 합성에 이종 GPU였던 F에선 tr이 +100%로 이겼습니다. 그런데 KV 히트율은 세 경우 모두 tr이 압승입니다. 그러니까 tr의 스래싱 억제 능력 자체는 항상 견고한데, 그게 처리량 이득으로 연결되느냐는 프로그램이 GPU KV에 얼마나 육박하는지, 그리고 GPU 용량 구성이 어떤지에 달려 있다—이게 오늘의 핵심 교훈입니다.</a:t>
+              <a:t>이제 2×2의 마지막 칸입니다. 실제 TraceLab 데이터를 4090과 5090 이종에서 돌렸어요. 핵심 질문은, D에서 tr이 잃었던 처리량이 더 큰 5090을 붙이면 회복되느냐였습니다. 결과는 회복됩니다—tr 처리량이 D 대비 1.6에서 1.7배로 올랐고(0.067→0.115), default와의 격차도 34%에서 8%로 좁혀졌습니다. 다만 완전히 역전하진 못했고, 히트율은 여전히 tr 압승(0.68~0.83 대 0.03), p95는 tr이 조금 열세입니다. 즉 큰 GPU가 tr의 실데이터 약점을 상당히 메워줬다는 게 이 칸의 메시지입니다.</a:t>
             </a:r>
           </a:p>
         </p:txBody>
@@ -795,7 +797,7 @@
           <a:lstStyle/>
           <a:p>
             <a:r>
-              <a:t>그럼 다음에 뭘 할 거냐. tr이 5090에 일을 더 보내긴 하는데 그 비율이 1대 1.6이었습니다. 실제 용량비는 1대 2.03인데 말이죠. 즉 tr이 큰 5090의 여유를 다 못 씁니다—처리량이 용량을 51% 늘렸는데 31%밖에 안 올랐어요. 그래서 다음 과제는 용량 비례 라우팅입니다. 방향을 다시 잡자면 '작은 GPU 혹사를 고치는 것'이 아니라 '큰 GPU 활용을 끌어올려 처리량 상단을 높이는 것'입니다. 신규 프로그램을 GPU 용량에 비례해서—가능하면 속도·대역폭까지 반영해서—배정하도록 라우터를 확장하는 게 계획입니다.</a:t>
+              <a:t>백엔드별로 보면 합성 이종(F)에서 봤던 패턴이 실제 데이터에서도 그대로입니다—default는 작은 4090을 가장 심하게 태우고(c48에서 4090 히트 0.03 대 5090 0.06), tr은 두 GPU를 0.67에서 0.87로 균형 있게 유지합니다. 한 가지 차이는, F에선 tr이 큰 5090에 일을 1.6배 더 보냈는데 실제 데이터에선 거의 1대 1로 5090을 덜 활용한다는 점입니다. 그런데도 처리량이 용량 증가분보다 더 많이 올랐다는 건 5090에 아직 여유가 있다는 뜻이라, 용량 비례로 5090에 더 밀면 default를 넘어설 여지가 있습니다—다음 과제로 이어집니다.</a:t>
             </a:r>
           </a:p>
         </p:txBody>
@@ -865,6 +867,146 @@
           <a:lstStyle/>
           <a:p>
             <a:r>
+              <a:t>이제 2×2 네 칸을 다 채웠습니다. 표로 정리하면, 합성에 동일 GPU는 tr 처리량 +57%, 합성에 이종은 +100%, 실데이터에 동일 GPU는 -34%, 실데이터에 이종은 -8%로 회복입니다. KV 히트율은 네 칸 모두 tr 압승이고요. 그러니까 tr의 스래싱 억제 능력 자체는 항상 견고한데, 처리량 이득은 프로그램이 GPU KV에 얼마나 육박하는지와 GPU 용량 구성에 달려 있다—이게 최종 결론입니다. 특히 실데이터에서 큰 5090이 tr의 적자를 34%에서 8%로 줄였다는 게 이종의 의미입니다.</a:t>
+            </a:r>
+          </a:p>
+        </p:txBody>
+      </p:sp>
+      <p:sp>
+        <p:nvSpPr>
+          <p:cNvPr id="4" name="Slide Number Placeholder 3"/>
+          <p:cNvSpPr>
+            <a:spLocks noGrp="1"/>
+          </p:cNvSpPr>
+          <p:nvPr>
+            <p:ph type="sldNum" idx="5" sz="quarter"/>
+          </p:nvPr>
+        </p:nvSpPr>
+        <p:spPr/>
+      </p:sp>
+    </p:spTree>
+  </p:cSld>
+  <p:clrMapOvr>
+    <a:masterClrMapping/>
+  </p:clrMapOvr>
+</p:notes>
+</file>
+
+<file path=ppt/notesSlides/notesSlide15.xml><?xml version="1.0" encoding="utf-8"?>
+<p:notes xmlns:a="http://schemas.openxmlformats.org/drawingml/2006/main" xmlns:p="http://schemas.openxmlformats.org/presentationml/2006/main" xmlns:r="http://schemas.openxmlformats.org/officeDocument/2006/relationships">
+  <p:cSld>
+    <p:spTree>
+      <p:nvGrpSpPr>
+        <p:cNvPr id="1" name=""/>
+        <p:cNvGrpSpPr/>
+        <p:nvPr/>
+      </p:nvGrpSpPr>
+      <p:grpSpPr>
+        <a:xfrm>
+          <a:off x="0" y="0"/>
+          <a:ext cx="0" cy="0"/>
+          <a:chOff x="0" y="0"/>
+          <a:chExt cx="0" cy="0"/>
+        </a:xfrm>
+      </p:grpSpPr>
+      <p:sp>
+        <p:nvSpPr>
+          <p:cNvPr id="2" name="Slide Image Placeholder 1"/>
+          <p:cNvSpPr>
+            <a:spLocks noGrp="1"/>
+          </p:cNvSpPr>
+          <p:nvPr>
+            <p:ph type="sldImg" idx="2"/>
+          </p:nvPr>
+        </p:nvSpPr>
+        <p:spPr/>
+      </p:sp>
+      <p:sp>
+        <p:nvSpPr>
+          <p:cNvPr id="3" name="Notes Placeholder 2"/>
+          <p:cNvSpPr>
+            <a:spLocks noGrp="1"/>
+          </p:cNvSpPr>
+          <p:nvPr>
+            <p:ph type="body" idx="3" sz="quarter"/>
+          </p:nvPr>
+        </p:nvSpPr>
+        <p:spPr/>
+        <p:txBody>
+          <a:bodyPr/>
+          <a:lstStyle/>
+          <a:p>
+            <a:r>
+              <a:t>그럼 다음에 뭘 할 거냐. tr이 5090에 일을 더 보내긴 하는데 그 비율이 1대 1.6이었습니다. 실제 용량비는 1대 2.03인데 말이죠. 즉 tr이 큰 5090의 여유를 다 못 씁니다—처리량이 용량을 51% 늘렸는데 31%밖에 안 올랐어요. 그래서 다음 과제는 용량 비례 라우팅입니다. 방향을 다시 잡자면 '작은 GPU 혹사를 고치는 것'이 아니라 '큰 GPU 활용을 끌어올려 처리량 상단을 높이는 것'입니다. 신규 프로그램을 GPU 용량에 비례해서—가능하면 속도·대역폭까지 반영해서—배정하도록 라우터를 확장하는 게 계획입니다.</a:t>
+            </a:r>
+          </a:p>
+        </p:txBody>
+      </p:sp>
+      <p:sp>
+        <p:nvSpPr>
+          <p:cNvPr id="4" name="Slide Number Placeholder 3"/>
+          <p:cNvSpPr>
+            <a:spLocks noGrp="1"/>
+          </p:cNvSpPr>
+          <p:nvPr>
+            <p:ph type="sldNum" idx="5" sz="quarter"/>
+          </p:nvPr>
+        </p:nvSpPr>
+        <p:spPr/>
+      </p:sp>
+    </p:spTree>
+  </p:cSld>
+  <p:clrMapOvr>
+    <a:masterClrMapping/>
+  </p:clrMapOvr>
+</p:notes>
+</file>
+
+<file path=ppt/notesSlides/notesSlide16.xml><?xml version="1.0" encoding="utf-8"?>
+<p:notes xmlns:a="http://schemas.openxmlformats.org/drawingml/2006/main" xmlns:p="http://schemas.openxmlformats.org/presentationml/2006/main" xmlns:r="http://schemas.openxmlformats.org/officeDocument/2006/relationships">
+  <p:cSld>
+    <p:spTree>
+      <p:nvGrpSpPr>
+        <p:cNvPr id="1" name=""/>
+        <p:cNvGrpSpPr/>
+        <p:nvPr/>
+      </p:nvGrpSpPr>
+      <p:grpSpPr>
+        <a:xfrm>
+          <a:off x="0" y="0"/>
+          <a:ext cx="0" cy="0"/>
+          <a:chOff x="0" y="0"/>
+          <a:chExt cx="0" cy="0"/>
+        </a:xfrm>
+      </p:grpSpPr>
+      <p:sp>
+        <p:nvSpPr>
+          <p:cNvPr id="2" name="Slide Image Placeholder 1"/>
+          <p:cNvSpPr>
+            <a:spLocks noGrp="1"/>
+          </p:cNvSpPr>
+          <p:nvPr>
+            <p:ph type="sldImg" idx="2"/>
+          </p:nvPr>
+        </p:nvSpPr>
+        <p:spPr/>
+      </p:sp>
+      <p:sp>
+        <p:nvSpPr>
+          <p:cNvPr id="3" name="Notes Placeholder 2"/>
+          <p:cNvSpPr>
+            <a:spLocks noGrp="1"/>
+          </p:cNvSpPr>
+          <p:nvPr>
+            <p:ph type="body" idx="3" sz="quarter"/>
+          </p:nvPr>
+        </p:nvSpPr>
+        <p:spPr/>
+        <p:txBody>
+          <a:bodyPr/>
+          <a:lstStyle/>
+          <a:p>
+            <a:r>
               <a:t>마지막으로 한계도 솔직히 말씀드립니다. 각 점을 3번만 반복해서 tr의 pause 타이밍에 따른 편차가 남아 있고, F 실험은 합성 워크로드라 실제 분포와 다릅니다. 백엔드별 부하를 prefix-cache 쿼리 수로 근사했는데 이건 재프리필이 섞여서 순수 라우팅된 프로그램 수와는 다릅니다. 또 D의 데이터는 32k 이하로 맞춘 서브셋이라—전체 턴의 92.5%가 32k를 넘어 제외됐거든요—짧은 세션 쪽 편향이 있습니다. SWE-bench 녹화와 cross-node 실험은 다음 미팅 이후로 미뤘고, 다음 단계는 용량 비례 라우팅을 구현해 D와 F를 다시 돌려 검증하는 겁니다.</a:t>
             </a:r>
           </a:p>
@@ -935,7 +1077,7 @@
           <a:lstStyle/>
           <a:p>
             <a:r>
-              <a:t>ThunderAgent가 푸는 문제부터요. 에이전트는 한 작업을 여러 턴에 걸쳐 처리하는데, 턴 사이에 툴을 호출하는 동안 그 프로그램의 KV 캐시—지금까지 계산해둔 문맥—가 GPU 메모리에서 밀려나 축출될 수 있습니다. 그러면 다음 턴에 그 문맥을 처음부터 다시 계산해야 하는데, 이걸 재프리필, 이게 심해지는 걸 스래싱이라고 부릅니다. tr 라우터는 프로그램 단위로 관리해서 활성 프로그램들의 KV가 GPU 용량 안에 들어오도록 유지하고, 초과하면 잠시 멈췄다 재개시켜 이 스래싱을 막습니다. 저희는 이걸 데이터 축(합성 대 실제)과 GPU 축(동일 대 이종) 둘로 나눠 봤고, 오늘은 실제 데이터(D)와 이종 GPU(F) 칸을 채운 겁니다.</a:t>
+              <a:t>ThunderAgent가 푸는 문제부터요. 에이전트는 한 작업을 여러 턴에 걸쳐 처리하는데, 턴 사이에 툴을 호출하는 동안 그 프로그램의 KV 캐시—지금까지 계산해둔 문맥—가 GPU 메모리에서 밀려나 축출될 수 있습니다. 그러면 다음 턴에 그 문맥을 처음부터 다시 계산해야 하는데, 이걸 재프리필, 이게 심해지는 걸 스래싱이라고 부릅니다. tr 라우터는 프로그램 단위로 관리해서 활성 프로그램들의 KV가 GPU 용량 안에 들어오도록 유지하고, 초과하면 잠시 멈췄다 재개시켜 이 스래싱을 막습니다. 저희는 이걸 데이터 축(합성 대 실제)과 GPU 축(동일 대 이종) 둘로 나눠 봤고, 오늘은 나머지 세 칸(D·F·G)을 채워 2×2 매트릭스를 완성한 겁니다.</a:t>
             </a:r>
           </a:p>
         </p:txBody>
@@ -5864,7 +6006,7 @@
                   <a:srgbClr val="1B2A4A"/>
                 </a:solidFill>
               </a:rPr>
-              <a:t>종합: 언제 tr이 이기고 지는가 (homo-homo vs D vs F)</a:t>
+              <a:t>G 결과 ① — 실 TraceLab × 이종: tr throughput 회복 (vs D)</a:t>
             </a:r>
           </a:p>
         </p:txBody>
@@ -5912,47 +6054,133 @@
           </a:p>
         </p:txBody>
       </p:sp>
+      <p:sp>
+        <p:nvSpPr>
+          <p:cNvPr id="4" name="TextBox 3"/>
+          <p:cNvSpPr txBox="1"/>
+          <p:nvPr/>
+        </p:nvSpPr>
+        <p:spPr>
+          <a:xfrm>
+            <a:off x="502920" y="1188720"/>
+            <a:ext cx="5760720" cy="1828800"/>
+          </a:xfrm>
+          <a:prstGeom prst="rect">
+            <a:avLst/>
+          </a:prstGeom>
+          <a:noFill/>
+        </p:spPr>
+        <p:txBody>
+          <a:bodyPr wrap="square">
+            <a:spAutoFit/>
+          </a:bodyPr>
+          <a:lstStyle/>
+          <a:p>
+            <a:pPr>
+              <a:spcAft>
+                <a:spcPts val="700"/>
+              </a:spcAft>
+            </a:pPr>
+            <a:r>
+              <a:rPr sz="1400" b="1">
+                <a:solidFill>
+                  <a:srgbClr val="1B2A4A"/>
+                </a:solidFill>
+              </a:rPr>
+              <a:t>실데이터를 4090+5090으로: D(2×4090)에서 tr이 잃은 throughput이 회복되나?</a:t>
+            </a:r>
+          </a:p>
+          <a:p>
+            <a:pPr lvl="1">
+              <a:spcAft>
+                <a:spcPts val="700"/>
+              </a:spcAft>
+            </a:pPr>
+            <a:r>
+              <a:rPr sz="1200" b="0">
+                <a:solidFill>
+                  <a:srgbClr val="1E7A3C"/>
+                </a:solidFill>
+              </a:rPr>
+              <a:t>tr throughput D 대비 1.6~1.7× 회복 (D 0.067~0.078 → G 0.115~0.126)</a:t>
+            </a:r>
+          </a:p>
+          <a:p>
+            <a:pPr lvl="1">
+              <a:spcAft>
+                <a:spcPts val="700"/>
+              </a:spcAft>
+            </a:pPr>
+            <a:r>
+              <a:rPr sz="1200" b="0">
+                <a:solidFill>
+                  <a:srgbClr val="1B2A4A"/>
+                </a:solidFill>
+              </a:rPr>
+              <a:t>default와 격차 34%→8%로 축소(c48) — 단 완전 역전은 아님</a:t>
+            </a:r>
+          </a:p>
+          <a:p>
+            <a:pPr>
+              <a:spcAft>
+                <a:spcPts val="700"/>
+              </a:spcAft>
+            </a:pPr>
+            <a:r>
+              <a:rPr sz="1400" b="1">
+                <a:solidFill>
+                  <a:srgbClr val="1B2A4A"/>
+                </a:solidFill>
+              </a:rPr>
+              <a:t>hit rate는 tr 압승 유지(0.68~0.83 vs 0.03). p95는 tr 여전히 열세(D 패턴).</a:t>
+            </a:r>
+          </a:p>
+        </p:txBody>
+      </p:sp>
       <p:graphicFrame>
         <p:nvGraphicFramePr>
-          <p:cNvPr id="4" name="Table 3"/>
+          <p:cNvPr id="5" name="Table 4"/>
           <p:cNvGraphicFramePr>
             <a:graphicFrameLocks noGrp="1"/>
           </p:cNvGraphicFramePr>
           <p:nvPr/>
         </p:nvGraphicFramePr>
         <p:xfrm>
-          <a:off x="548640" y="1371600"/>
-          <a:ext cx="11064240" cy="2377440"/>
+          <a:off x="457200" y="3200400"/>
+          <a:ext cx="5760720" cy="1371600"/>
         </p:xfrm>
         <a:graphic>
           <a:graphicData uri="http://schemas.openxmlformats.org/drawingml/2006/table">
             <a:tbl>
-              <a:tblPr firstRow="1" bandRow="1">
+              <a:tblPr>
                 <a:tableStyleId>{5C22544A-7EE6-4342-B048-85BDC9FD1C3A}</a:tableStyleId>
               </a:tblPr>
               <a:tblGrid>
-                <a:gridCol w="2468880"/>
-                <a:gridCol w="2926080"/>
-                <a:gridCol w="3108960"/>
-                <a:gridCol w="2560320"/>
+                <a:gridCol w="640080"/>
+                <a:gridCol w="1005840"/>
+                <a:gridCol w="1005840"/>
+                <a:gridCol w="1005840"/>
+                <a:gridCol w="1051560"/>
+                <a:gridCol w="1051560"/>
               </a:tblGrid>
-              <a:tr h="594360">
-                <a:tc>
-                  <a:txBody>
-                    <a:bodyPr/>
-                    <a:lstStyle/>
-                    <a:p>
-                      <a:r>
-                        <a:rPr sz="1300" b="1">
+              <a:tr h="274320">
+                <a:tc>
+                  <a:txBody>
+                    <a:bodyPr/>
+                    <a:lstStyle/>
+                    <a:p>
+                      <a:pPr algn="ctr"/>
+                      <a:r>
+                        <a:rPr sz="1200" b="1">
                           <a:solidFill>
                             <a:srgbClr val="FFFFFF"/>
                           </a:solidFill>
                         </a:rPr>
-                        <a:t>실험</a:t>
-                      </a:r>
-                    </a:p>
-                  </a:txBody>
-                  <a:tcPr>
+                        <a:t>C</a:t>
+                      </a:r>
+                    </a:p>
+                  </a:txBody>
+                  <a:tcPr marT="12700" marB="12700">
                     <a:solidFill>
                       <a:srgbClr val="1B2A4A"/>
                     </a:solidFill>
@@ -5963,17 +6191,18 @@
                     <a:bodyPr/>
                     <a:lstStyle/>
                     <a:p>
-                      <a:r>
-                        <a:rPr sz="1300" b="1">
+                      <a:pPr algn="ctr"/>
+                      <a:r>
+                        <a:rPr sz="1200" b="1">
                           <a:solidFill>
                             <a:srgbClr val="FFFFFF"/>
                           </a:solidFill>
                         </a:rPr>
-                        <a:t>워크로드 / HW</a:t>
-                      </a:r>
-                    </a:p>
-                  </a:txBody>
-                  <a:tcPr>
+                        <a:t>D tr</a:t>
+                      </a:r>
+                    </a:p>
+                  </a:txBody>
+                  <a:tcPr marT="12700" marB="12700">
                     <a:solidFill>
                       <a:srgbClr val="1B2A4A"/>
                     </a:solidFill>
@@ -5984,17 +6213,18 @@
                     <a:bodyPr/>
                     <a:lstStyle/>
                     <a:p>
-                      <a:r>
-                        <a:rPr sz="1300" b="1">
+                      <a:pPr algn="ctr"/>
+                      <a:r>
+                        <a:rPr sz="1200" b="1">
                           <a:solidFill>
                             <a:srgbClr val="FFFFFF"/>
                           </a:solidFill>
                         </a:rPr>
-                        <a:t>tr throughput 이득</a:t>
-                      </a:r>
-                    </a:p>
-                  </a:txBody>
-                  <a:tcPr>
+                        <a:t>G tr</a:t>
+                      </a:r>
+                    </a:p>
+                  </a:txBody>
+                  <a:tcPr marT="12700" marB="12700">
                     <a:solidFill>
                       <a:srgbClr val="1B2A4A"/>
                     </a:solidFill>
@@ -6005,231 +6235,602 @@
                     <a:bodyPr/>
                     <a:lstStyle/>
                     <a:p>
-                      <a:r>
-                        <a:rPr sz="1300" b="1">
+                      <a:pPr algn="ctr"/>
+                      <a:r>
+                        <a:rPr sz="1200" b="1">
                           <a:solidFill>
                             <a:srgbClr val="FFFFFF"/>
                           </a:solidFill>
                         </a:rPr>
-                        <a:t>tr KV hit 이득</a:t>
-                      </a:r>
-                    </a:p>
-                  </a:txBody>
-                  <a:tcPr>
+                        <a:t>G def</a:t>
+                      </a:r>
+                    </a:p>
+                  </a:txBody>
+                  <a:tcPr marT="12700" marB="12700">
                     <a:solidFill>
                       <a:srgbClr val="1B2A4A"/>
                     </a:solidFill>
                   </a:tcPr>
                 </a:tc>
+                <a:tc>
+                  <a:txBody>
+                    <a:bodyPr/>
+                    <a:lstStyle/>
+                    <a:p>
+                      <a:pPr algn="ctr"/>
+                      <a:r>
+                        <a:rPr sz="1200" b="1">
+                          <a:solidFill>
+                            <a:srgbClr val="FFFFFF"/>
+                          </a:solidFill>
+                        </a:rPr>
+                        <a:t>hit tr</a:t>
+                      </a:r>
+                    </a:p>
+                  </a:txBody>
+                  <a:tcPr marT="12700" marB="12700">
+                    <a:solidFill>
+                      <a:srgbClr val="1B2A4A"/>
+                    </a:solidFill>
+                  </a:tcPr>
+                </a:tc>
+                <a:tc>
+                  <a:txBody>
+                    <a:bodyPr/>
+                    <a:lstStyle/>
+                    <a:p>
+                      <a:pPr algn="ctr"/>
+                      <a:r>
+                        <a:rPr sz="1200" b="1">
+                          <a:solidFill>
+                            <a:srgbClr val="FFFFFF"/>
+                          </a:solidFill>
+                        </a:rPr>
+                        <a:t>hit def</a:t>
+                      </a:r>
+                    </a:p>
+                  </a:txBody>
+                  <a:tcPr marT="12700" marB="12700">
+                    <a:solidFill>
+                      <a:srgbClr val="1B2A4A"/>
+                    </a:solidFill>
+                  </a:tcPr>
+                </a:tc>
               </a:tr>
-              <a:tr h="594360">
-                <a:tc>
-                  <a:txBody>
-                    <a:bodyPr/>
-                    <a:lstStyle/>
-                    <a:p>
-                      <a:r>
-                        <a:rPr sz="1300">
+              <a:tr h="274320">
+                <a:tc>
+                  <a:txBody>
+                    <a:bodyPr/>
+                    <a:lstStyle/>
+                    <a:p>
+                      <a:pPr algn="ctr"/>
+                      <a:r>
+                        <a:rPr sz="1200" b="0">
                           <a:solidFill>
                             <a:srgbClr val="1B2A4A"/>
                           </a:solidFill>
                         </a:rPr>
-                        <a:t>homo-homo §9 (합성)</a:t>
-                      </a:r>
-                    </a:p>
-                  </a:txBody>
-                  <a:tcPr/>
-                </a:tc>
-                <a:tc>
-                  <a:txBody>
-                    <a:bodyPr/>
-                    <a:lstStyle/>
-                    <a:p>
-                      <a:r>
-                        <a:rPr sz="1300">
+                        <a:t>8</a:t>
+                      </a:r>
+                    </a:p>
+                  </a:txBody>
+                  <a:tcPr marT="12700" marB="12700">
+                    <a:solidFill>
+                      <a:srgbClr val="FFFFFF"/>
+                    </a:solidFill>
+                  </a:tcPr>
+                </a:tc>
+                <a:tc>
+                  <a:txBody>
+                    <a:bodyPr/>
+                    <a:lstStyle/>
+                    <a:p>
+                      <a:pPr algn="ctr"/>
+                      <a:r>
+                        <a:rPr sz="1200" b="0">
                           <a:solidFill>
                             <a:srgbClr val="1B2A4A"/>
                           </a:solidFill>
                         </a:rPr>
-                        <a:t>합성 KV압박 / 2×4090</a:t>
-                      </a:r>
-                    </a:p>
-                  </a:txBody>
-                  <a:tcPr/>
-                </a:tc>
-                <a:tc>
-                  <a:txBody>
-                    <a:bodyPr/>
-                    <a:lstStyle/>
-                    <a:p>
-                      <a:r>
-                        <a:rPr sz="1300">
+                        <a:t>0.078</a:t>
+                      </a:r>
+                    </a:p>
+                  </a:txBody>
+                  <a:tcPr marT="12700" marB="12700">
+                    <a:solidFill>
+                      <a:srgbClr val="FFFFFF"/>
+                    </a:solidFill>
+                  </a:tcPr>
+                </a:tc>
+                <a:tc>
+                  <a:txBody>
+                    <a:bodyPr/>
+                    <a:lstStyle/>
+                    <a:p>
+                      <a:pPr algn="ctr"/>
+                      <a:r>
+                        <a:rPr sz="1200" b="0">
                           <a:solidFill>
                             <a:srgbClr val="1B2A4A"/>
                           </a:solidFill>
                         </a:rPr>
-                        <a:t>+57% (0.49 vs 0.30)</a:t>
-                      </a:r>
-                    </a:p>
-                  </a:txBody>
-                  <a:tcPr/>
-                </a:tc>
-                <a:tc>
-                  <a:txBody>
-                    <a:bodyPr/>
-                    <a:lstStyle/>
-                    <a:p>
-                      <a:r>
-                        <a:rPr sz="1300">
+                        <a:t>0.126</a:t>
+                      </a:r>
+                    </a:p>
+                  </a:txBody>
+                  <a:tcPr marT="12700" marB="12700">
+                    <a:solidFill>
+                      <a:srgbClr val="FFFFFF"/>
+                    </a:solidFill>
+                  </a:tcPr>
+                </a:tc>
+                <a:tc>
+                  <a:txBody>
+                    <a:bodyPr/>
+                    <a:lstStyle/>
+                    <a:p>
+                      <a:pPr algn="ctr"/>
+                      <a:r>
+                        <a:rPr sz="1200" b="0">
                           <a:solidFill>
                             <a:srgbClr val="1B2A4A"/>
                           </a:solidFill>
                         </a:rPr>
-                        <a:t>0.67 vs 0.02 (압승)</a:t>
-                      </a:r>
-                    </a:p>
-                  </a:txBody>
-                  <a:tcPr/>
+                        <a:t>0.154</a:t>
+                      </a:r>
+                    </a:p>
+                  </a:txBody>
+                  <a:tcPr marT="12700" marB="12700">
+                    <a:solidFill>
+                      <a:srgbClr val="FFFFFF"/>
+                    </a:solidFill>
+                  </a:tcPr>
+                </a:tc>
+                <a:tc>
+                  <a:txBody>
+                    <a:bodyPr/>
+                    <a:lstStyle/>
+                    <a:p>
+                      <a:pPr algn="ctr"/>
+                      <a:r>
+                        <a:rPr sz="1200" b="0">
+                          <a:solidFill>
+                            <a:srgbClr val="1B2A4A"/>
+                          </a:solidFill>
+                        </a:rPr>
+                        <a:t>0.77</a:t>
+                      </a:r>
+                    </a:p>
+                  </a:txBody>
+                  <a:tcPr marT="12700" marB="12700">
+                    <a:solidFill>
+                      <a:srgbClr val="FFFFFF"/>
+                    </a:solidFill>
+                  </a:tcPr>
+                </a:tc>
+                <a:tc>
+                  <a:txBody>
+                    <a:bodyPr/>
+                    <a:lstStyle/>
+                    <a:p>
+                      <a:pPr algn="ctr"/>
+                      <a:r>
+                        <a:rPr sz="1200" b="1">
+                          <a:solidFill>
+                            <a:srgbClr val="B12A2A"/>
+                          </a:solidFill>
+                        </a:rPr>
+                        <a:t>0.39</a:t>
+                      </a:r>
+                    </a:p>
+                  </a:txBody>
+                  <a:tcPr marT="12700" marB="12700">
+                    <a:solidFill>
+                      <a:srgbClr val="FFFFFF"/>
+                    </a:solidFill>
+                  </a:tcPr>
                 </a:tc>
               </a:tr>
-              <a:tr h="594360">
-                <a:tc>
-                  <a:txBody>
-                    <a:bodyPr/>
-                    <a:lstStyle/>
-                    <a:p>
-                      <a:r>
-                        <a:rPr sz="1300">
+              <a:tr h="274320">
+                <a:tc>
+                  <a:txBody>
+                    <a:bodyPr/>
+                    <a:lstStyle/>
+                    <a:p>
+                      <a:pPr algn="ctr"/>
+                      <a:r>
+                        <a:rPr sz="1200" b="0">
                           <a:solidFill>
                             <a:srgbClr val="1B2A4A"/>
                           </a:solidFill>
                         </a:rPr>
-                        <a:t>D (실데이터)</a:t>
-                      </a:r>
-                    </a:p>
-                  </a:txBody>
-                  <a:tcPr/>
-                </a:tc>
-                <a:tc>
-                  <a:txBody>
-                    <a:bodyPr/>
-                    <a:lstStyle/>
-                    <a:p>
-                      <a:r>
-                        <a:rPr sz="1300">
+                        <a:t>16</a:t>
+                      </a:r>
+                    </a:p>
+                  </a:txBody>
+                  <a:tcPr marT="12700" marB="12700">
+                    <a:solidFill>
+                      <a:srgbClr val="FFFFFF"/>
+                    </a:solidFill>
+                  </a:tcPr>
+                </a:tc>
+                <a:tc>
+                  <a:txBody>
+                    <a:bodyPr/>
+                    <a:lstStyle/>
+                    <a:p>
+                      <a:pPr algn="ctr"/>
+                      <a:r>
+                        <a:rPr sz="1200" b="0">
                           <a:solidFill>
                             <a:srgbClr val="1B2A4A"/>
                           </a:solidFill>
                         </a:rPr>
-                        <a:t>TraceLab / 2×4090</a:t>
-                      </a:r>
-                    </a:p>
-                  </a:txBody>
-                  <a:tcPr/>
-                </a:tc>
-                <a:tc>
-                  <a:txBody>
-                    <a:bodyPr/>
-                    <a:lstStyle/>
-                    <a:p>
-                      <a:r>
-                        <a:rPr sz="1300">
+                        <a:t>0.073</a:t>
+                      </a:r>
+                    </a:p>
+                  </a:txBody>
+                  <a:tcPr marT="12700" marB="12700">
+                    <a:solidFill>
+                      <a:srgbClr val="FFFFFF"/>
+                    </a:solidFill>
+                  </a:tcPr>
+                </a:tc>
+                <a:tc>
+                  <a:txBody>
+                    <a:bodyPr/>
+                    <a:lstStyle/>
+                    <a:p>
+                      <a:pPr algn="ctr"/>
+                      <a:r>
+                        <a:rPr sz="1200" b="0">
                           <a:solidFill>
                             <a:srgbClr val="1B2A4A"/>
                           </a:solidFill>
                         </a:rPr>
-                        <a:t>−34% (0.067 vs 0.102)</a:t>
-                      </a:r>
-                    </a:p>
-                  </a:txBody>
-                  <a:tcPr/>
-                </a:tc>
-                <a:tc>
-                  <a:txBody>
-                    <a:bodyPr/>
-                    <a:lstStyle/>
-                    <a:p>
-                      <a:r>
-                        <a:rPr sz="1300">
+                        <a:t>0.116</a:t>
+                      </a:r>
+                    </a:p>
+                  </a:txBody>
+                  <a:tcPr marT="12700" marB="12700">
+                    <a:solidFill>
+                      <a:srgbClr val="FFFFFF"/>
+                    </a:solidFill>
+                  </a:tcPr>
+                </a:tc>
+                <a:tc>
+                  <a:txBody>
+                    <a:bodyPr/>
+                    <a:lstStyle/>
+                    <a:p>
+                      <a:pPr algn="ctr"/>
+                      <a:r>
+                        <a:rPr sz="1200" b="0">
                           <a:solidFill>
                             <a:srgbClr val="1B2A4A"/>
                           </a:solidFill>
                         </a:rPr>
-                        <a:t>0.77 vs 0.026 (압승)</a:t>
-                      </a:r>
-                    </a:p>
-                  </a:txBody>
-                  <a:tcPr/>
+                        <a:t>0.143</a:t>
+                      </a:r>
+                    </a:p>
+                  </a:txBody>
+                  <a:tcPr marT="12700" marB="12700">
+                    <a:solidFill>
+                      <a:srgbClr val="FFFFFF"/>
+                    </a:solidFill>
+                  </a:tcPr>
+                </a:tc>
+                <a:tc>
+                  <a:txBody>
+                    <a:bodyPr/>
+                    <a:lstStyle/>
+                    <a:p>
+                      <a:pPr algn="ctr"/>
+                      <a:r>
+                        <a:rPr sz="1200" b="0">
+                          <a:solidFill>
+                            <a:srgbClr val="1B2A4A"/>
+                          </a:solidFill>
+                        </a:rPr>
+                        <a:t>0.74</a:t>
+                      </a:r>
+                    </a:p>
+                  </a:txBody>
+                  <a:tcPr marT="12700" marB="12700">
+                    <a:solidFill>
+                      <a:srgbClr val="FFFFFF"/>
+                    </a:solidFill>
+                  </a:tcPr>
+                </a:tc>
+                <a:tc>
+                  <a:txBody>
+                    <a:bodyPr/>
+                    <a:lstStyle/>
+                    <a:p>
+                      <a:pPr algn="ctr"/>
+                      <a:r>
+                        <a:rPr sz="1200" b="1">
+                          <a:solidFill>
+                            <a:srgbClr val="B12A2A"/>
+                          </a:solidFill>
+                        </a:rPr>
+                        <a:t>0.07</a:t>
+                      </a:r>
+                    </a:p>
+                  </a:txBody>
+                  <a:tcPr marT="12700" marB="12700">
+                    <a:solidFill>
+                      <a:srgbClr val="FFFFFF"/>
+                    </a:solidFill>
+                  </a:tcPr>
                 </a:tc>
               </a:tr>
-              <a:tr h="594360">
-                <a:tc>
-                  <a:txBody>
-                    <a:bodyPr/>
-                    <a:lstStyle/>
-                    <a:p>
-                      <a:r>
-                        <a:rPr sz="1300">
+              <a:tr h="274320">
+                <a:tc>
+                  <a:txBody>
+                    <a:bodyPr/>
+                    <a:lstStyle/>
+                    <a:p>
+                      <a:pPr algn="ctr"/>
+                      <a:r>
+                        <a:rPr sz="1200" b="0">
                           <a:solidFill>
                             <a:srgbClr val="1B2A4A"/>
                           </a:solidFill>
                         </a:rPr>
-                        <a:t>F (이종)</a:t>
-                      </a:r>
-                    </a:p>
-                  </a:txBody>
-                  <a:tcPr/>
-                </a:tc>
-                <a:tc>
-                  <a:txBody>
-                    <a:bodyPr/>
-                    <a:lstStyle/>
-                    <a:p>
-                      <a:r>
-                        <a:rPr sz="1300">
+                        <a:t>32</a:t>
+                      </a:r>
+                    </a:p>
+                  </a:txBody>
+                  <a:tcPr marT="12700" marB="12700">
+                    <a:solidFill>
+                      <a:srgbClr val="FFFFFF"/>
+                    </a:solidFill>
+                  </a:tcPr>
+                </a:tc>
+                <a:tc>
+                  <a:txBody>
+                    <a:bodyPr/>
+                    <a:lstStyle/>
+                    <a:p>
+                      <a:pPr algn="ctr"/>
+                      <a:r>
+                        <a:rPr sz="1200" b="0">
                           <a:solidFill>
                             <a:srgbClr val="1B2A4A"/>
                           </a:solidFill>
                         </a:rPr>
-                        <a:t>합성 / 4090+5090</a:t>
-                      </a:r>
-                    </a:p>
-                  </a:txBody>
-                  <a:tcPr/>
-                </a:tc>
-                <a:tc>
-                  <a:txBody>
-                    <a:bodyPr/>
-                    <a:lstStyle/>
-                    <a:p>
-                      <a:r>
-                        <a:rPr sz="1300">
+                        <a:t>0.069</a:t>
+                      </a:r>
+                    </a:p>
+                  </a:txBody>
+                  <a:tcPr marT="12700" marB="12700">
+                    <a:solidFill>
+                      <a:srgbClr val="FFFFFF"/>
+                    </a:solidFill>
+                  </a:tcPr>
+                </a:tc>
+                <a:tc>
+                  <a:txBody>
+                    <a:bodyPr/>
+                    <a:lstStyle/>
+                    <a:p>
+                      <a:pPr algn="ctr"/>
+                      <a:r>
+                        <a:rPr sz="1200" b="0">
                           <a:solidFill>
                             <a:srgbClr val="1B2A4A"/>
                           </a:solidFill>
                         </a:rPr>
-                        <a:t>+100% (0.64 vs 0.32)</a:t>
-                      </a:r>
-                    </a:p>
-                  </a:txBody>
-                  <a:tcPr/>
-                </a:tc>
-                <a:tc>
-                  <a:txBody>
-                    <a:bodyPr/>
-                    <a:lstStyle/>
-                    <a:p>
-                      <a:r>
-                        <a:rPr sz="1300">
+                        <a:t>0.116</a:t>
+                      </a:r>
+                    </a:p>
+                  </a:txBody>
+                  <a:tcPr marT="12700" marB="12700">
+                    <a:solidFill>
+                      <a:srgbClr val="FFFFFF"/>
+                    </a:solidFill>
+                  </a:tcPr>
+                </a:tc>
+                <a:tc>
+                  <a:txBody>
+                    <a:bodyPr/>
+                    <a:lstStyle/>
+                    <a:p>
+                      <a:pPr algn="ctr"/>
+                      <a:r>
+                        <a:rPr sz="1200" b="0">
                           <a:solidFill>
                             <a:srgbClr val="1B2A4A"/>
                           </a:solidFill>
                         </a:rPr>
-                        <a:t>0.67 vs 0.02 (압승)</a:t>
-                      </a:r>
-                    </a:p>
-                  </a:txBody>
-                  <a:tcPr/>
+                        <a:t>0.132</a:t>
+                      </a:r>
+                    </a:p>
+                  </a:txBody>
+                  <a:tcPr marT="12700" marB="12700">
+                    <a:solidFill>
+                      <a:srgbClr val="FFFFFF"/>
+                    </a:solidFill>
+                  </a:tcPr>
+                </a:tc>
+                <a:tc>
+                  <a:txBody>
+                    <a:bodyPr/>
+                    <a:lstStyle/>
+                    <a:p>
+                      <a:pPr algn="ctr"/>
+                      <a:r>
+                        <a:rPr sz="1200" b="0">
+                          <a:solidFill>
+                            <a:srgbClr val="1B2A4A"/>
+                          </a:solidFill>
+                        </a:rPr>
+                        <a:t>0.73</a:t>
+                      </a:r>
+                    </a:p>
+                  </a:txBody>
+                  <a:tcPr marT="12700" marB="12700">
+                    <a:solidFill>
+                      <a:srgbClr val="FFFFFF"/>
+                    </a:solidFill>
+                  </a:tcPr>
+                </a:tc>
+                <a:tc>
+                  <a:txBody>
+                    <a:bodyPr/>
+                    <a:lstStyle/>
+                    <a:p>
+                      <a:pPr algn="ctr"/>
+                      <a:r>
+                        <a:rPr sz="1200" b="1">
+                          <a:solidFill>
+                            <a:srgbClr val="B12A2A"/>
+                          </a:solidFill>
+                        </a:rPr>
+                        <a:t>0.03</a:t>
+                      </a:r>
+                    </a:p>
+                  </a:txBody>
+                  <a:tcPr marT="12700" marB="12700">
+                    <a:solidFill>
+                      <a:srgbClr val="FFFFFF"/>
+                    </a:solidFill>
+                  </a:tcPr>
+                </a:tc>
+              </a:tr>
+              <a:tr h="274320">
+                <a:tc>
+                  <a:txBody>
+                    <a:bodyPr/>
+                    <a:lstStyle/>
+                    <a:p>
+                      <a:pPr algn="ctr"/>
+                      <a:r>
+                        <a:rPr sz="1200" b="0">
+                          <a:solidFill>
+                            <a:srgbClr val="1B2A4A"/>
+                          </a:solidFill>
+                        </a:rPr>
+                        <a:t>48</a:t>
+                      </a:r>
+                    </a:p>
+                  </a:txBody>
+                  <a:tcPr marT="12700" marB="12700">
+                    <a:solidFill>
+                      <a:srgbClr val="FFFFFF"/>
+                    </a:solidFill>
+                  </a:tcPr>
+                </a:tc>
+                <a:tc>
+                  <a:txBody>
+                    <a:bodyPr/>
+                    <a:lstStyle/>
+                    <a:p>
+                      <a:pPr algn="ctr"/>
+                      <a:r>
+                        <a:rPr sz="1200" b="0">
+                          <a:solidFill>
+                            <a:srgbClr val="1B2A4A"/>
+                          </a:solidFill>
+                        </a:rPr>
+                        <a:t>0.067</a:t>
+                      </a:r>
+                    </a:p>
+                  </a:txBody>
+                  <a:tcPr marT="12700" marB="12700">
+                    <a:solidFill>
+                      <a:srgbClr val="FFFFFF"/>
+                    </a:solidFill>
+                  </a:tcPr>
+                </a:tc>
+                <a:tc>
+                  <a:txBody>
+                    <a:bodyPr/>
+                    <a:lstStyle/>
+                    <a:p>
+                      <a:pPr algn="ctr"/>
+                      <a:r>
+                        <a:rPr sz="1200" b="0">
+                          <a:solidFill>
+                            <a:srgbClr val="1B2A4A"/>
+                          </a:solidFill>
+                        </a:rPr>
+                        <a:t>0.115</a:t>
+                      </a:r>
+                    </a:p>
+                  </a:txBody>
+                  <a:tcPr marT="12700" marB="12700">
+                    <a:solidFill>
+                      <a:srgbClr val="FFFFFF"/>
+                    </a:solidFill>
+                  </a:tcPr>
+                </a:tc>
+                <a:tc>
+                  <a:txBody>
+                    <a:bodyPr/>
+                    <a:lstStyle/>
+                    <a:p>
+                      <a:pPr algn="ctr"/>
+                      <a:r>
+                        <a:rPr sz="1200" b="0">
+                          <a:solidFill>
+                            <a:srgbClr val="1B2A4A"/>
+                          </a:solidFill>
+                        </a:rPr>
+                        <a:t>0.125</a:t>
+                      </a:r>
+                    </a:p>
+                  </a:txBody>
+                  <a:tcPr marT="12700" marB="12700">
+                    <a:solidFill>
+                      <a:srgbClr val="FFFFFF"/>
+                    </a:solidFill>
+                  </a:tcPr>
+                </a:tc>
+                <a:tc>
+                  <a:txBody>
+                    <a:bodyPr/>
+                    <a:lstStyle/>
+                    <a:p>
+                      <a:pPr algn="ctr"/>
+                      <a:r>
+                        <a:rPr sz="1200" b="0">
+                          <a:solidFill>
+                            <a:srgbClr val="1B2A4A"/>
+                          </a:solidFill>
+                        </a:rPr>
+                        <a:t>0.68</a:t>
+                      </a:r>
+                    </a:p>
+                  </a:txBody>
+                  <a:tcPr marT="12700" marB="12700">
+                    <a:solidFill>
+                      <a:srgbClr val="FFFFFF"/>
+                    </a:solidFill>
+                  </a:tcPr>
+                </a:tc>
+                <a:tc>
+                  <a:txBody>
+                    <a:bodyPr/>
+                    <a:lstStyle/>
+                    <a:p>
+                      <a:pPr algn="ctr"/>
+                      <a:r>
+                        <a:rPr sz="1200" b="1">
+                          <a:solidFill>
+                            <a:srgbClr val="B12A2A"/>
+                          </a:solidFill>
+                        </a:rPr>
+                        <a:t>0.03</a:t>
+                      </a:r>
+                    </a:p>
+                  </a:txBody>
+                  <a:tcPr marT="12700" marB="12700">
+                    <a:solidFill>
+                      <a:srgbClr val="FFFFFF"/>
+                    </a:solidFill>
+                  </a:tcPr>
                 </a:tc>
               </a:tr>
             </a:tbl>
@@ -6238,14 +6839,14 @@
       </p:graphicFrame>
       <p:sp>
         <p:nvSpPr>
-          <p:cNvPr id="5" name="TextBox 4"/>
+          <p:cNvPr id="6" name="TextBox 5"/>
           <p:cNvSpPr txBox="1"/>
           <p:nvPr/>
         </p:nvSpPr>
         <p:spPr>
           <a:xfrm>
-            <a:off x="640080" y="3977639"/>
-            <a:ext cx="10972800" cy="2103120"/>
+            <a:off x="457200" y="4754880"/>
+            <a:ext cx="5760720" cy="320040"/>
           </a:xfrm>
           <a:prstGeom prst="rect">
             <a:avLst/>
@@ -6253,53 +6854,77 @@
           <a:noFill/>
         </p:spPr>
         <p:txBody>
-          <a:bodyPr wrap="square">
+          <a:bodyPr wrap="none">
             <a:spAutoFit/>
           </a:bodyPr>
           <a:lstStyle/>
           <a:p>
-            <a:pPr>
-              <a:spcAft>
-                <a:spcPts val="700"/>
-              </a:spcAft>
-            </a:pPr>
-            <a:r>
-              <a:rPr sz="1600" b="1">
+            <a:pPr algn="ctr"/>
+            <a:r>
+              <a:rPr sz="1100" b="1">
                 <a:solidFill>
                   <a:srgbClr val="1B2A4A"/>
                 </a:solidFill>
               </a:rPr>
-              <a:t>KV hit rate: tr은 세 경우 모두 압승 (스래싱 억제는 견고).</a:t>
-            </a:r>
-          </a:p>
-          <a:p>
-            <a:pPr>
-              <a:spcAft>
-                <a:spcPts val="700"/>
-              </a:spcAft>
-            </a:pPr>
-            <a:r>
-              <a:rPr sz="1600" b="1">
+              <a:t>throughput D tr→G tr 회복 / default hit 붕괴(빨강)</a:t>
+            </a:r>
+          </a:p>
+        </p:txBody>
+      </p:sp>
+      <p:pic>
+        <p:nvPicPr>
+          <p:cNvPr id="7" name="Picture 6" descr="hetero_hetero_hitrate.png"/>
+          <p:cNvPicPr>
+            <a:picLocks noChangeAspect="1"/>
+          </p:cNvPicPr>
+          <p:nvPr/>
+        </p:nvPicPr>
+        <p:blipFill>
+          <a:blip r:embed="rId2"/>
+          <a:stretch>
+            <a:fillRect/>
+          </a:stretch>
+        </p:blipFill>
+        <p:spPr>
+          <a:xfrm>
+            <a:off x="6492240" y="1554480"/>
+            <a:ext cx="5486400" cy="3716594"/>
+          </a:xfrm>
+          <a:prstGeom prst="rect">
+            <a:avLst/>
+          </a:prstGeom>
+        </p:spPr>
+      </p:pic>
+      <p:sp>
+        <p:nvSpPr>
+          <p:cNvPr id="8" name="TextBox 7"/>
+          <p:cNvSpPr txBox="1"/>
+          <p:nvPr/>
+        </p:nvSpPr>
+        <p:spPr>
+          <a:xfrm>
+            <a:off x="6492240" y="5806440"/>
+            <a:ext cx="5486400" cy="320040"/>
+          </a:xfrm>
+          <a:prstGeom prst="rect">
+            <a:avLst/>
+          </a:prstGeom>
+          <a:noFill/>
+        </p:spPr>
+        <p:txBody>
+          <a:bodyPr wrap="none">
+            <a:spAutoFit/>
+          </a:bodyPr>
+          <a:lstStyle/>
+          <a:p>
+            <a:pPr algn="ctr"/>
+            <a:r>
+              <a:rPr sz="1100" b="1">
                 <a:solidFill>
                   <a:srgbClr val="1B2A4A"/>
                 </a:solidFill>
               </a:rPr>
-              <a:t>Throughput: 프로그램이 KV에 육박하면(D) tr이 지고, 여유·이종이면(§9·F) tr이 이긴다.</a:t>
-            </a:r>
-          </a:p>
-          <a:p>
-            <a:pPr lvl="1">
-              <a:spcAft>
-                <a:spcPts val="700"/>
-              </a:spcAft>
-            </a:pPr>
-            <a:r>
-              <a:rPr sz="1400" b="0">
-                <a:solidFill>
-                  <a:srgbClr val="1B2A4A"/>
-                </a:solidFill>
-              </a:rPr>
-              <a:t>→ tr의 이득은 '프로그램/KV 비율'과 'GPU 용량 구성'에 좌우된다.</a:t>
+              <a:t>G 전역 hit rate: tr 유지 vs default 붕괴</a:t>
             </a:r>
           </a:p>
         </p:txBody>
@@ -6350,7 +6975,7 @@
                   <a:srgbClr val="1B2A4A"/>
                 </a:solidFill>
               </a:rPr>
-              <a:t>시사점 · 다음 방향</a:t>
+              <a:t>G 결과 ② — 백엔드별 + 세 방향 결론</a:t>
             </a:r>
           </a:p>
         </p:txBody>
@@ -6406,8 +7031,8 @@
         </p:nvSpPr>
         <p:spPr>
           <a:xfrm>
-            <a:off x="640080" y="1280160"/>
-            <a:ext cx="10972800" cy="5029200"/>
+            <a:off x="502920" y="1188720"/>
+            <a:ext cx="5212080" cy="2468880"/>
           </a:xfrm>
           <a:prstGeom prst="rect">
             <a:avLst/>
@@ -6426,12 +7051,12 @@
               </a:spcAft>
             </a:pPr>
             <a:r>
-              <a:rPr sz="1700" b="1">
+              <a:rPr sz="1400" b="1">
                 <a:solidFill>
                   <a:srgbClr val="1B2A4A"/>
                 </a:solidFill>
               </a:rPr>
-              <a:t>핵심 발견</a:t>
+              <a:t>F 패턴이 실데이터에서도 유지:</a:t>
             </a:r>
           </a:p>
           <a:p>
@@ -6441,12 +7066,12 @@
               </a:spcAft>
             </a:pPr>
             <a:r>
-              <a:rPr sz="1500" b="0">
+              <a:rPr sz="1200" b="0">
                 <a:solidFill>
-                  <a:srgbClr val="4A4A4A"/>
+                  <a:srgbClr val="B12A2A"/>
                 </a:solidFill>
               </a:rPr>
-              <a:t>① tr의 스래싱 억제(KV hit)는 실데이터·이종에서 견고히 재현.</a:t>
+              <a:t>default가 작은 4090 최악 붕괴 (c48 4090 hit 0.03 vs 5090 0.06)</a:t>
             </a:r>
           </a:p>
           <a:p>
@@ -6456,12 +7081,27 @@
               </a:spcAft>
             </a:pPr>
             <a:r>
-              <a:rPr sz="1500" b="0">
+              <a:rPr sz="1200" b="0">
                 <a:solidFill>
-                  <a:srgbClr val="4A4A4A"/>
+                  <a:srgbClr val="1E7A3C"/>
                 </a:solidFill>
               </a:rPr>
-              <a:t>② 이종에서 소형-GPU 혹사는 default의 병리 — tr은 균형 유지(H1 반증).</a:t>
+              <a:t>tr은 4090·5090 균형 (둘 다 ~0.67~0.87)</a:t>
+            </a:r>
+          </a:p>
+          <a:p>
+            <a:pPr>
+              <a:spcAft>
+                <a:spcPts val="700"/>
+              </a:spcAft>
+            </a:pPr>
+            <a:r>
+              <a:rPr sz="1400" b="1">
+                <a:solidFill>
+                  <a:srgbClr val="1B2A4A"/>
+                </a:solidFill>
+              </a:rPr>
+              <a:t>단 tr split ~1:1 ≪ 용량비 1:2.03 → 실데이터에서 5090 과소활용 (F 1:1.6보다 큼)</a:t>
             </a:r>
           </a:p>
           <a:p>
@@ -6471,71 +7111,257 @@
               </a:spcAft>
             </a:pPr>
             <a:r>
-              <a:rPr sz="1500" b="0">
-                <a:solidFill>
-                  <a:srgbClr val="B12A2A"/>
-                </a:solidFill>
-              </a:rPr>
-              <a:t>③ 그러나 tr은 큰 5090을 과소활용 (split 1:1.6 &lt; 용량 1:2.03, +31% &lt; +51%).</a:t>
-            </a:r>
-          </a:p>
-          <a:p>
-            <a:pPr>
-              <a:spcAft>
-                <a:spcPts val="700"/>
-              </a:spcAft>
-            </a:pPr>
-            <a:r>
-              <a:rPr sz="1700" b="1">
+              <a:rPr sz="1200" b="0">
                 <a:solidFill>
                   <a:srgbClr val="1B2A4A"/>
                 </a:solidFill>
               </a:rPr>
-              <a:t>다음 과제: 용량 비례 라우팅</a:t>
-            </a:r>
-          </a:p>
-          <a:p>
-            <a:pPr lvl="1">
-              <a:spcAft>
-                <a:spcPts val="700"/>
-              </a:spcAft>
-            </a:pPr>
-            <a:r>
-              <a:rPr sz="1500" b="0">
-                <a:solidFill>
-                  <a:srgbClr val="1E7A3C"/>
-                </a:solidFill>
-              </a:rPr>
-              <a:t>목표를 재정의 — '소형 GPU 부하 경감'이 아니라 '대형 GPU 여유 활용으로 throughput 상단 올리기'.</a:t>
-            </a:r>
-          </a:p>
-          <a:p>
-            <a:pPr lvl="1">
-              <a:spcAft>
-                <a:spcPts val="700"/>
-              </a:spcAft>
-            </a:pPr>
-            <a:r>
-              <a:rPr sz="1500" b="0">
-                <a:solidFill>
-                  <a:srgbClr val="1B2A4A"/>
-                </a:solidFill>
-              </a:rPr>
-              <a:t>용량(가능하면 속도·대역폭)에 비례해 신규 프로그램 배정 → 5090 활용률↑ 검증.</a:t>
-            </a:r>
-          </a:p>
-        </p:txBody>
-      </p:sp>
-      <p:sp>
-        <p:nvSpPr>
-          <p:cNvPr id="5" name="TextBox 4"/>
+              <a:t>그럼에도 throughput +72%(용량 +51% 대비 초선형) → 용량 비례로 5090 더 쓰면 상단↑</a:t>
+            </a:r>
+          </a:p>
+        </p:txBody>
+      </p:sp>
+      <p:graphicFrame>
+        <p:nvGraphicFramePr>
+          <p:cNvPr id="5" name="Table 4"/>
+          <p:cNvGraphicFramePr>
+            <a:graphicFrameLocks noGrp="1"/>
+          </p:cNvGraphicFramePr>
+          <p:nvPr/>
+        </p:nvGraphicFramePr>
+        <p:xfrm>
+          <a:off x="548640" y="4114800"/>
+          <a:ext cx="4023360" cy="877824"/>
+        </p:xfrm>
+        <a:graphic>
+          <a:graphicData uri="http://schemas.openxmlformats.org/drawingml/2006/table">
+            <a:tbl>
+              <a:tblPr>
+                <a:tableStyleId>{5C22544A-7EE6-4342-B048-85BDC9FD1C3A}</a:tableStyleId>
+              </a:tblPr>
+              <a:tblGrid>
+                <a:gridCol w="1463040"/>
+                <a:gridCol w="1280160"/>
+                <a:gridCol w="1280160"/>
+              </a:tblGrid>
+              <a:tr h="292608">
+                <a:tc>
+                  <a:txBody>
+                    <a:bodyPr/>
+                    <a:lstStyle/>
+                    <a:p>
+                      <a:pPr algn="ctr"/>
+                      <a:r>
+                        <a:rPr sz="1300" b="1">
+                          <a:solidFill>
+                            <a:srgbClr val="FFFFFF"/>
+                          </a:solidFill>
+                        </a:rPr>
+                        <a:t>hit (c=48)</a:t>
+                      </a:r>
+                    </a:p>
+                  </a:txBody>
+                  <a:tcPr marT="12700" marB="12700">
+                    <a:solidFill>
+                      <a:srgbClr val="1B2A4A"/>
+                    </a:solidFill>
+                  </a:tcPr>
+                </a:tc>
+                <a:tc>
+                  <a:txBody>
+                    <a:bodyPr/>
+                    <a:lstStyle/>
+                    <a:p>
+                      <a:pPr algn="ctr"/>
+                      <a:r>
+                        <a:rPr sz="1300" b="1">
+                          <a:solidFill>
+                            <a:srgbClr val="FFFFFF"/>
+                          </a:solidFill>
+                        </a:rPr>
+                        <a:t>tr</a:t>
+                      </a:r>
+                    </a:p>
+                  </a:txBody>
+                  <a:tcPr marT="12700" marB="12700">
+                    <a:solidFill>
+                      <a:srgbClr val="1B2A4A"/>
+                    </a:solidFill>
+                  </a:tcPr>
+                </a:tc>
+                <a:tc>
+                  <a:txBody>
+                    <a:bodyPr/>
+                    <a:lstStyle/>
+                    <a:p>
+                      <a:pPr algn="ctr"/>
+                      <a:r>
+                        <a:rPr sz="1300" b="1">
+                          <a:solidFill>
+                            <a:srgbClr val="FFFFFF"/>
+                          </a:solidFill>
+                        </a:rPr>
+                        <a:t>default</a:t>
+                      </a:r>
+                    </a:p>
+                  </a:txBody>
+                  <a:tcPr marT="12700" marB="12700">
+                    <a:solidFill>
+                      <a:srgbClr val="1B2A4A"/>
+                    </a:solidFill>
+                  </a:tcPr>
+                </a:tc>
+              </a:tr>
+              <a:tr h="292608">
+                <a:tc>
+                  <a:txBody>
+                    <a:bodyPr/>
+                    <a:lstStyle/>
+                    <a:p>
+                      <a:pPr algn="ctr"/>
+                      <a:r>
+                        <a:rPr sz="1300" b="0">
+                          <a:solidFill>
+                            <a:srgbClr val="1B2A4A"/>
+                          </a:solidFill>
+                        </a:rPr>
+                        <a:t>4090</a:t>
+                      </a:r>
+                    </a:p>
+                  </a:txBody>
+                  <a:tcPr marT="12700" marB="12700">
+                    <a:solidFill>
+                      <a:srgbClr val="FFFFFF"/>
+                    </a:solidFill>
+                  </a:tcPr>
+                </a:tc>
+                <a:tc>
+                  <a:txBody>
+                    <a:bodyPr/>
+                    <a:lstStyle/>
+                    <a:p>
+                      <a:pPr algn="ctr"/>
+                      <a:r>
+                        <a:rPr sz="1300" b="0">
+                          <a:solidFill>
+                            <a:srgbClr val="1B2A4A"/>
+                          </a:solidFill>
+                        </a:rPr>
+                        <a:t>0.69</a:t>
+                      </a:r>
+                    </a:p>
+                  </a:txBody>
+                  <a:tcPr marT="12700" marB="12700">
+                    <a:solidFill>
+                      <a:srgbClr val="FFFFFF"/>
+                    </a:solidFill>
+                  </a:tcPr>
+                </a:tc>
+                <a:tc>
+                  <a:txBody>
+                    <a:bodyPr/>
+                    <a:lstStyle/>
+                    <a:p>
+                      <a:pPr algn="ctr"/>
+                      <a:r>
+                        <a:rPr sz="1300" b="1">
+                          <a:solidFill>
+                            <a:srgbClr val="B12A2A"/>
+                          </a:solidFill>
+                        </a:rPr>
+                        <a:t>0.03</a:t>
+                      </a:r>
+                    </a:p>
+                  </a:txBody>
+                  <a:tcPr marT="12700" marB="12700">
+                    <a:solidFill>
+                      <a:srgbClr val="FFFFFF"/>
+                    </a:solidFill>
+                  </a:tcPr>
+                </a:tc>
+              </a:tr>
+              <a:tr h="292608">
+                <a:tc>
+                  <a:txBody>
+                    <a:bodyPr/>
+                    <a:lstStyle/>
+                    <a:p>
+                      <a:pPr algn="ctr"/>
+                      <a:r>
+                        <a:rPr sz="1300" b="0">
+                          <a:solidFill>
+                            <a:srgbClr val="1B2A4A"/>
+                          </a:solidFill>
+                        </a:rPr>
+                        <a:t>5090</a:t>
+                      </a:r>
+                    </a:p>
+                  </a:txBody>
+                  <a:tcPr marT="12700" marB="12700">
+                    <a:solidFill>
+                      <a:srgbClr val="FFFFFF"/>
+                    </a:solidFill>
+                  </a:tcPr>
+                </a:tc>
+                <a:tc>
+                  <a:txBody>
+                    <a:bodyPr/>
+                    <a:lstStyle/>
+                    <a:p>
+                      <a:pPr algn="ctr"/>
+                      <a:r>
+                        <a:rPr sz="1300" b="0">
+                          <a:solidFill>
+                            <a:srgbClr val="1B2A4A"/>
+                          </a:solidFill>
+                        </a:rPr>
+                        <a:t>0.67</a:t>
+                      </a:r>
+                    </a:p>
+                  </a:txBody>
+                  <a:tcPr marT="12700" marB="12700">
+                    <a:solidFill>
+                      <a:srgbClr val="FFFFFF"/>
+                    </a:solidFill>
+                  </a:tcPr>
+                </a:tc>
+                <a:tc>
+                  <a:txBody>
+                    <a:bodyPr/>
+                    <a:lstStyle/>
+                    <a:p>
+                      <a:pPr algn="ctr"/>
+                      <a:r>
+                        <a:rPr sz="1300" b="1">
+                          <a:solidFill>
+                            <a:srgbClr val="B12A2A"/>
+                          </a:solidFill>
+                        </a:rPr>
+                        <a:t>0.06</a:t>
+                      </a:r>
+                    </a:p>
+                  </a:txBody>
+                  <a:tcPr marT="12700" marB="12700">
+                    <a:solidFill>
+                      <a:srgbClr val="FFFFFF"/>
+                    </a:solidFill>
+                  </a:tcPr>
+                </a:tc>
+              </a:tr>
+            </a:tbl>
+          </a:graphicData>
+        </a:graphic>
+      </p:graphicFrame>
+      <p:sp>
+        <p:nvSpPr>
+          <p:cNvPr id="6" name="TextBox 5"/>
           <p:cNvSpPr txBox="1"/>
           <p:nvPr/>
         </p:nvSpPr>
         <p:spPr>
           <a:xfrm>
-            <a:off x="640080" y="6419088"/>
-            <a:ext cx="11155680" cy="365760"/>
+            <a:off x="548640" y="5074920"/>
+            <a:ext cx="4023360" cy="320040"/>
           </a:xfrm>
           <a:prstGeom prst="rect">
             <a:avLst/>
@@ -6548,13 +7374,72 @@
           </a:bodyPr>
           <a:lstStyle/>
           <a:p>
-            <a:r>
-              <a:rPr sz="1100" i="1">
+            <a:pPr algn="ctr"/>
+            <a:r>
+              <a:rPr sz="1100" b="1">
                 <a:solidFill>
-                  <a:srgbClr val="2E6DB4"/>
+                  <a:srgbClr val="1B2A4A"/>
                 </a:solidFill>
               </a:rPr>
-              <a:t>router.py의 신규-프로그램 배정 로직을 용량 비례로 확장 (이번엔 관측만, 근거 확보 완료).</a:t>
+              <a:t>백엔드별 hit (c=48): default 4090 최악 붕괴</a:t>
+            </a:r>
+          </a:p>
+        </p:txBody>
+      </p:sp>
+      <p:pic>
+        <p:nvPicPr>
+          <p:cNvPr id="7" name="Picture 6" descr="hetero_hetero_perbackend_hitrate.png"/>
+          <p:cNvPicPr>
+            <a:picLocks noChangeAspect="1"/>
+          </p:cNvPicPr>
+          <p:nvPr/>
+        </p:nvPicPr>
+        <p:blipFill>
+          <a:blip r:embed="rId2"/>
+          <a:stretch>
+            <a:fillRect/>
+          </a:stretch>
+        </p:blipFill>
+        <p:spPr>
+          <a:xfrm>
+            <a:off x="5806440" y="1828800"/>
+            <a:ext cx="6217920" cy="4145280"/>
+          </a:xfrm>
+          <a:prstGeom prst="rect">
+            <a:avLst/>
+          </a:prstGeom>
+        </p:spPr>
+      </p:pic>
+      <p:sp>
+        <p:nvSpPr>
+          <p:cNvPr id="8" name="TextBox 7"/>
+          <p:cNvSpPr txBox="1"/>
+          <p:nvPr/>
+        </p:nvSpPr>
+        <p:spPr>
+          <a:xfrm>
+            <a:off x="5806440" y="6035040"/>
+            <a:ext cx="6217920" cy="320040"/>
+          </a:xfrm>
+          <a:prstGeom prst="rect">
+            <a:avLst/>
+          </a:prstGeom>
+          <a:noFill/>
+        </p:spPr>
+        <p:txBody>
+          <a:bodyPr wrap="none">
+            <a:spAutoFit/>
+          </a:bodyPr>
+          <a:lstStyle/>
+          <a:p>
+            <a:pPr algn="ctr"/>
+            <a:r>
+              <a:rPr sz="1100" b="1">
+                <a:solidFill>
+                  <a:srgbClr val="1B2A4A"/>
+                </a:solidFill>
+              </a:rPr>
+              <a:t>tr 균형 vs default 4090 최악 붕괴</a:t>
             </a:r>
           </a:p>
         </p:txBody>
@@ -6605,7 +7490,7 @@
                   <a:srgbClr val="1B2A4A"/>
                 </a:solidFill>
               </a:rPr>
-              <a:t>한계 · TODO</a:t>
+              <a:t>종합: 2×2 매트릭스 (데이터 × GPU) — 4칸 완성</a:t>
             </a:r>
           </a:p>
         </p:txBody>
@@ -6653,16 +7538,247 @@
           </a:p>
         </p:txBody>
       </p:sp>
-      <p:sp>
-        <p:nvSpPr>
-          <p:cNvPr id="4" name="TextBox 3"/>
+      <p:graphicFrame>
+        <p:nvGraphicFramePr>
+          <p:cNvPr id="4" name="Table 3"/>
+          <p:cNvGraphicFramePr>
+            <a:graphicFrameLocks noGrp="1"/>
+          </p:cNvGraphicFramePr>
+          <p:nvPr/>
+        </p:nvGraphicFramePr>
+        <p:xfrm>
+          <a:off x="640080" y="1508760"/>
+          <a:ext cx="10881360" cy="2103120"/>
+        </p:xfrm>
+        <a:graphic>
+          <a:graphicData uri="http://schemas.openxmlformats.org/drawingml/2006/table">
+            <a:tbl>
+              <a:tblPr firstRow="1" bandRow="1">
+                <a:tableStyleId>{5C22544A-7EE6-4342-B048-85BDC9FD1C3A}</a:tableStyleId>
+              </a:tblPr>
+              <a:tblGrid>
+                <a:gridCol w="2286000"/>
+                <a:gridCol w="4114800"/>
+                <a:gridCol w="4480560"/>
+              </a:tblGrid>
+              <a:tr h="701040">
+                <a:tc>
+                  <a:txBody>
+                    <a:bodyPr/>
+                    <a:lstStyle/>
+                    <a:p>
+                      <a:pPr algn="ctr"/>
+                      <a:r>
+                        <a:rPr sz="1400" b="1">
+                          <a:solidFill>
+                            <a:srgbClr val="FFFFFF"/>
+                          </a:solidFill>
+                        </a:rPr>
+                        <a:t/>
+                      </a:r>
+                    </a:p>
+                  </a:txBody>
+                  <a:tcPr>
+                    <a:solidFill>
+                      <a:srgbClr val="1B2A4A"/>
+                    </a:solidFill>
+                  </a:tcPr>
+                </a:tc>
+                <a:tc>
+                  <a:txBody>
+                    <a:bodyPr/>
+                    <a:lstStyle/>
+                    <a:p>
+                      <a:pPr algn="ctr"/>
+                      <a:r>
+                        <a:rPr sz="1400" b="1">
+                          <a:solidFill>
+                            <a:srgbClr val="FFFFFF"/>
+                          </a:solidFill>
+                        </a:rPr>
+                        <a:t>2×4090 (homo GPU)</a:t>
+                      </a:r>
+                    </a:p>
+                  </a:txBody>
+                  <a:tcPr>
+                    <a:solidFill>
+                      <a:srgbClr val="1B2A4A"/>
+                    </a:solidFill>
+                  </a:tcPr>
+                </a:tc>
+                <a:tc>
+                  <a:txBody>
+                    <a:bodyPr/>
+                    <a:lstStyle/>
+                    <a:p>
+                      <a:pPr algn="ctr"/>
+                      <a:r>
+                        <a:rPr sz="1400" b="1">
+                          <a:solidFill>
+                            <a:srgbClr val="FFFFFF"/>
+                          </a:solidFill>
+                        </a:rPr>
+                        <a:t>4090+5090 (hetero GPU)</a:t>
+                      </a:r>
+                    </a:p>
+                  </a:txBody>
+                  <a:tcPr>
+                    <a:solidFill>
+                      <a:srgbClr val="1B2A4A"/>
+                    </a:solidFill>
+                  </a:tcPr>
+                </a:tc>
+              </a:tr>
+              <a:tr h="701040">
+                <a:tc>
+                  <a:txBody>
+                    <a:bodyPr/>
+                    <a:lstStyle/>
+                    <a:p>
+                      <a:pPr algn="ctr"/>
+                      <a:r>
+                        <a:rPr sz="1400" b="1">
+                          <a:solidFill>
+                            <a:srgbClr val="FFFFFF"/>
+                          </a:solidFill>
+                        </a:rPr>
+                        <a:t>합성 데이터</a:t>
+                      </a:r>
+                    </a:p>
+                  </a:txBody>
+                  <a:tcPr>
+                    <a:solidFill>
+                      <a:srgbClr val="1B2A4A"/>
+                    </a:solidFill>
+                  </a:tcPr>
+                </a:tc>
+                <a:tc>
+                  <a:txBody>
+                    <a:bodyPr/>
+                    <a:lstStyle/>
+                    <a:p>
+                      <a:pPr algn="ctr"/>
+                      <a:r>
+                        <a:rPr sz="1400">
+                          <a:solidFill>
+                            <a:srgbClr val="1B2A4A"/>
+                          </a:solidFill>
+                        </a:rPr>
+                        <a:t>§9: tr thru +57% · hit 압승</a:t>
+                      </a:r>
+                    </a:p>
+                  </a:txBody>
+                  <a:tcPr>
+                    <a:solidFill>
+                      <a:srgbClr val="FFFFFF"/>
+                    </a:solidFill>
+                  </a:tcPr>
+                </a:tc>
+                <a:tc>
+                  <a:txBody>
+                    <a:bodyPr/>
+                    <a:lstStyle/>
+                    <a:p>
+                      <a:pPr algn="ctr"/>
+                      <a:r>
+                        <a:rPr sz="1400">
+                          <a:solidFill>
+                            <a:srgbClr val="1B2A4A"/>
+                          </a:solidFill>
+                        </a:rPr>
+                        <a:t>F: tr thru +100% · hit·p95 우위</a:t>
+                      </a:r>
+                    </a:p>
+                  </a:txBody>
+                  <a:tcPr>
+                    <a:solidFill>
+                      <a:srgbClr val="FFFFFF"/>
+                    </a:solidFill>
+                  </a:tcPr>
+                </a:tc>
+              </a:tr>
+              <a:tr h="701040">
+                <a:tc>
+                  <a:txBody>
+                    <a:bodyPr/>
+                    <a:lstStyle/>
+                    <a:p>
+                      <a:pPr algn="ctr"/>
+                      <a:r>
+                        <a:rPr sz="1400" b="1">
+                          <a:solidFill>
+                            <a:srgbClr val="FFFFFF"/>
+                          </a:solidFill>
+                        </a:rPr>
+                        <a:t>실제 TraceLab</a:t>
+                      </a:r>
+                    </a:p>
+                  </a:txBody>
+                  <a:tcPr>
+                    <a:solidFill>
+                      <a:srgbClr val="1B2A4A"/>
+                    </a:solidFill>
+                  </a:tcPr>
+                </a:tc>
+                <a:tc>
+                  <a:txBody>
+                    <a:bodyPr/>
+                    <a:lstStyle/>
+                    <a:p>
+                      <a:pPr algn="ctr"/>
+                      <a:r>
+                        <a:rPr sz="1400">
+                          <a:solidFill>
+                            <a:srgbClr val="1B2A4A"/>
+                          </a:solidFill>
+                        </a:rPr>
+                        <a:t>D: tr thru −34% · hit 압승(30×)</a:t>
+                      </a:r>
+                    </a:p>
+                  </a:txBody>
+                  <a:tcPr>
+                    <a:solidFill>
+                      <a:srgbClr val="FFFFFF"/>
+                    </a:solidFill>
+                  </a:tcPr>
+                </a:tc>
+                <a:tc>
+                  <a:txBody>
+                    <a:bodyPr/>
+                    <a:lstStyle/>
+                    <a:p>
+                      <a:pPr algn="ctr"/>
+                      <a:r>
+                        <a:rPr sz="1400">
+                          <a:solidFill>
+                            <a:srgbClr val="1B2A4A"/>
+                          </a:solidFill>
+                        </a:rPr>
+                        <a:t>G: tr thru −8%(회복) · hit 압승</a:t>
+                      </a:r>
+                    </a:p>
+                  </a:txBody>
+                  <a:tcPr>
+                    <a:solidFill>
+                      <a:srgbClr val="FFFFFF"/>
+                    </a:solidFill>
+                  </a:tcPr>
+                </a:tc>
+              </a:tr>
+            </a:tbl>
+          </a:graphicData>
+        </a:graphic>
+      </p:graphicFrame>
+      <p:sp>
+        <p:nvSpPr>
+          <p:cNvPr id="5" name="TextBox 4"/>
           <p:cNvSpPr txBox="1"/>
           <p:nvPr/>
         </p:nvSpPr>
         <p:spPr>
           <a:xfrm>
-            <a:off x="640080" y="1280160"/>
-            <a:ext cx="10972800" cy="5029200"/>
+            <a:off x="640080" y="4114800"/>
+            <a:ext cx="10972800" cy="2103120"/>
           </a:xfrm>
           <a:prstGeom prst="rect">
             <a:avLst/>
@@ -6681,12 +7797,12 @@
               </a:spcAft>
             </a:pPr>
             <a:r>
-              <a:rPr sz="1600" b="1">
+              <a:rPr sz="1500" b="1">
                 <a:solidFill>
                   <a:srgbClr val="1B2A4A"/>
                 </a:solidFill>
               </a:rPr>
-              <a:t>측정 신뢰도: 각 점 3회 (반복 간 편차, 특히 tr pause 타이밍) → 반복·에러바 보강.</a:t>
+              <a:t>KV hit rate: tr은 4칸 모두 압승 (스래싱 억제 견고).</a:t>
             </a:r>
           </a:p>
           <a:p>
@@ -6696,72 +7812,27 @@
               </a:spcAft>
             </a:pPr>
             <a:r>
-              <a:rPr sz="1600" b="1">
+              <a:rPr sz="1500" b="1">
                 <a:solidFill>
                   <a:srgbClr val="1B2A4A"/>
                 </a:solidFill>
               </a:rPr>
-              <a:t>워크로드: F는 합성(§9). 실데이터 이종(TraceLab × 4090+5090)은 미실행.</a:t>
-            </a:r>
-          </a:p>
-          <a:p>
-            <a:pPr>
+              <a:t>Throughput: 프로그램이 KV에 육박하는 실데이터(D)에선 tr이 지고, 여유·이종이면 이기거나 회복(§9·F·G).</a:t>
+            </a:r>
+          </a:p>
+          <a:p>
+            <a:pPr lvl="1">
               <a:spcAft>
                 <a:spcPts val="700"/>
               </a:spcAft>
             </a:pPr>
             <a:r>
-              <a:rPr sz="1600" b="1">
+              <a:rPr sz="1300" b="0">
                 <a:solidFill>
                   <a:srgbClr val="1B2A4A"/>
                 </a:solidFill>
               </a:rPr>
-              <a:t>지표 근사: split을 prefix-cache queries(재프리필 포함)로 근사 — 순수 라우팅 프로그램 수와 다름.</a:t>
-            </a:r>
-          </a:p>
-          <a:p>
-            <a:pPr>
-              <a:spcAft>
-                <a:spcPts val="700"/>
-              </a:spcAft>
-            </a:pPr>
-            <a:r>
-              <a:rPr sz="1600" b="1">
-                <a:solidFill>
-                  <a:srgbClr val="1B2A4A"/>
-                </a:solidFill>
-              </a:rPr>
-              <a:t>데이터 편향: fit≤32k 서브셋(982세션)은 짧은 세션 편향 — 92.5% turn이 32k 초과라 제외됨.</a:t>
-            </a:r>
-          </a:p>
-          <a:p>
-            <a:pPr>
-              <a:spcAft>
-                <a:spcPts val="700"/>
-              </a:spcAft>
-            </a:pPr>
-            <a:r>
-              <a:rPr sz="1600" b="1">
-                <a:solidFill>
-                  <a:srgbClr val="1B2A4A"/>
-                </a:solidFill>
-              </a:rPr>
-              <a:t>보류: C·D(SWE-bench 녹화), E(cross-node homo) — 다음 미팅 이후.</a:t>
-            </a:r>
-          </a:p>
-          <a:p>
-            <a:pPr>
-              <a:spcAft>
-                <a:spcPts val="700"/>
-              </a:spcAft>
-            </a:pPr>
-            <a:r>
-              <a:rPr sz="1600" b="1">
-                <a:solidFill>
-                  <a:srgbClr val="1B2A4A"/>
-                </a:solidFill>
-              </a:rPr>
-              <a:t>다음: 용량 비례 라우팅 구현 → D·F 재실행으로 이득 검증.</a:t>
+              <a:t>→ tr 이득은 '프로그램/KV 비율'·'GPU 용량'에 좌우. 이종 5090이 실데이터 적자를 34%→8%로 축소.</a:t>
             </a:r>
           </a:p>
         </p:txBody>
@@ -6774,7 +7845,7 @@
 </p:sld>
 </file>
 
-<file path=ppt/slides/slide2.xml><?xml version="1.0" encoding="utf-8"?>
+<file path=ppt/slides/slide15.xml><?xml version="1.0" encoding="utf-8"?>
 <p:sld xmlns:a="http://schemas.openxmlformats.org/drawingml/2006/main" xmlns:p="http://schemas.openxmlformats.org/presentationml/2006/main" xmlns:r="http://schemas.openxmlformats.org/officeDocument/2006/relationships">
   <p:cSld>
     <p:spTree>
@@ -6812,7 +7883,7 @@
                   <a:srgbClr val="1B2A4A"/>
                 </a:solidFill>
               </a:rPr>
-              <a:t>배경 · 목표</a:t>
+              <a:t>시사점 · 다음 방향</a:t>
             </a:r>
           </a:p>
         </p:txBody>
@@ -6893,6 +7964,468 @@
                   <a:srgbClr val="1B2A4A"/>
                 </a:solidFill>
               </a:rPr>
+              <a:t>핵심 발견</a:t>
+            </a:r>
+          </a:p>
+          <a:p>
+            <a:pPr lvl="1">
+              <a:spcAft>
+                <a:spcPts val="700"/>
+              </a:spcAft>
+            </a:pPr>
+            <a:r>
+              <a:rPr sz="1500" b="0">
+                <a:solidFill>
+                  <a:srgbClr val="4A4A4A"/>
+                </a:solidFill>
+              </a:rPr>
+              <a:t>① tr의 스래싱 억제(KV hit)는 실데이터·이종에서 견고히 재현.</a:t>
+            </a:r>
+          </a:p>
+          <a:p>
+            <a:pPr lvl="1">
+              <a:spcAft>
+                <a:spcPts val="700"/>
+              </a:spcAft>
+            </a:pPr>
+            <a:r>
+              <a:rPr sz="1500" b="0">
+                <a:solidFill>
+                  <a:srgbClr val="4A4A4A"/>
+                </a:solidFill>
+              </a:rPr>
+              <a:t>② 이종에서 소형-GPU 혹사는 default의 병리 — tr은 균형 유지(H1 반증).</a:t>
+            </a:r>
+          </a:p>
+          <a:p>
+            <a:pPr lvl="1">
+              <a:spcAft>
+                <a:spcPts val="700"/>
+              </a:spcAft>
+            </a:pPr>
+            <a:r>
+              <a:rPr sz="1500" b="0">
+                <a:solidFill>
+                  <a:srgbClr val="B12A2A"/>
+                </a:solidFill>
+              </a:rPr>
+              <a:t>③ 그러나 tr은 큰 5090을 과소활용 (split 1:1.6 &lt; 용량 1:2.03, +31% &lt; +51%).</a:t>
+            </a:r>
+          </a:p>
+          <a:p>
+            <a:pPr>
+              <a:spcAft>
+                <a:spcPts val="700"/>
+              </a:spcAft>
+            </a:pPr>
+            <a:r>
+              <a:rPr sz="1700" b="1">
+                <a:solidFill>
+                  <a:srgbClr val="1B2A4A"/>
+                </a:solidFill>
+              </a:rPr>
+              <a:t>다음 과제: 용량 비례 라우팅</a:t>
+            </a:r>
+          </a:p>
+          <a:p>
+            <a:pPr lvl="1">
+              <a:spcAft>
+                <a:spcPts val="700"/>
+              </a:spcAft>
+            </a:pPr>
+            <a:r>
+              <a:rPr sz="1500" b="0">
+                <a:solidFill>
+                  <a:srgbClr val="1E7A3C"/>
+                </a:solidFill>
+              </a:rPr>
+              <a:t>목표를 재정의 — '소형 GPU 부하 경감'이 아니라 '대형 GPU 여유 활용으로 throughput 상단 올리기'.</a:t>
+            </a:r>
+          </a:p>
+          <a:p>
+            <a:pPr lvl="1">
+              <a:spcAft>
+                <a:spcPts val="700"/>
+              </a:spcAft>
+            </a:pPr>
+            <a:r>
+              <a:rPr sz="1500" b="0">
+                <a:solidFill>
+                  <a:srgbClr val="1B2A4A"/>
+                </a:solidFill>
+              </a:rPr>
+              <a:t>용량(가능하면 속도·대역폭)에 비례해 신규 프로그램 배정 → 5090 활용률↑ 검증.</a:t>
+            </a:r>
+          </a:p>
+        </p:txBody>
+      </p:sp>
+      <p:sp>
+        <p:nvSpPr>
+          <p:cNvPr id="5" name="TextBox 4"/>
+          <p:cNvSpPr txBox="1"/>
+          <p:nvPr/>
+        </p:nvSpPr>
+        <p:spPr>
+          <a:xfrm>
+            <a:off x="640080" y="6419088"/>
+            <a:ext cx="11155680" cy="365760"/>
+          </a:xfrm>
+          <a:prstGeom prst="rect">
+            <a:avLst/>
+          </a:prstGeom>
+          <a:noFill/>
+        </p:spPr>
+        <p:txBody>
+          <a:bodyPr wrap="none">
+            <a:spAutoFit/>
+          </a:bodyPr>
+          <a:lstStyle/>
+          <a:p>
+            <a:r>
+              <a:rPr sz="1100" i="1">
+                <a:solidFill>
+                  <a:srgbClr val="2E6DB4"/>
+                </a:solidFill>
+              </a:rPr>
+              <a:t>router.py의 신규-프로그램 배정 로직을 용량 비례로 확장 (이번엔 관측만, 근거 확보 완료).</a:t>
+            </a:r>
+          </a:p>
+        </p:txBody>
+      </p:sp>
+    </p:spTree>
+  </p:cSld>
+  <p:clrMapOvr>
+    <a:masterClrMapping/>
+  </p:clrMapOvr>
+</p:sld>
+</file>
+
+<file path=ppt/slides/slide16.xml><?xml version="1.0" encoding="utf-8"?>
+<p:sld xmlns:a="http://schemas.openxmlformats.org/drawingml/2006/main" xmlns:p="http://schemas.openxmlformats.org/presentationml/2006/main" xmlns:r="http://schemas.openxmlformats.org/officeDocument/2006/relationships">
+  <p:cSld>
+    <p:spTree>
+      <p:nvGrpSpPr>
+        <p:cNvPr id="1" name=""/>
+        <p:cNvGrpSpPr/>
+        <p:nvPr/>
+      </p:nvGrpSpPr>
+      <p:grpSpPr/>
+      <p:sp>
+        <p:nvSpPr>
+          <p:cNvPr id="2" name="TextBox 1"/>
+          <p:cNvSpPr txBox="1"/>
+          <p:nvPr/>
+        </p:nvSpPr>
+        <p:spPr>
+          <a:xfrm>
+            <a:off x="502920" y="274320"/>
+            <a:ext cx="11247120" cy="822960"/>
+          </a:xfrm>
+          <a:prstGeom prst="rect">
+            <a:avLst/>
+          </a:prstGeom>
+          <a:noFill/>
+        </p:spPr>
+        <p:txBody>
+          <a:bodyPr wrap="none">
+            <a:spAutoFit/>
+          </a:bodyPr>
+          <a:lstStyle/>
+          <a:p>
+            <a:r>
+              <a:rPr sz="2600" b="1">
+                <a:solidFill>
+                  <a:srgbClr val="1B2A4A"/>
+                </a:solidFill>
+              </a:rPr>
+              <a:t>한계 · TODO</a:t>
+            </a:r>
+          </a:p>
+        </p:txBody>
+      </p:sp>
+      <p:sp>
+        <p:nvSpPr>
+          <p:cNvPr id="3" name="Rectangle 2"/>
+          <p:cNvSpPr/>
+          <p:nvPr/>
+        </p:nvSpPr>
+        <p:spPr>
+          <a:xfrm>
+            <a:off x="530352" y="1005840"/>
+            <a:ext cx="2926080" cy="38100"/>
+          </a:xfrm>
+          <a:prstGeom prst="rect">
+            <a:avLst/>
+          </a:prstGeom>
+          <a:solidFill>
+            <a:srgbClr val="2E6DB4"/>
+          </a:solidFill>
+          <a:ln>
+            <a:noFill/>
+          </a:ln>
+        </p:spPr>
+        <p:style>
+          <a:lnRef idx="1">
+            <a:schemeClr val="accent1"/>
+          </a:lnRef>
+          <a:fillRef idx="3">
+            <a:schemeClr val="accent1"/>
+          </a:fillRef>
+          <a:effectRef idx="2">
+            <a:schemeClr val="accent1"/>
+          </a:effectRef>
+          <a:fontRef idx="minor">
+            <a:schemeClr val="lt1"/>
+          </a:fontRef>
+        </p:style>
+        <p:txBody>
+          <a:bodyPr rtlCol="0" anchor="ctr"/>
+          <a:lstStyle/>
+          <a:p>
+            <a:pPr algn="ctr"/>
+          </a:p>
+        </p:txBody>
+      </p:sp>
+      <p:sp>
+        <p:nvSpPr>
+          <p:cNvPr id="4" name="TextBox 3"/>
+          <p:cNvSpPr txBox="1"/>
+          <p:nvPr/>
+        </p:nvSpPr>
+        <p:spPr>
+          <a:xfrm>
+            <a:off x="640080" y="1280160"/>
+            <a:ext cx="10972800" cy="5029200"/>
+          </a:xfrm>
+          <a:prstGeom prst="rect">
+            <a:avLst/>
+          </a:prstGeom>
+          <a:noFill/>
+        </p:spPr>
+        <p:txBody>
+          <a:bodyPr wrap="square">
+            <a:spAutoFit/>
+          </a:bodyPr>
+          <a:lstStyle/>
+          <a:p>
+            <a:pPr>
+              <a:spcAft>
+                <a:spcPts val="700"/>
+              </a:spcAft>
+            </a:pPr>
+            <a:r>
+              <a:rPr sz="1600" b="1">
+                <a:solidFill>
+                  <a:srgbClr val="1B2A4A"/>
+                </a:solidFill>
+              </a:rPr>
+              <a:t>측정 신뢰도: 각 점 3회 (반복 간 편차, 특히 tr pause 타이밍) → 반복·에러바 보강.</a:t>
+            </a:r>
+          </a:p>
+          <a:p>
+            <a:pPr>
+              <a:spcAft>
+                <a:spcPts val="700"/>
+              </a:spcAft>
+            </a:pPr>
+            <a:r>
+              <a:rPr sz="1600" b="1">
+                <a:solidFill>
+                  <a:srgbClr val="1B2A4A"/>
+                </a:solidFill>
+              </a:rPr>
+              <a:t>워크로드: F는 합성(§9). 실데이터 이종(TraceLab × 4090+5090)은 미실행.</a:t>
+            </a:r>
+          </a:p>
+          <a:p>
+            <a:pPr>
+              <a:spcAft>
+                <a:spcPts val="700"/>
+              </a:spcAft>
+            </a:pPr>
+            <a:r>
+              <a:rPr sz="1600" b="1">
+                <a:solidFill>
+                  <a:srgbClr val="1B2A4A"/>
+                </a:solidFill>
+              </a:rPr>
+              <a:t>지표 근사: split을 prefix-cache queries(재프리필 포함)로 근사 — 순수 라우팅 프로그램 수와 다름.</a:t>
+            </a:r>
+          </a:p>
+          <a:p>
+            <a:pPr>
+              <a:spcAft>
+                <a:spcPts val="700"/>
+              </a:spcAft>
+            </a:pPr>
+            <a:r>
+              <a:rPr sz="1600" b="1">
+                <a:solidFill>
+                  <a:srgbClr val="1B2A4A"/>
+                </a:solidFill>
+              </a:rPr>
+              <a:t>데이터 편향: fit≤32k 서브셋(982세션)은 짧은 세션 편향 — 92.5% turn이 32k 초과라 제외됨.</a:t>
+            </a:r>
+          </a:p>
+          <a:p>
+            <a:pPr>
+              <a:spcAft>
+                <a:spcPts val="700"/>
+              </a:spcAft>
+            </a:pPr>
+            <a:r>
+              <a:rPr sz="1600" b="1">
+                <a:solidFill>
+                  <a:srgbClr val="1B2A4A"/>
+                </a:solidFill>
+              </a:rPr>
+              <a:t>보류: C·D(SWE-bench 녹화), E(cross-node homo) — 다음 미팅 이후.</a:t>
+            </a:r>
+          </a:p>
+          <a:p>
+            <a:pPr>
+              <a:spcAft>
+                <a:spcPts val="700"/>
+              </a:spcAft>
+            </a:pPr>
+            <a:r>
+              <a:rPr sz="1600" b="1">
+                <a:solidFill>
+                  <a:srgbClr val="1B2A4A"/>
+                </a:solidFill>
+              </a:rPr>
+              <a:t>다음: 용량 비례 라우팅 구현 → D·F 재실행으로 이득 검증.</a:t>
+            </a:r>
+          </a:p>
+        </p:txBody>
+      </p:sp>
+    </p:spTree>
+  </p:cSld>
+  <p:clrMapOvr>
+    <a:masterClrMapping/>
+  </p:clrMapOvr>
+</p:sld>
+</file>
+
+<file path=ppt/slides/slide2.xml><?xml version="1.0" encoding="utf-8"?>
+<p:sld xmlns:a="http://schemas.openxmlformats.org/drawingml/2006/main" xmlns:p="http://schemas.openxmlformats.org/presentationml/2006/main" xmlns:r="http://schemas.openxmlformats.org/officeDocument/2006/relationships">
+  <p:cSld>
+    <p:spTree>
+      <p:nvGrpSpPr>
+        <p:cNvPr id="1" name=""/>
+        <p:cNvGrpSpPr/>
+        <p:nvPr/>
+      </p:nvGrpSpPr>
+      <p:grpSpPr/>
+      <p:sp>
+        <p:nvSpPr>
+          <p:cNvPr id="2" name="TextBox 1"/>
+          <p:cNvSpPr txBox="1"/>
+          <p:nvPr/>
+        </p:nvSpPr>
+        <p:spPr>
+          <a:xfrm>
+            <a:off x="502920" y="274320"/>
+            <a:ext cx="11247120" cy="822960"/>
+          </a:xfrm>
+          <a:prstGeom prst="rect">
+            <a:avLst/>
+          </a:prstGeom>
+          <a:noFill/>
+        </p:spPr>
+        <p:txBody>
+          <a:bodyPr wrap="none">
+            <a:spAutoFit/>
+          </a:bodyPr>
+          <a:lstStyle/>
+          <a:p>
+            <a:r>
+              <a:rPr sz="2600" b="1">
+                <a:solidFill>
+                  <a:srgbClr val="1B2A4A"/>
+                </a:solidFill>
+              </a:rPr>
+              <a:t>배경 · 목표</a:t>
+            </a:r>
+          </a:p>
+        </p:txBody>
+      </p:sp>
+      <p:sp>
+        <p:nvSpPr>
+          <p:cNvPr id="3" name="Rectangle 2"/>
+          <p:cNvSpPr/>
+          <p:nvPr/>
+        </p:nvSpPr>
+        <p:spPr>
+          <a:xfrm>
+            <a:off x="530352" y="1005840"/>
+            <a:ext cx="2926080" cy="38100"/>
+          </a:xfrm>
+          <a:prstGeom prst="rect">
+            <a:avLst/>
+          </a:prstGeom>
+          <a:solidFill>
+            <a:srgbClr val="2E6DB4"/>
+          </a:solidFill>
+          <a:ln>
+            <a:noFill/>
+          </a:ln>
+        </p:spPr>
+        <p:style>
+          <a:lnRef idx="1">
+            <a:schemeClr val="accent1"/>
+          </a:lnRef>
+          <a:fillRef idx="3">
+            <a:schemeClr val="accent1"/>
+          </a:fillRef>
+          <a:effectRef idx="2">
+            <a:schemeClr val="accent1"/>
+          </a:effectRef>
+          <a:fontRef idx="minor">
+            <a:schemeClr val="lt1"/>
+          </a:fontRef>
+        </p:style>
+        <p:txBody>
+          <a:bodyPr rtlCol="0" anchor="ctr"/>
+          <a:lstStyle/>
+          <a:p>
+            <a:pPr algn="ctr"/>
+          </a:p>
+        </p:txBody>
+      </p:sp>
+      <p:sp>
+        <p:nvSpPr>
+          <p:cNvPr id="4" name="TextBox 3"/>
+          <p:cNvSpPr txBox="1"/>
+          <p:nvPr/>
+        </p:nvSpPr>
+        <p:spPr>
+          <a:xfrm>
+            <a:off x="640080" y="1280160"/>
+            <a:ext cx="10972800" cy="5029200"/>
+          </a:xfrm>
+          <a:prstGeom prst="rect">
+            <a:avLst/>
+          </a:prstGeom>
+          <a:noFill/>
+        </p:spPr>
+        <p:txBody>
+          <a:bodyPr wrap="square">
+            <a:spAutoFit/>
+          </a:bodyPr>
+          <a:lstStyle/>
+          <a:p>
+            <a:pPr>
+              <a:spcAft>
+                <a:spcPts val="700"/>
+              </a:spcAft>
+            </a:pPr>
+            <a:r>
+              <a:rPr sz="1700" b="1">
+                <a:solidFill>
+                  <a:srgbClr val="1B2A4A"/>
+                </a:solidFill>
+              </a:rPr>
               <a:t>ThunderAgent = program-aware KV 캐시 스케줄링 (router tr) vs naive 프록시 (default)</a:t>
             </a:r>
           </a:p>
@@ -6938,7 +8471,7 @@
                   <a:srgbClr val="4A4A4A"/>
                 </a:solidFill>
               </a:rPr>
-              <a:t>✅ 완료: homo-homo (합성 × 2×4090)  —  기존 §7·§9·§10</a:t>
+              <a:t>✅ homo-homo (합성 × 2×4090) — 기존 §7·§9·§10</a:t>
             </a:r>
           </a:p>
           <a:p>
@@ -6953,7 +8486,7 @@
                   <a:srgbClr val="1E7A3C"/>
                 </a:solidFill>
               </a:rPr>
-              <a:t>★ 이번: D(실제 TraceLab × 2×4090) + F(합성 × 4090+5090 이종)</a:t>
+              <a:t>★ 이번: D(실TraceLab×2×4090) + F(합성×이종) + G(실TraceLab×이종) — 2×2 4칸 완성</a:t>
             </a:r>
           </a:p>
           <a:p>

</xml_diff>